<commit_message>
Rebuild Inflection Radar experience and publication sources
</commit_message>
<xml_diff>
--- a/assets/meeting-deck.pptx
+++ b/assets/meeting-deck.pptx
@@ -2,25 +2,25 @@
 <file path=ppt/presentation.xml><?xml version="1.0" encoding="utf-8"?>
 <p:presentation xmlns:p="http://schemas.openxmlformats.org/presentationml/2006/main">
   <p:sldMasterIdLst>
-    <p:sldMasterId xmlns:r="http://schemas.openxmlformats.org/officeDocument/2006/relationships" id="2147483648" r:id="Rf1bcee2acc404dc3"/>
+    <p:sldMasterId xmlns:r="http://schemas.openxmlformats.org/officeDocument/2006/relationships" id="2147483648" r:id="Raf03a0c4ee9147d4"/>
   </p:sldMasterIdLst>
   <p:notesMasterIdLst>
-    <p:notesMasterId xmlns:r="http://schemas.openxmlformats.org/officeDocument/2006/relationships" r:id="Rbe9d10af27c24039"/>
+    <p:notesMasterId xmlns:r="http://schemas.openxmlformats.org/officeDocument/2006/relationships" r:id="R982fdf3538ec40b1"/>
   </p:notesMasterIdLst>
   <p:sldIdLst>
-    <p:sldId xmlns:r="http://schemas.openxmlformats.org/officeDocument/2006/relationships" id="256" r:id="R8ba034ed6a1a4ec9"/>
-    <p:sldId xmlns:r="http://schemas.openxmlformats.org/officeDocument/2006/relationships" id="257" r:id="R63214e2ad7bb49fe"/>
-    <p:sldId xmlns:r="http://schemas.openxmlformats.org/officeDocument/2006/relationships" id="258" r:id="R5731a15bbb8a41b3"/>
-    <p:sldId xmlns:r="http://schemas.openxmlformats.org/officeDocument/2006/relationships" id="259" r:id="R85dc2a4454fd4888"/>
-    <p:sldId xmlns:r="http://schemas.openxmlformats.org/officeDocument/2006/relationships" id="260" r:id="R705b4f6caef045cc"/>
-    <p:sldId xmlns:r="http://schemas.openxmlformats.org/officeDocument/2006/relationships" id="261" r:id="R53624f69f6d840f0"/>
-    <p:sldId xmlns:r="http://schemas.openxmlformats.org/officeDocument/2006/relationships" id="262" r:id="Rf3603be7d3954221"/>
-    <p:sldId xmlns:r="http://schemas.openxmlformats.org/officeDocument/2006/relationships" id="263" r:id="R676794b6a49f4265"/>
-    <p:sldId xmlns:r="http://schemas.openxmlformats.org/officeDocument/2006/relationships" id="264" r:id="R6faa9b4ddf27422f"/>
-    <p:sldId xmlns:r="http://schemas.openxmlformats.org/officeDocument/2006/relationships" id="265" r:id="Rb79289dbafde49ad"/>
-    <p:sldId xmlns:r="http://schemas.openxmlformats.org/officeDocument/2006/relationships" id="266" r:id="R99614700650f43e8"/>
-    <p:sldId xmlns:r="http://schemas.openxmlformats.org/officeDocument/2006/relationships" id="267" r:id="R02fe0d95aaf741c8"/>
-    <p:sldId xmlns:r="http://schemas.openxmlformats.org/officeDocument/2006/relationships" id="268" r:id="Rbfbfc58bb4ba4949"/>
+    <p:sldId xmlns:r="http://schemas.openxmlformats.org/officeDocument/2006/relationships" id="256" r:id="Ra7da96a4e6a24480"/>
+    <p:sldId xmlns:r="http://schemas.openxmlformats.org/officeDocument/2006/relationships" id="257" r:id="R0d3da4dd04604d40"/>
+    <p:sldId xmlns:r="http://schemas.openxmlformats.org/officeDocument/2006/relationships" id="258" r:id="R9a551b0645784552"/>
+    <p:sldId xmlns:r="http://schemas.openxmlformats.org/officeDocument/2006/relationships" id="259" r:id="Rd4406d6ea9d149ea"/>
+    <p:sldId xmlns:r="http://schemas.openxmlformats.org/officeDocument/2006/relationships" id="260" r:id="Ra9147f253f714fd4"/>
+    <p:sldId xmlns:r="http://schemas.openxmlformats.org/officeDocument/2006/relationships" id="261" r:id="R6e4e674868c44e7f"/>
+    <p:sldId xmlns:r="http://schemas.openxmlformats.org/officeDocument/2006/relationships" id="262" r:id="R5a0bda7b1ec641a8"/>
+    <p:sldId xmlns:r="http://schemas.openxmlformats.org/officeDocument/2006/relationships" id="263" r:id="Ra15ac3f3206048c9"/>
+    <p:sldId xmlns:r="http://schemas.openxmlformats.org/officeDocument/2006/relationships" id="264" r:id="R7d9a2bc609174518"/>
+    <p:sldId xmlns:r="http://schemas.openxmlformats.org/officeDocument/2006/relationships" id="265" r:id="R5a26678756674ef8"/>
+    <p:sldId xmlns:r="http://schemas.openxmlformats.org/officeDocument/2006/relationships" id="266" r:id="Re891cf5eb7d54012"/>
+    <p:sldId xmlns:r="http://schemas.openxmlformats.org/officeDocument/2006/relationships" id="267" r:id="R32d153631d554b5d"/>
+    <p:sldId xmlns:r="http://schemas.openxmlformats.org/officeDocument/2006/relationships" id="268" r:id="R84f7fc3a0e75409b"/>
   </p:sldIdLst>
   <p:sldSz cx="12192000" cy="6858000"/>
   <p:notesSz cx="6858000" cy="9144000"/>
@@ -1652,7 +1652,7 @@
   </p:cSld>
   <p:clrMap bg1="lt1" tx1="dk1" bg2="lt2" tx2="dk2" accent1="accent1" accent2="accent2" accent3="accent3" accent4="accent4" accent5="accent5" accent6="accent6" hlink="hlink" folHlink="folHlink"/>
   <p:sldLayoutIdLst>
-    <p:sldLayoutId xmlns:r="http://schemas.openxmlformats.org/officeDocument/2006/relationships" id="2147483649" r:id="R75da06ab02844e7b"/>
+    <p:sldLayoutId xmlns:r="http://schemas.openxmlformats.org/officeDocument/2006/relationships" id="2147483649" r:id="R16f8818181ee44e6"/>
   </p:sldLayoutIdLst>
   <p:txStyles>
     <p:titleStyle>
@@ -2203,7 +2203,7 @@
           <p:cNvPr id="1" name="">
             <a:extLst xmlns:a="http://schemas.openxmlformats.org/drawingml/2006/main">
               <a:ext uri="{FF2B5EF4-FFF2-40B4-BE49-F238E27FC236}">
-                <a16:creationId xmlns:a16="http://schemas.microsoft.com/office/drawing/2014/main" id="{6ADED6B1-D9E1-47CD-B79D-95620D0E3C74}"/>
+                <a16:creationId xmlns:a16="http://schemas.microsoft.com/office/drawing/2014/main" id="{09461132-DAD1-4B36-989A-EA77458EC282}"/>
               </a:ext>
             </a:extLst>
           </p:cNvPr>
@@ -2234,7 +2234,7 @@
           <p:cNvPr id="2" name="">
             <a:extLst xmlns:a="http://schemas.openxmlformats.org/drawingml/2006/main">
               <a:ext uri="{FF2B5EF4-FFF2-40B4-BE49-F238E27FC236}">
-                <a16:creationId xmlns:a16="http://schemas.microsoft.com/office/drawing/2014/main" id="{4319AC4D-6F27-4DE6-B9D5-A9DB54FEFE53}"/>
+                <a16:creationId xmlns:a16="http://schemas.microsoft.com/office/drawing/2014/main" id="{08896217-B429-46C1-9463-609DA93112DA}"/>
               </a:ext>
             </a:extLst>
           </p:cNvPr>
@@ -2284,7 +2284,7 @@
           <p:cNvPr id="3" name="">
             <a:extLst xmlns:a="http://schemas.openxmlformats.org/drawingml/2006/main">
               <a:ext uri="{FF2B5EF4-FFF2-40B4-BE49-F238E27FC236}">
-                <a16:creationId xmlns:a16="http://schemas.microsoft.com/office/drawing/2014/main" id="{A38A3C53-1B96-4F66-B25A-28E05083C167}"/>
+                <a16:creationId xmlns:a16="http://schemas.microsoft.com/office/drawing/2014/main" id="{62D21B1D-ACF7-4445-A4EB-2D069A66D256}"/>
               </a:ext>
             </a:extLst>
           </p:cNvPr>
@@ -2351,7 +2351,7 @@
           <p:cNvPr id="4" name="">
             <a:extLst xmlns:a="http://schemas.openxmlformats.org/drawingml/2006/main">
               <a:ext uri="{FF2B5EF4-FFF2-40B4-BE49-F238E27FC236}">
-                <a16:creationId xmlns:a16="http://schemas.microsoft.com/office/drawing/2014/main" id="{9F475319-1506-4CFF-9A8D-D5BE10CEE12F}"/>
+                <a16:creationId xmlns:a16="http://schemas.microsoft.com/office/drawing/2014/main" id="{217E98CA-11CA-49D4-A0B5-BD5D28322B18}"/>
               </a:ext>
             </a:extLst>
           </p:cNvPr>
@@ -2382,7 +2382,7 @@
           <p:cNvPr id="5" name="">
             <a:extLst xmlns:a="http://schemas.openxmlformats.org/drawingml/2006/main">
               <a:ext uri="{FF2B5EF4-FFF2-40B4-BE49-F238E27FC236}">
-                <a16:creationId xmlns:a16="http://schemas.microsoft.com/office/drawing/2014/main" id="{466C8688-F901-49EB-A86D-16B063643C1E}"/>
+                <a16:creationId xmlns:a16="http://schemas.microsoft.com/office/drawing/2014/main" id="{9EF9388B-CDE0-4236-AE78-5D556760AB44}"/>
               </a:ext>
             </a:extLst>
           </p:cNvPr>
@@ -2432,7 +2432,7 @@
           <p:cNvPr id="6" name="">
             <a:extLst xmlns:a="http://schemas.openxmlformats.org/drawingml/2006/main">
               <a:ext uri="{FF2B5EF4-FFF2-40B4-BE49-F238E27FC236}">
-                <a16:creationId xmlns:a16="http://schemas.microsoft.com/office/drawing/2014/main" id="{5CAD5641-1086-431D-A7A1-36440E22EB8F}"/>
+                <a16:creationId xmlns:a16="http://schemas.microsoft.com/office/drawing/2014/main" id="{9653DFB1-42CF-4629-A5C2-5F1B13319B0E}"/>
               </a:ext>
             </a:extLst>
           </p:cNvPr>
@@ -2465,7 +2465,7 @@
           <p:cNvPr id="7" name="">
             <a:extLst xmlns:a="http://schemas.openxmlformats.org/drawingml/2006/main">
               <a:ext uri="{FF2B5EF4-FFF2-40B4-BE49-F238E27FC236}">
-                <a16:creationId xmlns:a16="http://schemas.microsoft.com/office/drawing/2014/main" id="{E94962B5-856D-444F-B170-E1DDCB3BFCC2}"/>
+                <a16:creationId xmlns:a16="http://schemas.microsoft.com/office/drawing/2014/main" id="{C4FC061C-2B0B-411B-BB1B-C66C3C16D84A}"/>
               </a:ext>
             </a:extLst>
           </p:cNvPr>
@@ -2515,7 +2515,7 @@
           <p:cNvPr id="8" name="">
             <a:extLst xmlns:a="http://schemas.openxmlformats.org/drawingml/2006/main">
               <a:ext uri="{FF2B5EF4-FFF2-40B4-BE49-F238E27FC236}">
-                <a16:creationId xmlns:a16="http://schemas.microsoft.com/office/drawing/2014/main" id="{980E40DA-7E33-4E4C-9834-F226B895A3F4}"/>
+                <a16:creationId xmlns:a16="http://schemas.microsoft.com/office/drawing/2014/main" id="{DF58CC69-62FD-4DD3-8FBF-78338945BA50}"/>
               </a:ext>
             </a:extLst>
           </p:cNvPr>
@@ -2565,7 +2565,7 @@
           <p:cNvPr id="9" name="">
             <a:extLst xmlns:a="http://schemas.openxmlformats.org/drawingml/2006/main">
               <a:ext uri="{FF2B5EF4-FFF2-40B4-BE49-F238E27FC236}">
-                <a16:creationId xmlns:a16="http://schemas.microsoft.com/office/drawing/2014/main" id="{5B235E70-013F-43E6-98FA-509B5313A106}"/>
+                <a16:creationId xmlns:a16="http://schemas.microsoft.com/office/drawing/2014/main" id="{F1320DEE-9C09-4B1F-822B-2198DC2FCB42}"/>
               </a:ext>
             </a:extLst>
           </p:cNvPr>
@@ -2632,7 +2632,7 @@
           <p:cNvPr id="10" name="">
             <a:extLst xmlns:a="http://schemas.openxmlformats.org/drawingml/2006/main">
               <a:ext uri="{FF2B5EF4-FFF2-40B4-BE49-F238E27FC236}">
-                <a16:creationId xmlns:a16="http://schemas.microsoft.com/office/drawing/2014/main" id="{5ACF00DC-25C8-40C1-BC87-EEF7F54206B2}"/>
+                <a16:creationId xmlns:a16="http://schemas.microsoft.com/office/drawing/2014/main" id="{442D7585-C855-4875-8DFC-A43D45045DB4}"/>
               </a:ext>
             </a:extLst>
           </p:cNvPr>
@@ -2697,7 +2697,7 @@
     </p:spTree>
     <p:extLst>
       <p:ext uri="{BB962C8B-B14F-4D97-AF65-F5344CB8AC3E}">
-        <p14:creationId xmlns:p14="http://schemas.microsoft.com/office/powerpoint/2010/main" val="1761775190"/>
+        <p14:creationId xmlns:p14="http://schemas.microsoft.com/office/powerpoint/2010/main" val="1833472429"/>
       </p:ext>
     </p:extLst>
   </p:cSld>
@@ -2728,7 +2728,7 @@
           <p:cNvPr id="1" name="">
             <a:extLst xmlns:a="http://schemas.openxmlformats.org/drawingml/2006/main">
               <a:ext uri="{FF2B5EF4-FFF2-40B4-BE49-F238E27FC236}">
-                <a16:creationId xmlns:a16="http://schemas.microsoft.com/office/drawing/2014/main" id="{5AD5510F-ECFC-4070-8EEC-141D35885970}"/>
+                <a16:creationId xmlns:a16="http://schemas.microsoft.com/office/drawing/2014/main" id="{562B90D3-F235-4B04-88AE-91A9FC307350}"/>
               </a:ext>
             </a:extLst>
           </p:cNvPr>
@@ -2759,7 +2759,7 @@
           <p:cNvPr id="2" name="">
             <a:extLst xmlns:a="http://schemas.openxmlformats.org/drawingml/2006/main">
               <a:ext uri="{FF2B5EF4-FFF2-40B4-BE49-F238E27FC236}">
-                <a16:creationId xmlns:a16="http://schemas.microsoft.com/office/drawing/2014/main" id="{8DE84D21-B18C-4EF0-881B-C553CD5FF90D}"/>
+                <a16:creationId xmlns:a16="http://schemas.microsoft.com/office/drawing/2014/main" id="{2F98190D-E44D-4B17-B5F3-87D39E71A63A}"/>
               </a:ext>
             </a:extLst>
           </p:cNvPr>
@@ -2809,7 +2809,7 @@
           <p:cNvPr id="3" name="">
             <a:extLst xmlns:a="http://schemas.openxmlformats.org/drawingml/2006/main">
               <a:ext uri="{FF2B5EF4-FFF2-40B4-BE49-F238E27FC236}">
-                <a16:creationId xmlns:a16="http://schemas.microsoft.com/office/drawing/2014/main" id="{FE0883BF-D45E-4178-8AE4-4AA50693D45C}"/>
+                <a16:creationId xmlns:a16="http://schemas.microsoft.com/office/drawing/2014/main" id="{EB477D7B-4B3B-4A69-90EE-7A2BC7C3A49E}"/>
               </a:ext>
             </a:extLst>
           </p:cNvPr>
@@ -2859,7 +2859,7 @@
           <p:cNvPr id="4" name="">
             <a:extLst xmlns:a="http://schemas.openxmlformats.org/drawingml/2006/main">
               <a:ext uri="{FF2B5EF4-FFF2-40B4-BE49-F238E27FC236}">
-                <a16:creationId xmlns:a16="http://schemas.microsoft.com/office/drawing/2014/main" id="{359EBDB3-BCF9-47FD-BA3B-C0E4F2267804}"/>
+                <a16:creationId xmlns:a16="http://schemas.microsoft.com/office/drawing/2014/main" id="{82E87411-58FF-4702-86A1-A84BB712D64D}"/>
               </a:ext>
             </a:extLst>
           </p:cNvPr>
@@ -2890,7 +2890,7 @@
           <p:cNvPr id="5" name="">
             <a:extLst xmlns:a="http://schemas.openxmlformats.org/drawingml/2006/main">
               <a:ext uri="{FF2B5EF4-FFF2-40B4-BE49-F238E27FC236}">
-                <a16:creationId xmlns:a16="http://schemas.microsoft.com/office/drawing/2014/main" id="{95646A2A-E50D-46A8-9A86-D1B37F29611E}"/>
+                <a16:creationId xmlns:a16="http://schemas.microsoft.com/office/drawing/2014/main" id="{ACB6C5F5-FE6B-4216-B5A2-3477DCDE30E1}"/>
               </a:ext>
             </a:extLst>
           </p:cNvPr>
@@ -2940,7 +2940,7 @@
           <p:cNvPr id="6" name="">
             <a:extLst xmlns:a="http://schemas.openxmlformats.org/drawingml/2006/main">
               <a:ext uri="{FF2B5EF4-FFF2-40B4-BE49-F238E27FC236}">
-                <a16:creationId xmlns:a16="http://schemas.microsoft.com/office/drawing/2014/main" id="{5D3C85BD-6F0A-4B7C-B95E-B6629FF5532A}"/>
+                <a16:creationId xmlns:a16="http://schemas.microsoft.com/office/drawing/2014/main" id="{C8948267-7860-4B17-A59E-00F3C9D8BE29}"/>
               </a:ext>
             </a:extLst>
           </p:cNvPr>
@@ -2990,7 +2990,7 @@
           <p:cNvPr id="7" name="">
             <a:extLst xmlns:a="http://schemas.openxmlformats.org/drawingml/2006/main">
               <a:ext uri="{FF2B5EF4-FFF2-40B4-BE49-F238E27FC236}">
-                <a16:creationId xmlns:a16="http://schemas.microsoft.com/office/drawing/2014/main" id="{3D3D3ACF-010A-41E0-8DE8-2FA5D47EB11D}"/>
+                <a16:creationId xmlns:a16="http://schemas.microsoft.com/office/drawing/2014/main" id="{152ABCEC-3241-4DEC-AD57-E7FB90B328E3}"/>
               </a:ext>
             </a:extLst>
           </p:cNvPr>
@@ -3040,7 +3040,7 @@
           <p:cNvPr id="8" name="">
             <a:extLst xmlns:a="http://schemas.openxmlformats.org/drawingml/2006/main">
               <a:ext uri="{FF2B5EF4-FFF2-40B4-BE49-F238E27FC236}">
-                <a16:creationId xmlns:a16="http://schemas.microsoft.com/office/drawing/2014/main" id="{5CD2AA52-DBE2-4913-8947-4CAF7B0F91EA}"/>
+                <a16:creationId xmlns:a16="http://schemas.microsoft.com/office/drawing/2014/main" id="{0D868608-0B57-41D2-A913-E716FB04CA18}"/>
               </a:ext>
             </a:extLst>
           </p:cNvPr>
@@ -3090,7 +3090,7 @@
           <p:cNvPr id="9" name="">
             <a:extLst xmlns:a="http://schemas.openxmlformats.org/drawingml/2006/main">
               <a:ext uri="{FF2B5EF4-FFF2-40B4-BE49-F238E27FC236}">
-                <a16:creationId xmlns:a16="http://schemas.microsoft.com/office/drawing/2014/main" id="{6F5957D4-561C-456E-B9CD-B46A1E0B6E0E}"/>
+                <a16:creationId xmlns:a16="http://schemas.microsoft.com/office/drawing/2014/main" id="{C4018410-A8CF-4EE4-A705-99519F8EFBEB}"/>
               </a:ext>
             </a:extLst>
           </p:cNvPr>
@@ -3121,7 +3121,7 @@
           <p:cNvPr id="10" name="">
             <a:extLst xmlns:a="http://schemas.openxmlformats.org/drawingml/2006/main">
               <a:ext uri="{FF2B5EF4-FFF2-40B4-BE49-F238E27FC236}">
-                <a16:creationId xmlns:a16="http://schemas.microsoft.com/office/drawing/2014/main" id="{3F3A6E25-E1E1-477E-84C8-26D8FE2B285B}"/>
+                <a16:creationId xmlns:a16="http://schemas.microsoft.com/office/drawing/2014/main" id="{3A9E4B1C-91A9-4D14-9CB0-39B2A2960312}"/>
               </a:ext>
             </a:extLst>
           </p:cNvPr>
@@ -3154,7 +3154,7 @@
           <p:cNvPr id="11" name="">
             <a:extLst xmlns:a="http://schemas.openxmlformats.org/drawingml/2006/main">
               <a:ext uri="{FF2B5EF4-FFF2-40B4-BE49-F238E27FC236}">
-                <a16:creationId xmlns:a16="http://schemas.microsoft.com/office/drawing/2014/main" id="{7DD148FF-7842-435D-97B9-7698D9F8F405}"/>
+                <a16:creationId xmlns:a16="http://schemas.microsoft.com/office/drawing/2014/main" id="{AD966440-C16B-4239-80D4-5890296A614E}"/>
               </a:ext>
             </a:extLst>
           </p:cNvPr>
@@ -3204,7 +3204,7 @@
           <p:cNvPr id="12" name="">
             <a:extLst xmlns:a="http://schemas.openxmlformats.org/drawingml/2006/main">
               <a:ext uri="{FF2B5EF4-FFF2-40B4-BE49-F238E27FC236}">
-                <a16:creationId xmlns:a16="http://schemas.microsoft.com/office/drawing/2014/main" id="{96B3B9B6-2EF3-4B23-AE2F-24C47082FD57}"/>
+                <a16:creationId xmlns:a16="http://schemas.microsoft.com/office/drawing/2014/main" id="{50D1CD7A-D4F7-4A34-9A0F-45C81C0F05D3}"/>
               </a:ext>
             </a:extLst>
           </p:cNvPr>
@@ -3254,7 +3254,7 @@
           <p:cNvPr id="13" name="">
             <a:extLst xmlns:a="http://schemas.openxmlformats.org/drawingml/2006/main">
               <a:ext uri="{FF2B5EF4-FFF2-40B4-BE49-F238E27FC236}">
-                <a16:creationId xmlns:a16="http://schemas.microsoft.com/office/drawing/2014/main" id="{28283E05-ECE7-4D7D-AEAC-E45903E63390}"/>
+                <a16:creationId xmlns:a16="http://schemas.microsoft.com/office/drawing/2014/main" id="{2EDD8412-FF2C-4C61-97B8-D3E9FE6AF3B1}"/>
               </a:ext>
             </a:extLst>
           </p:cNvPr>
@@ -3285,7 +3285,7 @@
           <p:cNvPr id="14" name="">
             <a:extLst xmlns:a="http://schemas.openxmlformats.org/drawingml/2006/main">
               <a:ext uri="{FF2B5EF4-FFF2-40B4-BE49-F238E27FC236}">
-                <a16:creationId xmlns:a16="http://schemas.microsoft.com/office/drawing/2014/main" id="{FA0E8883-E680-4D05-86F7-6B19C77B9FD3}"/>
+                <a16:creationId xmlns:a16="http://schemas.microsoft.com/office/drawing/2014/main" id="{FBA91D7B-80D8-4807-8A04-16495D17F078}"/>
               </a:ext>
             </a:extLst>
           </p:cNvPr>
@@ -3318,7 +3318,7 @@
           <p:cNvPr id="15" name="">
             <a:extLst xmlns:a="http://schemas.openxmlformats.org/drawingml/2006/main">
               <a:ext uri="{FF2B5EF4-FFF2-40B4-BE49-F238E27FC236}">
-                <a16:creationId xmlns:a16="http://schemas.microsoft.com/office/drawing/2014/main" id="{D368BF06-5F96-41FA-BDAA-D772711173E6}"/>
+                <a16:creationId xmlns:a16="http://schemas.microsoft.com/office/drawing/2014/main" id="{96FFFC83-6306-4353-8D81-34FE56412F44}"/>
               </a:ext>
             </a:extLst>
           </p:cNvPr>
@@ -3368,7 +3368,7 @@
           <p:cNvPr id="16" name="">
             <a:extLst xmlns:a="http://schemas.openxmlformats.org/drawingml/2006/main">
               <a:ext uri="{FF2B5EF4-FFF2-40B4-BE49-F238E27FC236}">
-                <a16:creationId xmlns:a16="http://schemas.microsoft.com/office/drawing/2014/main" id="{0627B3B0-2490-47B0-BE0F-752867D0439A}"/>
+                <a16:creationId xmlns:a16="http://schemas.microsoft.com/office/drawing/2014/main" id="{48ED780E-20B2-4A57-8DD6-3C992C0D8756}"/>
               </a:ext>
             </a:extLst>
           </p:cNvPr>
@@ -3418,7 +3418,7 @@
           <p:cNvPr id="17" name="">
             <a:extLst xmlns:a="http://schemas.openxmlformats.org/drawingml/2006/main">
               <a:ext uri="{FF2B5EF4-FFF2-40B4-BE49-F238E27FC236}">
-                <a16:creationId xmlns:a16="http://schemas.microsoft.com/office/drawing/2014/main" id="{DA7284E7-075E-4701-B989-8E66BEF6DE59}"/>
+                <a16:creationId xmlns:a16="http://schemas.microsoft.com/office/drawing/2014/main" id="{E4F47925-D295-461C-9A8E-9BC7B4CD2CD3}"/>
               </a:ext>
             </a:extLst>
           </p:cNvPr>
@@ -3449,7 +3449,7 @@
           <p:cNvPr id="18" name="">
             <a:extLst xmlns:a="http://schemas.openxmlformats.org/drawingml/2006/main">
               <a:ext uri="{FF2B5EF4-FFF2-40B4-BE49-F238E27FC236}">
-                <a16:creationId xmlns:a16="http://schemas.microsoft.com/office/drawing/2014/main" id="{7F332288-FDE7-453E-856F-C9DF95C4B33B}"/>
+                <a16:creationId xmlns:a16="http://schemas.microsoft.com/office/drawing/2014/main" id="{1B35A16B-A0F8-4411-B6F3-A5FAEC6F3611}"/>
               </a:ext>
             </a:extLst>
           </p:cNvPr>
@@ -3482,7 +3482,7 @@
           <p:cNvPr id="19" name="">
             <a:extLst xmlns:a="http://schemas.openxmlformats.org/drawingml/2006/main">
               <a:ext uri="{FF2B5EF4-FFF2-40B4-BE49-F238E27FC236}">
-                <a16:creationId xmlns:a16="http://schemas.microsoft.com/office/drawing/2014/main" id="{254576F5-D25E-4335-8C63-B165C9278053}"/>
+                <a16:creationId xmlns:a16="http://schemas.microsoft.com/office/drawing/2014/main" id="{11000245-977C-4726-A988-996C3FA87038}"/>
               </a:ext>
             </a:extLst>
           </p:cNvPr>
@@ -3532,7 +3532,7 @@
           <p:cNvPr id="20" name="">
             <a:extLst xmlns:a="http://schemas.openxmlformats.org/drawingml/2006/main">
               <a:ext uri="{FF2B5EF4-FFF2-40B4-BE49-F238E27FC236}">
-                <a16:creationId xmlns:a16="http://schemas.microsoft.com/office/drawing/2014/main" id="{47CF64D1-7B88-4123-BAFD-7E72F1E6F951}"/>
+                <a16:creationId xmlns:a16="http://schemas.microsoft.com/office/drawing/2014/main" id="{EF2C6356-F739-40F4-B7EA-857B5323EEAC}"/>
               </a:ext>
             </a:extLst>
           </p:cNvPr>
@@ -3582,7 +3582,7 @@
           <p:cNvPr id="21" name="">
             <a:extLst xmlns:a="http://schemas.openxmlformats.org/drawingml/2006/main">
               <a:ext uri="{FF2B5EF4-FFF2-40B4-BE49-F238E27FC236}">
-                <a16:creationId xmlns:a16="http://schemas.microsoft.com/office/drawing/2014/main" id="{65462727-D57F-4E8F-B3D3-415A1C174246}"/>
+                <a16:creationId xmlns:a16="http://schemas.microsoft.com/office/drawing/2014/main" id="{4E862A11-393F-4EFF-8C71-49B9795742E6}"/>
               </a:ext>
             </a:extLst>
           </p:cNvPr>
@@ -3613,7 +3613,7 @@
           <p:cNvPr id="22" name="">
             <a:extLst xmlns:a="http://schemas.openxmlformats.org/drawingml/2006/main">
               <a:ext uri="{FF2B5EF4-FFF2-40B4-BE49-F238E27FC236}">
-                <a16:creationId xmlns:a16="http://schemas.microsoft.com/office/drawing/2014/main" id="{D18CE28E-553B-41F8-B0AD-E26214E2B853}"/>
+                <a16:creationId xmlns:a16="http://schemas.microsoft.com/office/drawing/2014/main" id="{9DBC1946-B35C-4798-A1B4-E3E6D548D66A}"/>
               </a:ext>
             </a:extLst>
           </p:cNvPr>
@@ -3646,7 +3646,7 @@
           <p:cNvPr id="23" name="">
             <a:extLst xmlns:a="http://schemas.openxmlformats.org/drawingml/2006/main">
               <a:ext uri="{FF2B5EF4-FFF2-40B4-BE49-F238E27FC236}">
-                <a16:creationId xmlns:a16="http://schemas.microsoft.com/office/drawing/2014/main" id="{786F8372-C3FB-40DF-8F1A-2E08032392FE}"/>
+                <a16:creationId xmlns:a16="http://schemas.microsoft.com/office/drawing/2014/main" id="{B691DC48-E4F5-495B-90B0-2482E84BECCB}"/>
               </a:ext>
             </a:extLst>
           </p:cNvPr>
@@ -3696,7 +3696,7 @@
           <p:cNvPr id="24" name="">
             <a:extLst xmlns:a="http://schemas.openxmlformats.org/drawingml/2006/main">
               <a:ext uri="{FF2B5EF4-FFF2-40B4-BE49-F238E27FC236}">
-                <a16:creationId xmlns:a16="http://schemas.microsoft.com/office/drawing/2014/main" id="{536AC1C3-27AC-4722-B507-3736274250B6}"/>
+                <a16:creationId xmlns:a16="http://schemas.microsoft.com/office/drawing/2014/main" id="{84C0020B-CE5E-4865-B317-DA9369AEBA5C}"/>
               </a:ext>
             </a:extLst>
           </p:cNvPr>
@@ -3746,7 +3746,7 @@
           <p:cNvPr id="25" name="">
             <a:extLst xmlns:a="http://schemas.openxmlformats.org/drawingml/2006/main">
               <a:ext uri="{FF2B5EF4-FFF2-40B4-BE49-F238E27FC236}">
-                <a16:creationId xmlns:a16="http://schemas.microsoft.com/office/drawing/2014/main" id="{078C1D88-243C-431C-9D20-2E4C3415BF36}"/>
+                <a16:creationId xmlns:a16="http://schemas.microsoft.com/office/drawing/2014/main" id="{BC5D93F4-55D1-4ABC-AC3F-E04824BCFE97}"/>
               </a:ext>
             </a:extLst>
           </p:cNvPr>
@@ -3777,7 +3777,7 @@
           <p:cNvPr id="26" name="">
             <a:extLst xmlns:a="http://schemas.openxmlformats.org/drawingml/2006/main">
               <a:ext uri="{FF2B5EF4-FFF2-40B4-BE49-F238E27FC236}">
-                <a16:creationId xmlns:a16="http://schemas.microsoft.com/office/drawing/2014/main" id="{00C8F528-FC73-4B34-B895-139885CA8B38}"/>
+                <a16:creationId xmlns:a16="http://schemas.microsoft.com/office/drawing/2014/main" id="{7D6E0B85-DECD-4D05-B34D-34C9EFC49AF9}"/>
               </a:ext>
             </a:extLst>
           </p:cNvPr>
@@ -3810,7 +3810,7 @@
           <p:cNvPr id="27" name="">
             <a:extLst xmlns:a="http://schemas.openxmlformats.org/drawingml/2006/main">
               <a:ext uri="{FF2B5EF4-FFF2-40B4-BE49-F238E27FC236}">
-                <a16:creationId xmlns:a16="http://schemas.microsoft.com/office/drawing/2014/main" id="{C1FCAF2A-6383-4BBB-B2D8-00BC254185C4}"/>
+                <a16:creationId xmlns:a16="http://schemas.microsoft.com/office/drawing/2014/main" id="{9E42675A-8626-4C63-AC62-E3BC1004A14F}"/>
               </a:ext>
             </a:extLst>
           </p:cNvPr>
@@ -3860,7 +3860,7 @@
           <p:cNvPr id="28" name="">
             <a:extLst xmlns:a="http://schemas.openxmlformats.org/drawingml/2006/main">
               <a:ext uri="{FF2B5EF4-FFF2-40B4-BE49-F238E27FC236}">
-                <a16:creationId xmlns:a16="http://schemas.microsoft.com/office/drawing/2014/main" id="{13297977-9B0E-4B8D-9E95-5CBDD46F5FD3}"/>
+                <a16:creationId xmlns:a16="http://schemas.microsoft.com/office/drawing/2014/main" id="{C7D9B091-BB95-475D-BCEE-7F0367611100}"/>
               </a:ext>
             </a:extLst>
           </p:cNvPr>
@@ -3910,7 +3910,7 @@
           <p:cNvPr id="29" name="">
             <a:extLst xmlns:a="http://schemas.openxmlformats.org/drawingml/2006/main">
               <a:ext uri="{FF2B5EF4-FFF2-40B4-BE49-F238E27FC236}">
-                <a16:creationId xmlns:a16="http://schemas.microsoft.com/office/drawing/2014/main" id="{AF0A71C9-5AD6-47F1-B00C-CC73D2377FAD}"/>
+                <a16:creationId xmlns:a16="http://schemas.microsoft.com/office/drawing/2014/main" id="{CC3E08C6-06A7-4A30-87A9-044083CB8CB1}"/>
               </a:ext>
             </a:extLst>
           </p:cNvPr>
@@ -3941,7 +3941,7 @@
           <p:cNvPr id="30" name="">
             <a:extLst xmlns:a="http://schemas.openxmlformats.org/drawingml/2006/main">
               <a:ext uri="{FF2B5EF4-FFF2-40B4-BE49-F238E27FC236}">
-                <a16:creationId xmlns:a16="http://schemas.microsoft.com/office/drawing/2014/main" id="{398D94E6-C18E-4888-98C2-837E7C72CFF1}"/>
+                <a16:creationId xmlns:a16="http://schemas.microsoft.com/office/drawing/2014/main" id="{F6B48AB5-DAD7-4410-B4B1-DFFEDB7557F0}"/>
               </a:ext>
             </a:extLst>
           </p:cNvPr>
@@ -3974,7 +3974,7 @@
           <p:cNvPr id="31" name="">
             <a:extLst xmlns:a="http://schemas.openxmlformats.org/drawingml/2006/main">
               <a:ext uri="{FF2B5EF4-FFF2-40B4-BE49-F238E27FC236}">
-                <a16:creationId xmlns:a16="http://schemas.microsoft.com/office/drawing/2014/main" id="{D887C46C-8F67-4611-A4CF-84F06E9E6B63}"/>
+                <a16:creationId xmlns:a16="http://schemas.microsoft.com/office/drawing/2014/main" id="{EB8682B1-97F0-49D2-91AC-321D78759353}"/>
               </a:ext>
             </a:extLst>
           </p:cNvPr>
@@ -4024,7 +4024,7 @@
           <p:cNvPr id="32" name="">
             <a:extLst xmlns:a="http://schemas.openxmlformats.org/drawingml/2006/main">
               <a:ext uri="{FF2B5EF4-FFF2-40B4-BE49-F238E27FC236}">
-                <a16:creationId xmlns:a16="http://schemas.microsoft.com/office/drawing/2014/main" id="{76EB7592-3552-48F8-9A68-8DDC6AF9F87C}"/>
+                <a16:creationId xmlns:a16="http://schemas.microsoft.com/office/drawing/2014/main" id="{9FB7841E-E026-4CA2-BD1F-73924BCD997E}"/>
               </a:ext>
             </a:extLst>
           </p:cNvPr>
@@ -4074,7 +4074,7 @@
           <p:cNvPr id="33" name="">
             <a:extLst xmlns:a="http://schemas.openxmlformats.org/drawingml/2006/main">
               <a:ext uri="{FF2B5EF4-FFF2-40B4-BE49-F238E27FC236}">
-                <a16:creationId xmlns:a16="http://schemas.microsoft.com/office/drawing/2014/main" id="{918857DC-6FC2-4EFA-AAE9-2E86D0CC57D5}"/>
+                <a16:creationId xmlns:a16="http://schemas.microsoft.com/office/drawing/2014/main" id="{635C0EF4-1B14-4EE4-B357-A99FB379AEBB}"/>
               </a:ext>
             </a:extLst>
           </p:cNvPr>
@@ -4105,7 +4105,7 @@
           <p:cNvPr id="34" name="">
             <a:extLst xmlns:a="http://schemas.openxmlformats.org/drawingml/2006/main">
               <a:ext uri="{FF2B5EF4-FFF2-40B4-BE49-F238E27FC236}">
-                <a16:creationId xmlns:a16="http://schemas.microsoft.com/office/drawing/2014/main" id="{AE35B642-BB34-4EDD-B6EA-5773B9ECC58C}"/>
+                <a16:creationId xmlns:a16="http://schemas.microsoft.com/office/drawing/2014/main" id="{803D6E1A-05D5-4212-9DDD-C1A026E38540}"/>
               </a:ext>
             </a:extLst>
           </p:cNvPr>
@@ -4138,7 +4138,7 @@
           <p:cNvPr id="35" name="">
             <a:extLst xmlns:a="http://schemas.openxmlformats.org/drawingml/2006/main">
               <a:ext uri="{FF2B5EF4-FFF2-40B4-BE49-F238E27FC236}">
-                <a16:creationId xmlns:a16="http://schemas.microsoft.com/office/drawing/2014/main" id="{86BA83C2-FDE2-4B12-97B9-D7D44C7FFC1C}"/>
+                <a16:creationId xmlns:a16="http://schemas.microsoft.com/office/drawing/2014/main" id="{E54AE015-2943-4940-8F54-ABF92E3E96EB}"/>
               </a:ext>
             </a:extLst>
           </p:cNvPr>
@@ -4188,7 +4188,7 @@
           <p:cNvPr id="36" name="">
             <a:extLst xmlns:a="http://schemas.openxmlformats.org/drawingml/2006/main">
               <a:ext uri="{FF2B5EF4-FFF2-40B4-BE49-F238E27FC236}">
-                <a16:creationId xmlns:a16="http://schemas.microsoft.com/office/drawing/2014/main" id="{1FF4C48C-CF58-4C4D-BF96-527FF969F9FD}"/>
+                <a16:creationId xmlns:a16="http://schemas.microsoft.com/office/drawing/2014/main" id="{52DFB720-3CE1-4D55-A217-AB7C0E6E6114}"/>
               </a:ext>
             </a:extLst>
           </p:cNvPr>
@@ -4238,7 +4238,7 @@
           <p:cNvPr id="37" name="">
             <a:extLst xmlns:a="http://schemas.openxmlformats.org/drawingml/2006/main">
               <a:ext uri="{FF2B5EF4-FFF2-40B4-BE49-F238E27FC236}">
-                <a16:creationId xmlns:a16="http://schemas.microsoft.com/office/drawing/2014/main" id="{0F3EBA89-CACF-424B-8B11-DB156FEAA7B8}"/>
+                <a16:creationId xmlns:a16="http://schemas.microsoft.com/office/drawing/2014/main" id="{0E99D563-7C50-46EF-A46D-999328C2C842}"/>
               </a:ext>
             </a:extLst>
           </p:cNvPr>
@@ -4269,7 +4269,7 @@
           <p:cNvPr id="38" name="">
             <a:extLst xmlns:a="http://schemas.openxmlformats.org/drawingml/2006/main">
               <a:ext uri="{FF2B5EF4-FFF2-40B4-BE49-F238E27FC236}">
-                <a16:creationId xmlns:a16="http://schemas.microsoft.com/office/drawing/2014/main" id="{60237AC2-54E0-4F84-AB63-92820B16F968}"/>
+                <a16:creationId xmlns:a16="http://schemas.microsoft.com/office/drawing/2014/main" id="{6E565BBC-DDFB-4706-9E8D-908C12B0E3F6}"/>
               </a:ext>
             </a:extLst>
           </p:cNvPr>
@@ -4302,7 +4302,7 @@
           <p:cNvPr id="39" name="">
             <a:extLst xmlns:a="http://schemas.openxmlformats.org/drawingml/2006/main">
               <a:ext uri="{FF2B5EF4-FFF2-40B4-BE49-F238E27FC236}">
-                <a16:creationId xmlns:a16="http://schemas.microsoft.com/office/drawing/2014/main" id="{89227BC3-4B62-427D-AC01-EED6451D1937}"/>
+                <a16:creationId xmlns:a16="http://schemas.microsoft.com/office/drawing/2014/main" id="{53A5F209-6C64-403E-99AA-45CDFE96C93B}"/>
               </a:ext>
             </a:extLst>
           </p:cNvPr>
@@ -4352,7 +4352,7 @@
           <p:cNvPr id="40" name="">
             <a:extLst xmlns:a="http://schemas.openxmlformats.org/drawingml/2006/main">
               <a:ext uri="{FF2B5EF4-FFF2-40B4-BE49-F238E27FC236}">
-                <a16:creationId xmlns:a16="http://schemas.microsoft.com/office/drawing/2014/main" id="{DB1C35BF-3E2B-4A65-BEBD-2019602A5404}"/>
+                <a16:creationId xmlns:a16="http://schemas.microsoft.com/office/drawing/2014/main" id="{E0BB5905-1B76-4A6C-B16B-6AD8736E4333}"/>
               </a:ext>
             </a:extLst>
           </p:cNvPr>
@@ -4402,7 +4402,7 @@
           <p:cNvPr id="41" name="">
             <a:extLst xmlns:a="http://schemas.openxmlformats.org/drawingml/2006/main">
               <a:ext uri="{FF2B5EF4-FFF2-40B4-BE49-F238E27FC236}">
-                <a16:creationId xmlns:a16="http://schemas.microsoft.com/office/drawing/2014/main" id="{BCB43715-E928-4D8E-9274-CEE54C68B6F4}"/>
+                <a16:creationId xmlns:a16="http://schemas.microsoft.com/office/drawing/2014/main" id="{7C238933-D7DD-428A-A6F8-8795ED5D00CE}"/>
               </a:ext>
             </a:extLst>
           </p:cNvPr>
@@ -4435,7 +4435,7 @@
           <p:cNvPr id="42" name="">
             <a:extLst xmlns:a="http://schemas.openxmlformats.org/drawingml/2006/main">
               <a:ext uri="{FF2B5EF4-FFF2-40B4-BE49-F238E27FC236}">
-                <a16:creationId xmlns:a16="http://schemas.microsoft.com/office/drawing/2014/main" id="{80DE3E18-ACBB-442A-B010-F5FB4DDFD5D9}"/>
+                <a16:creationId xmlns:a16="http://schemas.microsoft.com/office/drawing/2014/main" id="{4FB41CF2-76C6-4426-B96D-C98B0B2257BC}"/>
               </a:ext>
             </a:extLst>
           </p:cNvPr>
@@ -4485,7 +4485,7 @@
           <p:cNvPr id="43" name="">
             <a:extLst xmlns:a="http://schemas.openxmlformats.org/drawingml/2006/main">
               <a:ext uri="{FF2B5EF4-FFF2-40B4-BE49-F238E27FC236}">
-                <a16:creationId xmlns:a16="http://schemas.microsoft.com/office/drawing/2014/main" id="{2F306699-66C6-4FCF-A072-3F25A6C33711}"/>
+                <a16:creationId xmlns:a16="http://schemas.microsoft.com/office/drawing/2014/main" id="{99A4EB93-C0F4-4316-9DDC-03E95EEB13B4}"/>
               </a:ext>
             </a:extLst>
           </p:cNvPr>
@@ -4533,7 +4533,7 @@
     </p:spTree>
     <p:extLst>
       <p:ext uri="{BB962C8B-B14F-4D97-AF65-F5344CB8AC3E}">
-        <p14:creationId xmlns:p14="http://schemas.microsoft.com/office/powerpoint/2010/main" val="599762992"/>
+        <p14:creationId xmlns:p14="http://schemas.microsoft.com/office/powerpoint/2010/main" val="753483949"/>
       </p:ext>
     </p:extLst>
   </p:cSld>
@@ -4564,7 +4564,7 @@
           <p:cNvPr id="1" name="">
             <a:extLst xmlns:a="http://schemas.openxmlformats.org/drawingml/2006/main">
               <a:ext uri="{FF2B5EF4-FFF2-40B4-BE49-F238E27FC236}">
-                <a16:creationId xmlns:a16="http://schemas.microsoft.com/office/drawing/2014/main" id="{BE08F0BF-3047-4DB7-939A-5AF7D358618B}"/>
+                <a16:creationId xmlns:a16="http://schemas.microsoft.com/office/drawing/2014/main" id="{A3B7E45F-FFC2-4E1F-8CDD-978BE658A5B3}"/>
               </a:ext>
             </a:extLst>
           </p:cNvPr>
@@ -4595,7 +4595,7 @@
           <p:cNvPr id="2" name="">
             <a:extLst xmlns:a="http://schemas.openxmlformats.org/drawingml/2006/main">
               <a:ext uri="{FF2B5EF4-FFF2-40B4-BE49-F238E27FC236}">
-                <a16:creationId xmlns:a16="http://schemas.microsoft.com/office/drawing/2014/main" id="{5CA5A537-6639-46D2-BEC1-A7E69B0C3037}"/>
+                <a16:creationId xmlns:a16="http://schemas.microsoft.com/office/drawing/2014/main" id="{A404ECBC-AED4-47EF-AF29-FB79F568305A}"/>
               </a:ext>
             </a:extLst>
           </p:cNvPr>
@@ -4645,7 +4645,7 @@
           <p:cNvPr id="3" name="">
             <a:extLst xmlns:a="http://schemas.openxmlformats.org/drawingml/2006/main">
               <a:ext uri="{FF2B5EF4-FFF2-40B4-BE49-F238E27FC236}">
-                <a16:creationId xmlns:a16="http://schemas.microsoft.com/office/drawing/2014/main" id="{759E9623-3D29-472A-B4C8-57892ED6F238}"/>
+                <a16:creationId xmlns:a16="http://schemas.microsoft.com/office/drawing/2014/main" id="{F1F127E1-086E-45E3-9B75-EF6C3DB2B669}"/>
               </a:ext>
             </a:extLst>
           </p:cNvPr>
@@ -4695,7 +4695,7 @@
           <p:cNvPr id="4" name="">
             <a:extLst xmlns:a="http://schemas.openxmlformats.org/drawingml/2006/main">
               <a:ext uri="{FF2B5EF4-FFF2-40B4-BE49-F238E27FC236}">
-                <a16:creationId xmlns:a16="http://schemas.microsoft.com/office/drawing/2014/main" id="{81300271-47BF-48E8-BEA9-9F4392899A72}"/>
+                <a16:creationId xmlns:a16="http://schemas.microsoft.com/office/drawing/2014/main" id="{18A42678-DC32-45FE-B5C1-146BB2C19453}"/>
               </a:ext>
             </a:extLst>
           </p:cNvPr>
@@ -4726,7 +4726,7 @@
           <p:cNvPr id="5" name="">
             <a:extLst xmlns:a="http://schemas.openxmlformats.org/drawingml/2006/main">
               <a:ext uri="{FF2B5EF4-FFF2-40B4-BE49-F238E27FC236}">
-                <a16:creationId xmlns:a16="http://schemas.microsoft.com/office/drawing/2014/main" id="{8B647770-AAC0-4B67-8542-8D429D7FFE2B}"/>
+                <a16:creationId xmlns:a16="http://schemas.microsoft.com/office/drawing/2014/main" id="{8A831890-020C-4D9F-8F84-D0AA06E0E5E9}"/>
               </a:ext>
             </a:extLst>
           </p:cNvPr>
@@ -4776,7 +4776,7 @@
           <p:cNvPr id="6" name="">
             <a:extLst xmlns:a="http://schemas.openxmlformats.org/drawingml/2006/main">
               <a:ext uri="{FF2B5EF4-FFF2-40B4-BE49-F238E27FC236}">
-                <a16:creationId xmlns:a16="http://schemas.microsoft.com/office/drawing/2014/main" id="{47536AD5-0422-4A05-AD82-904E8CCB5D63}"/>
+                <a16:creationId xmlns:a16="http://schemas.microsoft.com/office/drawing/2014/main" id="{81820E3E-E324-4B34-805E-1E11A547A802}"/>
               </a:ext>
             </a:extLst>
           </p:cNvPr>
@@ -4826,7 +4826,7 @@
           <p:cNvPr id="7" name="">
             <a:extLst xmlns:a="http://schemas.openxmlformats.org/drawingml/2006/main">
               <a:ext uri="{FF2B5EF4-FFF2-40B4-BE49-F238E27FC236}">
-                <a16:creationId xmlns:a16="http://schemas.microsoft.com/office/drawing/2014/main" id="{E2E4219A-0142-4FF1-8F60-E672AC3AB798}"/>
+                <a16:creationId xmlns:a16="http://schemas.microsoft.com/office/drawing/2014/main" id="{3FB7D9AC-F149-4026-9AA4-A0BDF920F45B}"/>
               </a:ext>
             </a:extLst>
           </p:cNvPr>
@@ -4876,7 +4876,7 @@
           <p:cNvPr id="8" name="">
             <a:extLst xmlns:a="http://schemas.openxmlformats.org/drawingml/2006/main">
               <a:ext uri="{FF2B5EF4-FFF2-40B4-BE49-F238E27FC236}">
-                <a16:creationId xmlns:a16="http://schemas.microsoft.com/office/drawing/2014/main" id="{68EDF999-9D01-4E6D-9D9E-7306C47F4207}"/>
+                <a16:creationId xmlns:a16="http://schemas.microsoft.com/office/drawing/2014/main" id="{4542890A-EDE6-4CF4-A78F-DBF5BDBC91B1}"/>
               </a:ext>
             </a:extLst>
           </p:cNvPr>
@@ -4926,7 +4926,7 @@
           <p:cNvPr id="9" name="">
             <a:extLst xmlns:a="http://schemas.openxmlformats.org/drawingml/2006/main">
               <a:ext uri="{FF2B5EF4-FFF2-40B4-BE49-F238E27FC236}">
-                <a16:creationId xmlns:a16="http://schemas.microsoft.com/office/drawing/2014/main" id="{B0265157-F5F2-4782-8D92-FF41652F1C0A}"/>
+                <a16:creationId xmlns:a16="http://schemas.microsoft.com/office/drawing/2014/main" id="{EFA87A78-7E10-4475-B837-7993F414E337}"/>
               </a:ext>
             </a:extLst>
           </p:cNvPr>
@@ -4957,7 +4957,7 @@
           <p:cNvPr id="10" name="">
             <a:extLst xmlns:a="http://schemas.openxmlformats.org/drawingml/2006/main">
               <a:ext uri="{FF2B5EF4-FFF2-40B4-BE49-F238E27FC236}">
-                <a16:creationId xmlns:a16="http://schemas.microsoft.com/office/drawing/2014/main" id="{2736C00F-61C9-47BA-B18C-70A436A18907}"/>
+                <a16:creationId xmlns:a16="http://schemas.microsoft.com/office/drawing/2014/main" id="{2C3E18C3-DF09-4674-8559-0DBEBD907000}"/>
               </a:ext>
             </a:extLst>
           </p:cNvPr>
@@ -4990,7 +4990,7 @@
           <p:cNvPr id="11" name="">
             <a:extLst xmlns:a="http://schemas.openxmlformats.org/drawingml/2006/main">
               <a:ext uri="{FF2B5EF4-FFF2-40B4-BE49-F238E27FC236}">
-                <a16:creationId xmlns:a16="http://schemas.microsoft.com/office/drawing/2014/main" id="{610DF41C-66F0-4B30-8093-2A9B283AF7B1}"/>
+                <a16:creationId xmlns:a16="http://schemas.microsoft.com/office/drawing/2014/main" id="{23C042B1-722C-4CFE-BE07-0BF88D442123}"/>
               </a:ext>
             </a:extLst>
           </p:cNvPr>
@@ -5040,7 +5040,7 @@
           <p:cNvPr id="12" name="">
             <a:extLst xmlns:a="http://schemas.openxmlformats.org/drawingml/2006/main">
               <a:ext uri="{FF2B5EF4-FFF2-40B4-BE49-F238E27FC236}">
-                <a16:creationId xmlns:a16="http://schemas.microsoft.com/office/drawing/2014/main" id="{262EE958-C1D5-45C5-A540-147FD4CC72D4}"/>
+                <a16:creationId xmlns:a16="http://schemas.microsoft.com/office/drawing/2014/main" id="{A9576B80-6A12-4334-9034-4C7FB2D45DB3}"/>
               </a:ext>
             </a:extLst>
           </p:cNvPr>
@@ -5090,7 +5090,7 @@
           <p:cNvPr id="13" name="">
             <a:extLst xmlns:a="http://schemas.openxmlformats.org/drawingml/2006/main">
               <a:ext uri="{FF2B5EF4-FFF2-40B4-BE49-F238E27FC236}">
-                <a16:creationId xmlns:a16="http://schemas.microsoft.com/office/drawing/2014/main" id="{CBE9E811-9E24-4679-8F49-1D64741DA7AE}"/>
+                <a16:creationId xmlns:a16="http://schemas.microsoft.com/office/drawing/2014/main" id="{A7390B52-762C-4020-AAE5-83D83FF19CC3}"/>
               </a:ext>
             </a:extLst>
           </p:cNvPr>
@@ -5123,7 +5123,7 @@
           <p:cNvPr id="14" name="">
             <a:extLst xmlns:a="http://schemas.openxmlformats.org/drawingml/2006/main">
               <a:ext uri="{FF2B5EF4-FFF2-40B4-BE49-F238E27FC236}">
-                <a16:creationId xmlns:a16="http://schemas.microsoft.com/office/drawing/2014/main" id="{619F3303-5CFA-4EC9-8A0D-B3A479ED0921}"/>
+                <a16:creationId xmlns:a16="http://schemas.microsoft.com/office/drawing/2014/main" id="{A6F30FB1-54E9-4A94-B533-2D4C11251611}"/>
               </a:ext>
             </a:extLst>
           </p:cNvPr>
@@ -5173,7 +5173,7 @@
           <p:cNvPr id="15" name="">
             <a:extLst xmlns:a="http://schemas.openxmlformats.org/drawingml/2006/main">
               <a:ext uri="{FF2B5EF4-FFF2-40B4-BE49-F238E27FC236}">
-                <a16:creationId xmlns:a16="http://schemas.microsoft.com/office/drawing/2014/main" id="{6678754C-FDFA-4B87-A0A8-82F316E9DB8B}"/>
+                <a16:creationId xmlns:a16="http://schemas.microsoft.com/office/drawing/2014/main" id="{56095191-8231-49AF-9A78-DC457B65BDD1}"/>
               </a:ext>
             </a:extLst>
           </p:cNvPr>
@@ -5223,7 +5223,7 @@
           <p:cNvPr id="16" name="">
             <a:extLst xmlns:a="http://schemas.openxmlformats.org/drawingml/2006/main">
               <a:ext uri="{FF2B5EF4-FFF2-40B4-BE49-F238E27FC236}">
-                <a16:creationId xmlns:a16="http://schemas.microsoft.com/office/drawing/2014/main" id="{010297DD-E949-43D2-883F-C5A52586674E}"/>
+                <a16:creationId xmlns:a16="http://schemas.microsoft.com/office/drawing/2014/main" id="{1A59D605-5EE8-43F5-B937-497E67B163BC}"/>
               </a:ext>
             </a:extLst>
           </p:cNvPr>
@@ -5256,7 +5256,7 @@
           <p:cNvPr id="17" name="">
             <a:extLst xmlns:a="http://schemas.openxmlformats.org/drawingml/2006/main">
               <a:ext uri="{FF2B5EF4-FFF2-40B4-BE49-F238E27FC236}">
-                <a16:creationId xmlns:a16="http://schemas.microsoft.com/office/drawing/2014/main" id="{E2EDA9F7-9EAB-47BC-B8B5-F43BC16B2DBD}"/>
+                <a16:creationId xmlns:a16="http://schemas.microsoft.com/office/drawing/2014/main" id="{B5081569-9609-4911-A44B-1A4A1BFB7D33}"/>
               </a:ext>
             </a:extLst>
           </p:cNvPr>
@@ -5306,7 +5306,7 @@
           <p:cNvPr id="18" name="">
             <a:extLst xmlns:a="http://schemas.openxmlformats.org/drawingml/2006/main">
               <a:ext uri="{FF2B5EF4-FFF2-40B4-BE49-F238E27FC236}">
-                <a16:creationId xmlns:a16="http://schemas.microsoft.com/office/drawing/2014/main" id="{6FE608BB-7382-4B0A-84E9-4F8A0E261B6B}"/>
+                <a16:creationId xmlns:a16="http://schemas.microsoft.com/office/drawing/2014/main" id="{0CA7D0DC-184B-4049-9D40-23EDF4520766}"/>
               </a:ext>
             </a:extLst>
           </p:cNvPr>
@@ -5356,7 +5356,7 @@
           <p:cNvPr id="19" name="">
             <a:extLst xmlns:a="http://schemas.openxmlformats.org/drawingml/2006/main">
               <a:ext uri="{FF2B5EF4-FFF2-40B4-BE49-F238E27FC236}">
-                <a16:creationId xmlns:a16="http://schemas.microsoft.com/office/drawing/2014/main" id="{DC9A0163-5654-4D22-A1B0-DE99724AA2DD}"/>
+                <a16:creationId xmlns:a16="http://schemas.microsoft.com/office/drawing/2014/main" id="{CB6A922E-645C-4CE7-A88E-7BBF460C1AC5}"/>
               </a:ext>
             </a:extLst>
           </p:cNvPr>
@@ -5389,7 +5389,7 @@
           <p:cNvPr id="20" name="">
             <a:extLst xmlns:a="http://schemas.openxmlformats.org/drawingml/2006/main">
               <a:ext uri="{FF2B5EF4-FFF2-40B4-BE49-F238E27FC236}">
-                <a16:creationId xmlns:a16="http://schemas.microsoft.com/office/drawing/2014/main" id="{485DAADC-B993-4FD1-8B1C-FAD536EB606E}"/>
+                <a16:creationId xmlns:a16="http://schemas.microsoft.com/office/drawing/2014/main" id="{345E71A1-5FCD-42A8-951F-B89CCBD08A3A}"/>
               </a:ext>
             </a:extLst>
           </p:cNvPr>
@@ -5439,7 +5439,7 @@
           <p:cNvPr id="21" name="">
             <a:extLst xmlns:a="http://schemas.openxmlformats.org/drawingml/2006/main">
               <a:ext uri="{FF2B5EF4-FFF2-40B4-BE49-F238E27FC236}">
-                <a16:creationId xmlns:a16="http://schemas.microsoft.com/office/drawing/2014/main" id="{B05F2E36-A594-4B76-A83C-6DEEFA86A732}"/>
+                <a16:creationId xmlns:a16="http://schemas.microsoft.com/office/drawing/2014/main" id="{2D48CEB0-1172-4ED4-AF52-78AE59451B4E}"/>
               </a:ext>
             </a:extLst>
           </p:cNvPr>
@@ -5489,7 +5489,7 @@
           <p:cNvPr id="22" name="">
             <a:extLst xmlns:a="http://schemas.openxmlformats.org/drawingml/2006/main">
               <a:ext uri="{FF2B5EF4-FFF2-40B4-BE49-F238E27FC236}">
-                <a16:creationId xmlns:a16="http://schemas.microsoft.com/office/drawing/2014/main" id="{55317744-1408-4E40-98BF-3C6EFE031393}"/>
+                <a16:creationId xmlns:a16="http://schemas.microsoft.com/office/drawing/2014/main" id="{BCC8368B-7298-48F5-AF92-582E7307B057}"/>
               </a:ext>
             </a:extLst>
           </p:cNvPr>
@@ -5522,7 +5522,7 @@
           <p:cNvPr id="23" name="">
             <a:extLst xmlns:a="http://schemas.openxmlformats.org/drawingml/2006/main">
               <a:ext uri="{FF2B5EF4-FFF2-40B4-BE49-F238E27FC236}">
-                <a16:creationId xmlns:a16="http://schemas.microsoft.com/office/drawing/2014/main" id="{280F218A-B2AF-457C-8129-EE8878E00E9C}"/>
+                <a16:creationId xmlns:a16="http://schemas.microsoft.com/office/drawing/2014/main" id="{B3A0854C-33D4-49F3-BD22-3CECB24E7A67}"/>
               </a:ext>
             </a:extLst>
           </p:cNvPr>
@@ -5572,7 +5572,7 @@
           <p:cNvPr id="24" name="">
             <a:extLst xmlns:a="http://schemas.openxmlformats.org/drawingml/2006/main">
               <a:ext uri="{FF2B5EF4-FFF2-40B4-BE49-F238E27FC236}">
-                <a16:creationId xmlns:a16="http://schemas.microsoft.com/office/drawing/2014/main" id="{20842CEE-1397-43D2-9CEB-C516FB7BAE73}"/>
+                <a16:creationId xmlns:a16="http://schemas.microsoft.com/office/drawing/2014/main" id="{9E108B87-5C15-4E18-8204-AE6131100E30}"/>
               </a:ext>
             </a:extLst>
           </p:cNvPr>
@@ -5622,7 +5622,7 @@
           <p:cNvPr id="25" name="">
             <a:extLst xmlns:a="http://schemas.openxmlformats.org/drawingml/2006/main">
               <a:ext uri="{FF2B5EF4-FFF2-40B4-BE49-F238E27FC236}">
-                <a16:creationId xmlns:a16="http://schemas.microsoft.com/office/drawing/2014/main" id="{08824DA5-E8F8-466F-B760-F02660AC6A1F}"/>
+                <a16:creationId xmlns:a16="http://schemas.microsoft.com/office/drawing/2014/main" id="{91172AD4-6B69-46BC-BC69-D2A46FFEDDFA}"/>
               </a:ext>
             </a:extLst>
           </p:cNvPr>
@@ -5655,7 +5655,7 @@
           <p:cNvPr id="26" name="">
             <a:extLst xmlns:a="http://schemas.openxmlformats.org/drawingml/2006/main">
               <a:ext uri="{FF2B5EF4-FFF2-40B4-BE49-F238E27FC236}">
-                <a16:creationId xmlns:a16="http://schemas.microsoft.com/office/drawing/2014/main" id="{7DBD507E-13F0-48E3-9B22-23EBB6BA6617}"/>
+                <a16:creationId xmlns:a16="http://schemas.microsoft.com/office/drawing/2014/main" id="{BDB19634-086E-4B0B-BC27-3AF5E30B7557}"/>
               </a:ext>
             </a:extLst>
           </p:cNvPr>
@@ -5705,7 +5705,7 @@
           <p:cNvPr id="27" name="">
             <a:extLst xmlns:a="http://schemas.openxmlformats.org/drawingml/2006/main">
               <a:ext uri="{FF2B5EF4-FFF2-40B4-BE49-F238E27FC236}">
-                <a16:creationId xmlns:a16="http://schemas.microsoft.com/office/drawing/2014/main" id="{DEDDB3EA-6416-46DE-A6C1-9DE1E35586D6}"/>
+                <a16:creationId xmlns:a16="http://schemas.microsoft.com/office/drawing/2014/main" id="{865FC081-B37D-4F7C-AF0C-0D8E946AEB92}"/>
               </a:ext>
             </a:extLst>
           </p:cNvPr>
@@ -5755,7 +5755,7 @@
           <p:cNvPr id="28" name="">
             <a:extLst xmlns:a="http://schemas.openxmlformats.org/drawingml/2006/main">
               <a:ext uri="{FF2B5EF4-FFF2-40B4-BE49-F238E27FC236}">
-                <a16:creationId xmlns:a16="http://schemas.microsoft.com/office/drawing/2014/main" id="{97562472-1799-486F-B49D-C66F3DE8CD67}"/>
+                <a16:creationId xmlns:a16="http://schemas.microsoft.com/office/drawing/2014/main" id="{6D6EC421-5E45-4D72-8EC9-FBB73DEF7B45}"/>
               </a:ext>
             </a:extLst>
           </p:cNvPr>
@@ -5788,7 +5788,7 @@
           <p:cNvPr id="29" name="">
             <a:extLst xmlns:a="http://schemas.openxmlformats.org/drawingml/2006/main">
               <a:ext uri="{FF2B5EF4-FFF2-40B4-BE49-F238E27FC236}">
-                <a16:creationId xmlns:a16="http://schemas.microsoft.com/office/drawing/2014/main" id="{13FF9F51-CF36-41BA-8BD6-727F134A6F8F}"/>
+                <a16:creationId xmlns:a16="http://schemas.microsoft.com/office/drawing/2014/main" id="{BE38DCA3-2823-490C-9424-7A70041A2692}"/>
               </a:ext>
             </a:extLst>
           </p:cNvPr>
@@ -5838,7 +5838,7 @@
           <p:cNvPr id="30" name="">
             <a:extLst xmlns:a="http://schemas.openxmlformats.org/drawingml/2006/main">
               <a:ext uri="{FF2B5EF4-FFF2-40B4-BE49-F238E27FC236}">
-                <a16:creationId xmlns:a16="http://schemas.microsoft.com/office/drawing/2014/main" id="{530E8A0C-CAB4-4EB1-ACF8-6B58714D2120}"/>
+                <a16:creationId xmlns:a16="http://schemas.microsoft.com/office/drawing/2014/main" id="{01C6F207-F4E9-46EE-8C52-CCFA419A23BD}"/>
               </a:ext>
             </a:extLst>
           </p:cNvPr>
@@ -5888,7 +5888,7 @@
           <p:cNvPr id="31" name="">
             <a:extLst xmlns:a="http://schemas.openxmlformats.org/drawingml/2006/main">
               <a:ext uri="{FF2B5EF4-FFF2-40B4-BE49-F238E27FC236}">
-                <a16:creationId xmlns:a16="http://schemas.microsoft.com/office/drawing/2014/main" id="{2088BA76-74E6-48C8-BA79-573CF8EC8F8A}"/>
+                <a16:creationId xmlns:a16="http://schemas.microsoft.com/office/drawing/2014/main" id="{70CF058D-E9B4-4EA8-AB84-0FB8CD3B60C7}"/>
               </a:ext>
             </a:extLst>
           </p:cNvPr>
@@ -5921,7 +5921,7 @@
           <p:cNvPr id="32" name="">
             <a:extLst xmlns:a="http://schemas.openxmlformats.org/drawingml/2006/main">
               <a:ext uri="{FF2B5EF4-FFF2-40B4-BE49-F238E27FC236}">
-                <a16:creationId xmlns:a16="http://schemas.microsoft.com/office/drawing/2014/main" id="{E8C1CD2B-A5CE-4886-BE75-29C91A8CB6F2}"/>
+                <a16:creationId xmlns:a16="http://schemas.microsoft.com/office/drawing/2014/main" id="{2244B1F9-29D8-4CEB-9323-3085F10C1265}"/>
               </a:ext>
             </a:extLst>
           </p:cNvPr>
@@ -5971,7 +5971,7 @@
           <p:cNvPr id="33" name="">
             <a:extLst xmlns:a="http://schemas.openxmlformats.org/drawingml/2006/main">
               <a:ext uri="{FF2B5EF4-FFF2-40B4-BE49-F238E27FC236}">
-                <a16:creationId xmlns:a16="http://schemas.microsoft.com/office/drawing/2014/main" id="{22A400AD-3811-409F-BBFE-C9007CA4DD38}"/>
+                <a16:creationId xmlns:a16="http://schemas.microsoft.com/office/drawing/2014/main" id="{F68A273E-1465-498F-9327-EBB2ABB3D194}"/>
               </a:ext>
             </a:extLst>
           </p:cNvPr>
@@ -6021,7 +6021,7 @@
           <p:cNvPr id="34" name="">
             <a:extLst xmlns:a="http://schemas.openxmlformats.org/drawingml/2006/main">
               <a:ext uri="{FF2B5EF4-FFF2-40B4-BE49-F238E27FC236}">
-                <a16:creationId xmlns:a16="http://schemas.microsoft.com/office/drawing/2014/main" id="{7C12C5B7-C38F-42CC-8B8C-F637347D313F}"/>
+                <a16:creationId xmlns:a16="http://schemas.microsoft.com/office/drawing/2014/main" id="{E777C5AD-F2D6-4E28-89AC-C58DB26AF0EE}"/>
               </a:ext>
             </a:extLst>
           </p:cNvPr>
@@ -6054,7 +6054,7 @@
           <p:cNvPr id="35" name="">
             <a:extLst xmlns:a="http://schemas.openxmlformats.org/drawingml/2006/main">
               <a:ext uri="{FF2B5EF4-FFF2-40B4-BE49-F238E27FC236}">
-                <a16:creationId xmlns:a16="http://schemas.microsoft.com/office/drawing/2014/main" id="{B3A76982-E312-49F6-AD73-F5815ADC59D4}"/>
+                <a16:creationId xmlns:a16="http://schemas.microsoft.com/office/drawing/2014/main" id="{A6B76A0C-4292-4B03-9DC0-514B62CF2776}"/>
               </a:ext>
             </a:extLst>
           </p:cNvPr>
@@ -6104,7 +6104,7 @@
           <p:cNvPr id="36" name="">
             <a:extLst xmlns:a="http://schemas.openxmlformats.org/drawingml/2006/main">
               <a:ext uri="{FF2B5EF4-FFF2-40B4-BE49-F238E27FC236}">
-                <a16:creationId xmlns:a16="http://schemas.microsoft.com/office/drawing/2014/main" id="{8BC91060-BB37-42E1-8A06-5EDBE7F70CAE}"/>
+                <a16:creationId xmlns:a16="http://schemas.microsoft.com/office/drawing/2014/main" id="{E4B57FF3-9893-45C2-80C1-F646C7049E60}"/>
               </a:ext>
             </a:extLst>
           </p:cNvPr>
@@ -6154,7 +6154,7 @@
           <p:cNvPr id="37" name="">
             <a:extLst xmlns:a="http://schemas.openxmlformats.org/drawingml/2006/main">
               <a:ext uri="{FF2B5EF4-FFF2-40B4-BE49-F238E27FC236}">
-                <a16:creationId xmlns:a16="http://schemas.microsoft.com/office/drawing/2014/main" id="{FA6B392D-10E5-4CD8-B85F-7CA542E5CC66}"/>
+                <a16:creationId xmlns:a16="http://schemas.microsoft.com/office/drawing/2014/main" id="{0C16463D-F469-4A87-B551-452AC8F1DA84}"/>
               </a:ext>
             </a:extLst>
           </p:cNvPr>
@@ -6187,7 +6187,7 @@
           <p:cNvPr id="38" name="">
             <a:extLst xmlns:a="http://schemas.openxmlformats.org/drawingml/2006/main">
               <a:ext uri="{FF2B5EF4-FFF2-40B4-BE49-F238E27FC236}">
-                <a16:creationId xmlns:a16="http://schemas.microsoft.com/office/drawing/2014/main" id="{1AACC0B9-E022-4272-94BE-45E05758EFA7}"/>
+                <a16:creationId xmlns:a16="http://schemas.microsoft.com/office/drawing/2014/main" id="{FF6C7A22-1424-4DCD-A4CC-5BD5AC6C1642}"/>
               </a:ext>
             </a:extLst>
           </p:cNvPr>
@@ -6237,7 +6237,7 @@
           <p:cNvPr id="39" name="">
             <a:extLst xmlns:a="http://schemas.openxmlformats.org/drawingml/2006/main">
               <a:ext uri="{FF2B5EF4-FFF2-40B4-BE49-F238E27FC236}">
-                <a16:creationId xmlns:a16="http://schemas.microsoft.com/office/drawing/2014/main" id="{C08144BC-214D-4D9F-9C18-EC4077436027}"/>
+                <a16:creationId xmlns:a16="http://schemas.microsoft.com/office/drawing/2014/main" id="{082A29BD-BBAC-4BE2-83AE-5667BCAF444E}"/>
               </a:ext>
             </a:extLst>
           </p:cNvPr>
@@ -6285,7 +6285,7 @@
     </p:spTree>
     <p:extLst>
       <p:ext uri="{BB962C8B-B14F-4D97-AF65-F5344CB8AC3E}">
-        <p14:creationId xmlns:p14="http://schemas.microsoft.com/office/powerpoint/2010/main" val="1416021932"/>
+        <p14:creationId xmlns:p14="http://schemas.microsoft.com/office/powerpoint/2010/main" val="91668791"/>
       </p:ext>
     </p:extLst>
   </p:cSld>
@@ -6316,7 +6316,7 @@
           <p:cNvPr id="1" name="">
             <a:extLst xmlns:a="http://schemas.openxmlformats.org/drawingml/2006/main">
               <a:ext uri="{FF2B5EF4-FFF2-40B4-BE49-F238E27FC236}">
-                <a16:creationId xmlns:a16="http://schemas.microsoft.com/office/drawing/2014/main" id="{534D3EB7-40B0-4662-B1BB-AD47F82AF19D}"/>
+                <a16:creationId xmlns:a16="http://schemas.microsoft.com/office/drawing/2014/main" id="{B9E96379-8775-4C3C-8E3D-C1BAB54CA413}"/>
               </a:ext>
             </a:extLst>
           </p:cNvPr>
@@ -6347,7 +6347,7 @@
           <p:cNvPr id="2" name="">
             <a:extLst xmlns:a="http://schemas.openxmlformats.org/drawingml/2006/main">
               <a:ext uri="{FF2B5EF4-FFF2-40B4-BE49-F238E27FC236}">
-                <a16:creationId xmlns:a16="http://schemas.microsoft.com/office/drawing/2014/main" id="{252C38AB-0942-4205-A180-62B91BD1224F}"/>
+                <a16:creationId xmlns:a16="http://schemas.microsoft.com/office/drawing/2014/main" id="{AB445488-073F-4E17-A9F6-6C62A8041C5C}"/>
               </a:ext>
             </a:extLst>
           </p:cNvPr>
@@ -6397,7 +6397,7 @@
           <p:cNvPr id="3" name="">
             <a:extLst xmlns:a="http://schemas.openxmlformats.org/drawingml/2006/main">
               <a:ext uri="{FF2B5EF4-FFF2-40B4-BE49-F238E27FC236}">
-                <a16:creationId xmlns:a16="http://schemas.microsoft.com/office/drawing/2014/main" id="{AE81E4C9-A22D-4217-AFBD-9EAC30095D41}"/>
+                <a16:creationId xmlns:a16="http://schemas.microsoft.com/office/drawing/2014/main" id="{17BD46E3-6D25-433F-A3E5-2F03AAD3F7A7}"/>
               </a:ext>
             </a:extLst>
           </p:cNvPr>
@@ -6447,7 +6447,7 @@
           <p:cNvPr id="4" name="">
             <a:extLst xmlns:a="http://schemas.openxmlformats.org/drawingml/2006/main">
               <a:ext uri="{FF2B5EF4-FFF2-40B4-BE49-F238E27FC236}">
-                <a16:creationId xmlns:a16="http://schemas.microsoft.com/office/drawing/2014/main" id="{B1AA3614-4ECF-4255-B078-1BEC30AAA38E}"/>
+                <a16:creationId xmlns:a16="http://schemas.microsoft.com/office/drawing/2014/main" id="{D97B4E24-9203-43EC-BFE3-7E8E539455E1}"/>
               </a:ext>
             </a:extLst>
           </p:cNvPr>
@@ -6478,7 +6478,7 @@
           <p:cNvPr id="5" name="">
             <a:extLst xmlns:a="http://schemas.openxmlformats.org/drawingml/2006/main">
               <a:ext uri="{FF2B5EF4-FFF2-40B4-BE49-F238E27FC236}">
-                <a16:creationId xmlns:a16="http://schemas.microsoft.com/office/drawing/2014/main" id="{EF5256F0-83A6-41ED-83C2-FFC197978115}"/>
+                <a16:creationId xmlns:a16="http://schemas.microsoft.com/office/drawing/2014/main" id="{980D9166-431C-4BB1-8695-939CB9C4BD37}"/>
               </a:ext>
             </a:extLst>
           </p:cNvPr>
@@ -6528,7 +6528,7 @@
           <p:cNvPr id="6" name="">
             <a:extLst xmlns:a="http://schemas.openxmlformats.org/drawingml/2006/main">
               <a:ext uri="{FF2B5EF4-FFF2-40B4-BE49-F238E27FC236}">
-                <a16:creationId xmlns:a16="http://schemas.microsoft.com/office/drawing/2014/main" id="{851A3ED2-4046-4899-A5E4-D14C0C3895B3}"/>
+                <a16:creationId xmlns:a16="http://schemas.microsoft.com/office/drawing/2014/main" id="{ECF2101D-1B78-48CD-A0C4-CD372DEF8EE2}"/>
               </a:ext>
             </a:extLst>
           </p:cNvPr>
@@ -6578,7 +6578,7 @@
           <p:cNvPr id="7" name="">
             <a:extLst xmlns:a="http://schemas.openxmlformats.org/drawingml/2006/main">
               <a:ext uri="{FF2B5EF4-FFF2-40B4-BE49-F238E27FC236}">
-                <a16:creationId xmlns:a16="http://schemas.microsoft.com/office/drawing/2014/main" id="{326E7F3B-9463-4D66-A47F-9ABDAA642696}"/>
+                <a16:creationId xmlns:a16="http://schemas.microsoft.com/office/drawing/2014/main" id="{9DC254E3-D271-47B1-9264-99929C224290}"/>
               </a:ext>
             </a:extLst>
           </p:cNvPr>
@@ -6628,7 +6628,7 @@
           <p:cNvPr id="8" name="">
             <a:extLst xmlns:a="http://schemas.openxmlformats.org/drawingml/2006/main">
               <a:ext uri="{FF2B5EF4-FFF2-40B4-BE49-F238E27FC236}">
-                <a16:creationId xmlns:a16="http://schemas.microsoft.com/office/drawing/2014/main" id="{06964C47-972E-46D1-8006-243DDDE7921A}"/>
+                <a16:creationId xmlns:a16="http://schemas.microsoft.com/office/drawing/2014/main" id="{E185E0C9-06C3-49B9-AC2E-75834FE7DA26}"/>
               </a:ext>
             </a:extLst>
           </p:cNvPr>
@@ -6678,7 +6678,7 @@
           <p:cNvPr id="9" name="">
             <a:extLst xmlns:a="http://schemas.openxmlformats.org/drawingml/2006/main">
               <a:ext uri="{FF2B5EF4-FFF2-40B4-BE49-F238E27FC236}">
-                <a16:creationId xmlns:a16="http://schemas.microsoft.com/office/drawing/2014/main" id="{3A991B7B-2BB7-4310-9BF9-48BD317E0961}"/>
+                <a16:creationId xmlns:a16="http://schemas.microsoft.com/office/drawing/2014/main" id="{D4EC0797-46E4-4121-A0C4-38F22522E7BC}"/>
               </a:ext>
             </a:extLst>
           </p:cNvPr>
@@ -6709,7 +6709,7 @@
           <p:cNvPr id="10" name="">
             <a:extLst xmlns:a="http://schemas.openxmlformats.org/drawingml/2006/main">
               <a:ext uri="{FF2B5EF4-FFF2-40B4-BE49-F238E27FC236}">
-                <a16:creationId xmlns:a16="http://schemas.microsoft.com/office/drawing/2014/main" id="{955AA417-5054-4858-B68F-4889D30DBE1A}"/>
+                <a16:creationId xmlns:a16="http://schemas.microsoft.com/office/drawing/2014/main" id="{A898CE5E-5E2D-4C9D-BA6B-50B4FFC09AC4}"/>
               </a:ext>
             </a:extLst>
           </p:cNvPr>
@@ -6742,7 +6742,7 @@
           <p:cNvPr id="11" name="">
             <a:extLst xmlns:a="http://schemas.openxmlformats.org/drawingml/2006/main">
               <a:ext uri="{FF2B5EF4-FFF2-40B4-BE49-F238E27FC236}">
-                <a16:creationId xmlns:a16="http://schemas.microsoft.com/office/drawing/2014/main" id="{47A008A3-2492-4A48-B2D9-27435117AF7A}"/>
+                <a16:creationId xmlns:a16="http://schemas.microsoft.com/office/drawing/2014/main" id="{E539650C-B8B3-43C4-B5D1-2F613BB1FF00}"/>
               </a:ext>
             </a:extLst>
           </p:cNvPr>
@@ -6792,7 +6792,7 @@
           <p:cNvPr id="12" name="">
             <a:extLst xmlns:a="http://schemas.openxmlformats.org/drawingml/2006/main">
               <a:ext uri="{FF2B5EF4-FFF2-40B4-BE49-F238E27FC236}">
-                <a16:creationId xmlns:a16="http://schemas.microsoft.com/office/drawing/2014/main" id="{6E7F393D-39B3-4A15-B7C0-252024370127}"/>
+                <a16:creationId xmlns:a16="http://schemas.microsoft.com/office/drawing/2014/main" id="{6D2A0A6B-FC74-4C78-9D89-D0B155E7AEDC}"/>
               </a:ext>
             </a:extLst>
           </p:cNvPr>
@@ -6893,7 +6893,7 @@
           <p:cNvPr id="13" name="">
             <a:extLst xmlns:a="http://schemas.openxmlformats.org/drawingml/2006/main">
               <a:ext uri="{FF2B5EF4-FFF2-40B4-BE49-F238E27FC236}">
-                <a16:creationId xmlns:a16="http://schemas.microsoft.com/office/drawing/2014/main" id="{576B9B75-7617-4FAA-8D47-226BA90AC42D}"/>
+                <a16:creationId xmlns:a16="http://schemas.microsoft.com/office/drawing/2014/main" id="{8084EF7E-7595-4F03-807A-4F02A0A89497}"/>
               </a:ext>
             </a:extLst>
           </p:cNvPr>
@@ -6926,7 +6926,7 @@
           <p:cNvPr id="14" name="">
             <a:extLst xmlns:a="http://schemas.openxmlformats.org/drawingml/2006/main">
               <a:ext uri="{FF2B5EF4-FFF2-40B4-BE49-F238E27FC236}">
-                <a16:creationId xmlns:a16="http://schemas.microsoft.com/office/drawing/2014/main" id="{E76531B0-59D6-4BD5-A29C-A024DF138513}"/>
+                <a16:creationId xmlns:a16="http://schemas.microsoft.com/office/drawing/2014/main" id="{24BA8533-5685-4559-85B9-A71B0624EF5B}"/>
               </a:ext>
             </a:extLst>
           </p:cNvPr>
@@ -6976,7 +6976,7 @@
           <p:cNvPr id="15" name="">
             <a:extLst xmlns:a="http://schemas.openxmlformats.org/drawingml/2006/main">
               <a:ext uri="{FF2B5EF4-FFF2-40B4-BE49-F238E27FC236}">
-                <a16:creationId xmlns:a16="http://schemas.microsoft.com/office/drawing/2014/main" id="{E8E52B5E-919E-441E-BEF2-42F3D155BD13}"/>
+                <a16:creationId xmlns:a16="http://schemas.microsoft.com/office/drawing/2014/main" id="{204B6E21-6FD0-4F4E-B705-DD63BC35D303}"/>
               </a:ext>
             </a:extLst>
           </p:cNvPr>
@@ -7060,7 +7060,7 @@
           <p:cNvPr id="16" name="">
             <a:extLst xmlns:a="http://schemas.openxmlformats.org/drawingml/2006/main">
               <a:ext uri="{FF2B5EF4-FFF2-40B4-BE49-F238E27FC236}">
-                <a16:creationId xmlns:a16="http://schemas.microsoft.com/office/drawing/2014/main" id="{94094E97-6677-4EB7-AC70-441FA7B0776A}"/>
+                <a16:creationId xmlns:a16="http://schemas.microsoft.com/office/drawing/2014/main" id="{665EEC76-A0C6-4528-947A-267DC9E02AA4}"/>
               </a:ext>
             </a:extLst>
           </p:cNvPr>
@@ -7093,7 +7093,7 @@
           <p:cNvPr id="17" name="">
             <a:extLst xmlns:a="http://schemas.openxmlformats.org/drawingml/2006/main">
               <a:ext uri="{FF2B5EF4-FFF2-40B4-BE49-F238E27FC236}">
-                <a16:creationId xmlns:a16="http://schemas.microsoft.com/office/drawing/2014/main" id="{2D773C1C-B4B3-4F77-8347-58AF95E2FF02}"/>
+                <a16:creationId xmlns:a16="http://schemas.microsoft.com/office/drawing/2014/main" id="{E7D2A6C3-A67D-4031-9210-6D905D088FDE}"/>
               </a:ext>
             </a:extLst>
           </p:cNvPr>
@@ -7143,7 +7143,7 @@
           <p:cNvPr id="18" name="">
             <a:extLst xmlns:a="http://schemas.openxmlformats.org/drawingml/2006/main">
               <a:ext uri="{FF2B5EF4-FFF2-40B4-BE49-F238E27FC236}">
-                <a16:creationId xmlns:a16="http://schemas.microsoft.com/office/drawing/2014/main" id="{55E33895-6341-45F9-9B27-B75665BCCC35}"/>
+                <a16:creationId xmlns:a16="http://schemas.microsoft.com/office/drawing/2014/main" id="{D9A1FF33-46B0-4545-991F-E886E2D023F0}"/>
               </a:ext>
             </a:extLst>
           </p:cNvPr>
@@ -7227,7 +7227,7 @@
           <p:cNvPr id="19" name="">
             <a:extLst xmlns:a="http://schemas.openxmlformats.org/drawingml/2006/main">
               <a:ext uri="{FF2B5EF4-FFF2-40B4-BE49-F238E27FC236}">
-                <a16:creationId xmlns:a16="http://schemas.microsoft.com/office/drawing/2014/main" id="{8A1BFFC3-5290-4272-A501-809979980691}"/>
+                <a16:creationId xmlns:a16="http://schemas.microsoft.com/office/drawing/2014/main" id="{4EDDE02D-DCA1-4FA8-979E-36EB0CB7B99E}"/>
               </a:ext>
             </a:extLst>
           </p:cNvPr>
@@ -7260,7 +7260,7 @@
           <p:cNvPr id="20" name="">
             <a:extLst xmlns:a="http://schemas.openxmlformats.org/drawingml/2006/main">
               <a:ext uri="{FF2B5EF4-FFF2-40B4-BE49-F238E27FC236}">
-                <a16:creationId xmlns:a16="http://schemas.microsoft.com/office/drawing/2014/main" id="{8BB7F064-5DD5-47B5-A1FC-2F0E3E1CF1CF}"/>
+                <a16:creationId xmlns:a16="http://schemas.microsoft.com/office/drawing/2014/main" id="{67A9C256-17C6-4BEA-93E2-69DA7DF4842F}"/>
               </a:ext>
             </a:extLst>
           </p:cNvPr>
@@ -7310,7 +7310,7 @@
           <p:cNvPr id="21" name="">
             <a:extLst xmlns:a="http://schemas.openxmlformats.org/drawingml/2006/main">
               <a:ext uri="{FF2B5EF4-FFF2-40B4-BE49-F238E27FC236}">
-                <a16:creationId xmlns:a16="http://schemas.microsoft.com/office/drawing/2014/main" id="{2611F135-23A7-491C-8A14-522CA864FC2D}"/>
+                <a16:creationId xmlns:a16="http://schemas.microsoft.com/office/drawing/2014/main" id="{B52F0D5B-2C9A-4358-BFD5-733F2A2A6B5F}"/>
               </a:ext>
             </a:extLst>
           </p:cNvPr>
@@ -7394,7 +7394,7 @@
           <p:cNvPr id="22" name="">
             <a:extLst xmlns:a="http://schemas.openxmlformats.org/drawingml/2006/main">
               <a:ext uri="{FF2B5EF4-FFF2-40B4-BE49-F238E27FC236}">
-                <a16:creationId xmlns:a16="http://schemas.microsoft.com/office/drawing/2014/main" id="{A71735DF-7EFF-4445-9D38-841C089F6EEA}"/>
+                <a16:creationId xmlns:a16="http://schemas.microsoft.com/office/drawing/2014/main" id="{971FDBFD-7BDD-4C4D-A783-51C1A893F713}"/>
               </a:ext>
             </a:extLst>
           </p:cNvPr>
@@ -7427,7 +7427,7 @@
           <p:cNvPr id="23" name="">
             <a:extLst xmlns:a="http://schemas.openxmlformats.org/drawingml/2006/main">
               <a:ext uri="{FF2B5EF4-FFF2-40B4-BE49-F238E27FC236}">
-                <a16:creationId xmlns:a16="http://schemas.microsoft.com/office/drawing/2014/main" id="{7EFB43FA-388F-4EB4-90AC-300664085084}"/>
+                <a16:creationId xmlns:a16="http://schemas.microsoft.com/office/drawing/2014/main" id="{EC25629A-661E-4026-A2E5-5F643F07034E}"/>
               </a:ext>
             </a:extLst>
           </p:cNvPr>
@@ -7477,7 +7477,7 @@
           <p:cNvPr id="24" name="">
             <a:extLst xmlns:a="http://schemas.openxmlformats.org/drawingml/2006/main">
               <a:ext uri="{FF2B5EF4-FFF2-40B4-BE49-F238E27FC236}">
-                <a16:creationId xmlns:a16="http://schemas.microsoft.com/office/drawing/2014/main" id="{748331A7-CC9D-4186-9786-CC0706F8B32C}"/>
+                <a16:creationId xmlns:a16="http://schemas.microsoft.com/office/drawing/2014/main" id="{E0355346-7B98-4EB5-A2F8-517B36A2CCC0}"/>
               </a:ext>
             </a:extLst>
           </p:cNvPr>
@@ -7559,7 +7559,7 @@
     </p:spTree>
     <p:extLst>
       <p:ext uri="{BB962C8B-B14F-4D97-AF65-F5344CB8AC3E}">
-        <p14:creationId xmlns:p14="http://schemas.microsoft.com/office/powerpoint/2010/main" val="1487116126"/>
+        <p14:creationId xmlns:p14="http://schemas.microsoft.com/office/powerpoint/2010/main" val="664442651"/>
       </p:ext>
     </p:extLst>
   </p:cSld>
@@ -7590,7 +7590,7 @@
           <p:cNvPr id="1" name="">
             <a:extLst xmlns:a="http://schemas.openxmlformats.org/drawingml/2006/main">
               <a:ext uri="{FF2B5EF4-FFF2-40B4-BE49-F238E27FC236}">
-                <a16:creationId xmlns:a16="http://schemas.microsoft.com/office/drawing/2014/main" id="{5CF584CD-2981-41E9-8194-4F348003D587}"/>
+                <a16:creationId xmlns:a16="http://schemas.microsoft.com/office/drawing/2014/main" id="{46EFB433-BA6E-456E-A0D6-CF8E4D23757F}"/>
               </a:ext>
             </a:extLst>
           </p:cNvPr>
@@ -7621,7 +7621,7 @@
           <p:cNvPr id="2" name="">
             <a:extLst xmlns:a="http://schemas.openxmlformats.org/drawingml/2006/main">
               <a:ext uri="{FF2B5EF4-FFF2-40B4-BE49-F238E27FC236}">
-                <a16:creationId xmlns:a16="http://schemas.microsoft.com/office/drawing/2014/main" id="{5D6AC8FD-1846-4778-8833-0EF5FB2E035F}"/>
+                <a16:creationId xmlns:a16="http://schemas.microsoft.com/office/drawing/2014/main" id="{F1D922BD-26B3-43B9-8010-581C1393C13A}"/>
               </a:ext>
             </a:extLst>
           </p:cNvPr>
@@ -7671,7 +7671,7 @@
           <p:cNvPr id="3" name="">
             <a:extLst xmlns:a="http://schemas.openxmlformats.org/drawingml/2006/main">
               <a:ext uri="{FF2B5EF4-FFF2-40B4-BE49-F238E27FC236}">
-                <a16:creationId xmlns:a16="http://schemas.microsoft.com/office/drawing/2014/main" id="{9F5DA469-4522-4DDC-8DE0-B1B849EE882C}"/>
+                <a16:creationId xmlns:a16="http://schemas.microsoft.com/office/drawing/2014/main" id="{838D59E0-3A4E-4B82-8467-2EA10E6EBF7B}"/>
               </a:ext>
             </a:extLst>
           </p:cNvPr>
@@ -7738,7 +7738,7 @@
           <p:cNvPr id="4" name="">
             <a:extLst xmlns:a="http://schemas.openxmlformats.org/drawingml/2006/main">
               <a:ext uri="{FF2B5EF4-FFF2-40B4-BE49-F238E27FC236}">
-                <a16:creationId xmlns:a16="http://schemas.microsoft.com/office/drawing/2014/main" id="{AF550413-2215-44AA-B340-9B591CAF8729}"/>
+                <a16:creationId xmlns:a16="http://schemas.microsoft.com/office/drawing/2014/main" id="{88FE2665-9FEF-4733-B2BF-15B7C2F14B04}"/>
               </a:ext>
             </a:extLst>
           </p:cNvPr>
@@ -7769,7 +7769,7 @@
           <p:cNvPr id="5" name="">
             <a:extLst xmlns:a="http://schemas.openxmlformats.org/drawingml/2006/main">
               <a:ext uri="{FF2B5EF4-FFF2-40B4-BE49-F238E27FC236}">
-                <a16:creationId xmlns:a16="http://schemas.microsoft.com/office/drawing/2014/main" id="{E1068670-9070-4AEA-AC52-F354B7994B67}"/>
+                <a16:creationId xmlns:a16="http://schemas.microsoft.com/office/drawing/2014/main" id="{7483DF11-1312-4E03-BA12-A7F4557AA3CF}"/>
               </a:ext>
             </a:extLst>
           </p:cNvPr>
@@ -7819,7 +7819,7 @@
           <p:cNvPr id="6" name="">
             <a:extLst xmlns:a="http://schemas.openxmlformats.org/drawingml/2006/main">
               <a:ext uri="{FF2B5EF4-FFF2-40B4-BE49-F238E27FC236}">
-                <a16:creationId xmlns:a16="http://schemas.microsoft.com/office/drawing/2014/main" id="{87B7C5D2-D93B-4E1E-BCAE-4D5DA47F7E90}"/>
+                <a16:creationId xmlns:a16="http://schemas.microsoft.com/office/drawing/2014/main" id="{74C03F3A-5A87-420C-96EC-697E50A2D204}"/>
               </a:ext>
             </a:extLst>
           </p:cNvPr>
@@ -7869,7 +7869,7 @@
           <p:cNvPr id="7" name="">
             <a:extLst xmlns:a="http://schemas.openxmlformats.org/drawingml/2006/main">
               <a:ext uri="{FF2B5EF4-FFF2-40B4-BE49-F238E27FC236}">
-                <a16:creationId xmlns:a16="http://schemas.microsoft.com/office/drawing/2014/main" id="{E213AD67-BFC5-4544-A95E-391CCF42B19E}"/>
+                <a16:creationId xmlns:a16="http://schemas.microsoft.com/office/drawing/2014/main" id="{1533763E-D811-4892-84F5-0171AE22E47A}"/>
               </a:ext>
             </a:extLst>
           </p:cNvPr>
@@ -7919,7 +7919,7 @@
           <p:cNvPr id="8" name="">
             <a:extLst xmlns:a="http://schemas.openxmlformats.org/drawingml/2006/main">
               <a:ext uri="{FF2B5EF4-FFF2-40B4-BE49-F238E27FC236}">
-                <a16:creationId xmlns:a16="http://schemas.microsoft.com/office/drawing/2014/main" id="{A9F2AC52-60FC-47E3-ABBF-1C195DBFB0E4}"/>
+                <a16:creationId xmlns:a16="http://schemas.microsoft.com/office/drawing/2014/main" id="{897B7BAC-CCD2-4A20-9ED1-D805CCE41F11}"/>
               </a:ext>
             </a:extLst>
           </p:cNvPr>
@@ -7969,7 +7969,7 @@
           <p:cNvPr id="9" name="">
             <a:extLst xmlns:a="http://schemas.openxmlformats.org/drawingml/2006/main">
               <a:ext uri="{FF2B5EF4-FFF2-40B4-BE49-F238E27FC236}">
-                <a16:creationId xmlns:a16="http://schemas.microsoft.com/office/drawing/2014/main" id="{089573CE-1AF8-4063-8EC7-1E1E590F5B74}"/>
+                <a16:creationId xmlns:a16="http://schemas.microsoft.com/office/drawing/2014/main" id="{61DDCD92-8CFC-4321-A5FE-1D1255B4B70E}"/>
               </a:ext>
             </a:extLst>
           </p:cNvPr>
@@ -8002,7 +8002,7 @@
           <p:cNvPr id="10" name="">
             <a:extLst xmlns:a="http://schemas.openxmlformats.org/drawingml/2006/main">
               <a:ext uri="{FF2B5EF4-FFF2-40B4-BE49-F238E27FC236}">
-                <a16:creationId xmlns:a16="http://schemas.microsoft.com/office/drawing/2014/main" id="{38A91D53-182E-4712-AE0F-B981AD1CF7EF}"/>
+                <a16:creationId xmlns:a16="http://schemas.microsoft.com/office/drawing/2014/main" id="{D7062F35-D066-4CCF-8A5A-6660F88545BD}"/>
               </a:ext>
             </a:extLst>
           </p:cNvPr>
@@ -8052,7 +8052,7 @@
           <p:cNvPr id="11" name="">
             <a:extLst xmlns:a="http://schemas.openxmlformats.org/drawingml/2006/main">
               <a:ext uri="{FF2B5EF4-FFF2-40B4-BE49-F238E27FC236}">
-                <a16:creationId xmlns:a16="http://schemas.microsoft.com/office/drawing/2014/main" id="{A91133E5-1848-475D-8329-0E29ACF9DAB5}"/>
+                <a16:creationId xmlns:a16="http://schemas.microsoft.com/office/drawing/2014/main" id="{AE4E46AE-AC69-4065-A27C-E9788AA5D6E7}"/>
               </a:ext>
             </a:extLst>
           </p:cNvPr>
@@ -8170,7 +8170,7 @@
           <p:cNvPr id="12" name="">
             <a:extLst xmlns:a="http://schemas.openxmlformats.org/drawingml/2006/main">
               <a:ext uri="{FF2B5EF4-FFF2-40B4-BE49-F238E27FC236}">
-                <a16:creationId xmlns:a16="http://schemas.microsoft.com/office/drawing/2014/main" id="{B336285C-9574-4A68-9C17-5EC59C342586}"/>
+                <a16:creationId xmlns:a16="http://schemas.microsoft.com/office/drawing/2014/main" id="{DCF5B1B7-A763-4F55-8FDD-EDE3C97D2101}"/>
               </a:ext>
             </a:extLst>
           </p:cNvPr>
@@ -8218,7 +8218,7 @@
     </p:spTree>
     <p:extLst>
       <p:ext uri="{BB962C8B-B14F-4D97-AF65-F5344CB8AC3E}">
-        <p14:creationId xmlns:p14="http://schemas.microsoft.com/office/powerpoint/2010/main" val="1796498894"/>
+        <p14:creationId xmlns:p14="http://schemas.microsoft.com/office/powerpoint/2010/main" val="881363244"/>
       </p:ext>
     </p:extLst>
   </p:cSld>
@@ -8249,7 +8249,7 @@
           <p:cNvPr id="1" name="">
             <a:extLst xmlns:a="http://schemas.openxmlformats.org/drawingml/2006/main">
               <a:ext uri="{FF2B5EF4-FFF2-40B4-BE49-F238E27FC236}">
-                <a16:creationId xmlns:a16="http://schemas.microsoft.com/office/drawing/2014/main" id="{EE04E297-B5F2-4224-BA70-9BDB0AD2BC50}"/>
+                <a16:creationId xmlns:a16="http://schemas.microsoft.com/office/drawing/2014/main" id="{96F44FA7-21C1-4067-90D9-6B194F6FCD56}"/>
               </a:ext>
             </a:extLst>
           </p:cNvPr>
@@ -8280,7 +8280,7 @@
           <p:cNvPr id="2" name="">
             <a:extLst xmlns:a="http://schemas.openxmlformats.org/drawingml/2006/main">
               <a:ext uri="{FF2B5EF4-FFF2-40B4-BE49-F238E27FC236}">
-                <a16:creationId xmlns:a16="http://schemas.microsoft.com/office/drawing/2014/main" id="{EB7E6B22-EE64-4658-805F-A33F4788ADA8}"/>
+                <a16:creationId xmlns:a16="http://schemas.microsoft.com/office/drawing/2014/main" id="{93B0800E-778A-482E-8815-E9B3B597AA12}"/>
               </a:ext>
             </a:extLst>
           </p:cNvPr>
@@ -8330,7 +8330,7 @@
           <p:cNvPr id="3" name="">
             <a:extLst xmlns:a="http://schemas.openxmlformats.org/drawingml/2006/main">
               <a:ext uri="{FF2B5EF4-FFF2-40B4-BE49-F238E27FC236}">
-                <a16:creationId xmlns:a16="http://schemas.microsoft.com/office/drawing/2014/main" id="{F2594BB4-9BE8-43F4-AD96-F74A5949CAA9}"/>
+                <a16:creationId xmlns:a16="http://schemas.microsoft.com/office/drawing/2014/main" id="{494944D0-1354-4750-94FC-75C054F866E4}"/>
               </a:ext>
             </a:extLst>
           </p:cNvPr>
@@ -8380,7 +8380,7 @@
           <p:cNvPr id="4" name="">
             <a:extLst xmlns:a="http://schemas.openxmlformats.org/drawingml/2006/main">
               <a:ext uri="{FF2B5EF4-FFF2-40B4-BE49-F238E27FC236}">
-                <a16:creationId xmlns:a16="http://schemas.microsoft.com/office/drawing/2014/main" id="{E5F36C41-B614-4433-B671-B8C796C6ACC5}"/>
+                <a16:creationId xmlns:a16="http://schemas.microsoft.com/office/drawing/2014/main" id="{F2961401-8E2F-4F7E-A2C9-F066A037A6AC}"/>
               </a:ext>
             </a:extLst>
           </p:cNvPr>
@@ -8411,7 +8411,7 @@
           <p:cNvPr id="5" name="">
             <a:extLst xmlns:a="http://schemas.openxmlformats.org/drawingml/2006/main">
               <a:ext uri="{FF2B5EF4-FFF2-40B4-BE49-F238E27FC236}">
-                <a16:creationId xmlns:a16="http://schemas.microsoft.com/office/drawing/2014/main" id="{214F4FD8-90B5-4B42-A0DF-5512BB9D3266}"/>
+                <a16:creationId xmlns:a16="http://schemas.microsoft.com/office/drawing/2014/main" id="{8634F35D-4FC6-4F08-809E-3E294D916C45}"/>
               </a:ext>
             </a:extLst>
           </p:cNvPr>
@@ -8461,7 +8461,7 @@
           <p:cNvPr id="6" name="">
             <a:extLst xmlns:a="http://schemas.openxmlformats.org/drawingml/2006/main">
               <a:ext uri="{FF2B5EF4-FFF2-40B4-BE49-F238E27FC236}">
-                <a16:creationId xmlns:a16="http://schemas.microsoft.com/office/drawing/2014/main" id="{E6F38D45-6319-40F1-90AE-D79D3C7F7A15}"/>
+                <a16:creationId xmlns:a16="http://schemas.microsoft.com/office/drawing/2014/main" id="{44F72582-45EE-46F2-A565-B467BA34006F}"/>
               </a:ext>
             </a:extLst>
           </p:cNvPr>
@@ -8511,7 +8511,7 @@
           <p:cNvPr id="7" name="">
             <a:extLst xmlns:a="http://schemas.openxmlformats.org/drawingml/2006/main">
               <a:ext uri="{FF2B5EF4-FFF2-40B4-BE49-F238E27FC236}">
-                <a16:creationId xmlns:a16="http://schemas.microsoft.com/office/drawing/2014/main" id="{F919EF8B-8C70-4DDA-BBC7-31C5B119CC12}"/>
+                <a16:creationId xmlns:a16="http://schemas.microsoft.com/office/drawing/2014/main" id="{99CF85D7-613E-468F-99E8-5DD1D6516235}"/>
               </a:ext>
             </a:extLst>
           </p:cNvPr>
@@ -8561,7 +8561,7 @@
           <p:cNvPr id="8" name="">
             <a:extLst xmlns:a="http://schemas.openxmlformats.org/drawingml/2006/main">
               <a:ext uri="{FF2B5EF4-FFF2-40B4-BE49-F238E27FC236}">
-                <a16:creationId xmlns:a16="http://schemas.microsoft.com/office/drawing/2014/main" id="{2E8355A8-FE41-4072-BA5C-34ECBC550B66}"/>
+                <a16:creationId xmlns:a16="http://schemas.microsoft.com/office/drawing/2014/main" id="{42DDF6DD-DAA8-41A6-BE56-B40183B9EC76}"/>
               </a:ext>
             </a:extLst>
           </p:cNvPr>
@@ -8611,7 +8611,7 @@
           <p:cNvPr id="9" name="">
             <a:extLst xmlns:a="http://schemas.openxmlformats.org/drawingml/2006/main">
               <a:ext uri="{FF2B5EF4-FFF2-40B4-BE49-F238E27FC236}">
-                <a16:creationId xmlns:a16="http://schemas.microsoft.com/office/drawing/2014/main" id="{B179484B-CC6B-41AB-8F6D-D78905C8FB68}"/>
+                <a16:creationId xmlns:a16="http://schemas.microsoft.com/office/drawing/2014/main" id="{D31218F2-1E32-4C1D-B656-2B42EF5FC6EF}"/>
               </a:ext>
             </a:extLst>
           </p:cNvPr>
@@ -8642,7 +8642,7 @@
           <p:cNvPr id="10" name="">
             <a:extLst xmlns:a="http://schemas.openxmlformats.org/drawingml/2006/main">
               <a:ext uri="{FF2B5EF4-FFF2-40B4-BE49-F238E27FC236}">
-                <a16:creationId xmlns:a16="http://schemas.microsoft.com/office/drawing/2014/main" id="{325665E6-EDBA-49F3-BC35-40D0C7947719}"/>
+                <a16:creationId xmlns:a16="http://schemas.microsoft.com/office/drawing/2014/main" id="{38B18C6D-5F90-4EE5-9C88-93A8044CFB35}"/>
               </a:ext>
             </a:extLst>
           </p:cNvPr>
@@ -8675,7 +8675,7 @@
           <p:cNvPr id="11" name="">
             <a:extLst xmlns:a="http://schemas.openxmlformats.org/drawingml/2006/main">
               <a:ext uri="{FF2B5EF4-FFF2-40B4-BE49-F238E27FC236}">
-                <a16:creationId xmlns:a16="http://schemas.microsoft.com/office/drawing/2014/main" id="{B32F0658-CAD4-4F80-9914-50247CB1F483}"/>
+                <a16:creationId xmlns:a16="http://schemas.microsoft.com/office/drawing/2014/main" id="{385EE14D-5067-4019-A59C-EC2BB627BF63}"/>
               </a:ext>
             </a:extLst>
           </p:cNvPr>
@@ -8725,7 +8725,7 @@
           <p:cNvPr id="12" name="">
             <a:extLst xmlns:a="http://schemas.openxmlformats.org/drawingml/2006/main">
               <a:ext uri="{FF2B5EF4-FFF2-40B4-BE49-F238E27FC236}">
-                <a16:creationId xmlns:a16="http://schemas.microsoft.com/office/drawing/2014/main" id="{717E44D5-1DD0-45FF-AE20-2B35124930B0}"/>
+                <a16:creationId xmlns:a16="http://schemas.microsoft.com/office/drawing/2014/main" id="{6B27FFEB-A19E-4834-A9C7-DAEFD377D825}"/>
               </a:ext>
             </a:extLst>
           </p:cNvPr>
@@ -8809,7 +8809,7 @@
           <p:cNvPr id="13" name="">
             <a:extLst xmlns:a="http://schemas.openxmlformats.org/drawingml/2006/main">
               <a:ext uri="{FF2B5EF4-FFF2-40B4-BE49-F238E27FC236}">
-                <a16:creationId xmlns:a16="http://schemas.microsoft.com/office/drawing/2014/main" id="{D55E1F84-6A5C-494E-9179-B947E18079B1}"/>
+                <a16:creationId xmlns:a16="http://schemas.microsoft.com/office/drawing/2014/main" id="{E0676ECE-583F-4307-9C6C-0E5B1C486324}"/>
               </a:ext>
             </a:extLst>
           </p:cNvPr>
@@ -8842,7 +8842,7 @@
           <p:cNvPr id="14" name="">
             <a:extLst xmlns:a="http://schemas.openxmlformats.org/drawingml/2006/main">
               <a:ext uri="{FF2B5EF4-FFF2-40B4-BE49-F238E27FC236}">
-                <a16:creationId xmlns:a16="http://schemas.microsoft.com/office/drawing/2014/main" id="{8B73AAD6-30ED-4EE6-A724-105E3F681CCC}"/>
+                <a16:creationId xmlns:a16="http://schemas.microsoft.com/office/drawing/2014/main" id="{AB468E9C-A46F-493B-84D1-25D63465A070}"/>
               </a:ext>
             </a:extLst>
           </p:cNvPr>
@@ -8892,7 +8892,7 @@
           <p:cNvPr id="15" name="">
             <a:extLst xmlns:a="http://schemas.openxmlformats.org/drawingml/2006/main">
               <a:ext uri="{FF2B5EF4-FFF2-40B4-BE49-F238E27FC236}">
-                <a16:creationId xmlns:a16="http://schemas.microsoft.com/office/drawing/2014/main" id="{B3AC031D-B291-4915-AF96-43DF170ECD1A}"/>
+                <a16:creationId xmlns:a16="http://schemas.microsoft.com/office/drawing/2014/main" id="{CE20E167-1638-4D82-9316-48BE8D1EC562}"/>
               </a:ext>
             </a:extLst>
           </p:cNvPr>
@@ -8991,7 +8991,7 @@
     </p:spTree>
     <p:extLst>
       <p:ext uri="{BB962C8B-B14F-4D97-AF65-F5344CB8AC3E}">
-        <p14:creationId xmlns:p14="http://schemas.microsoft.com/office/powerpoint/2010/main" val="1080517263"/>
+        <p14:creationId xmlns:p14="http://schemas.microsoft.com/office/powerpoint/2010/main" val="308646174"/>
       </p:ext>
     </p:extLst>
   </p:cSld>
@@ -9022,7 +9022,7 @@
           <p:cNvPr id="1" name="">
             <a:extLst xmlns:a="http://schemas.openxmlformats.org/drawingml/2006/main">
               <a:ext uri="{FF2B5EF4-FFF2-40B4-BE49-F238E27FC236}">
-                <a16:creationId xmlns:a16="http://schemas.microsoft.com/office/drawing/2014/main" id="{288F7D6D-8174-4DD3-A294-4ACA79BC4EC5}"/>
+                <a16:creationId xmlns:a16="http://schemas.microsoft.com/office/drawing/2014/main" id="{95882008-B601-4399-A577-3F3AAA4CDEAB}"/>
               </a:ext>
             </a:extLst>
           </p:cNvPr>
@@ -9053,7 +9053,7 @@
           <p:cNvPr id="2" name="">
             <a:extLst xmlns:a="http://schemas.openxmlformats.org/drawingml/2006/main">
               <a:ext uri="{FF2B5EF4-FFF2-40B4-BE49-F238E27FC236}">
-                <a16:creationId xmlns:a16="http://schemas.microsoft.com/office/drawing/2014/main" id="{6148DBA0-1C3F-469C-A4E3-8507C437DDD4}"/>
+                <a16:creationId xmlns:a16="http://schemas.microsoft.com/office/drawing/2014/main" id="{DECF4E4D-8F04-4156-BBC3-67BBE72F4049}"/>
               </a:ext>
             </a:extLst>
           </p:cNvPr>
@@ -9103,7 +9103,7 @@
           <p:cNvPr id="3" name="">
             <a:extLst xmlns:a="http://schemas.openxmlformats.org/drawingml/2006/main">
               <a:ext uri="{FF2B5EF4-FFF2-40B4-BE49-F238E27FC236}">
-                <a16:creationId xmlns:a16="http://schemas.microsoft.com/office/drawing/2014/main" id="{8D00E6CB-9C22-4521-9D16-EEDC743C894E}"/>
+                <a16:creationId xmlns:a16="http://schemas.microsoft.com/office/drawing/2014/main" id="{1F73DBAB-B10A-461D-9AC8-256F2818F98B}"/>
               </a:ext>
             </a:extLst>
           </p:cNvPr>
@@ -9153,7 +9153,7 @@
           <p:cNvPr id="4" name="">
             <a:extLst xmlns:a="http://schemas.openxmlformats.org/drawingml/2006/main">
               <a:ext uri="{FF2B5EF4-FFF2-40B4-BE49-F238E27FC236}">
-                <a16:creationId xmlns:a16="http://schemas.microsoft.com/office/drawing/2014/main" id="{352CA8C4-C7F3-4E19-9920-125F5A36B283}"/>
+                <a16:creationId xmlns:a16="http://schemas.microsoft.com/office/drawing/2014/main" id="{5D043F3B-5361-4612-82D5-77043139C4EA}"/>
               </a:ext>
             </a:extLst>
           </p:cNvPr>
@@ -9184,7 +9184,7 @@
           <p:cNvPr id="5" name="">
             <a:extLst xmlns:a="http://schemas.openxmlformats.org/drawingml/2006/main">
               <a:ext uri="{FF2B5EF4-FFF2-40B4-BE49-F238E27FC236}">
-                <a16:creationId xmlns:a16="http://schemas.microsoft.com/office/drawing/2014/main" id="{EC0D8D59-E1EE-4293-8E1B-34DEB45CF457}"/>
+                <a16:creationId xmlns:a16="http://schemas.microsoft.com/office/drawing/2014/main" id="{E74E7DA6-7C29-48C2-B26B-A9FB5920D01D}"/>
               </a:ext>
             </a:extLst>
           </p:cNvPr>
@@ -9234,7 +9234,7 @@
           <p:cNvPr id="6" name="">
             <a:extLst xmlns:a="http://schemas.openxmlformats.org/drawingml/2006/main">
               <a:ext uri="{FF2B5EF4-FFF2-40B4-BE49-F238E27FC236}">
-                <a16:creationId xmlns:a16="http://schemas.microsoft.com/office/drawing/2014/main" id="{5AAA39E1-2B6A-47DC-8836-FBE4F947B660}"/>
+                <a16:creationId xmlns:a16="http://schemas.microsoft.com/office/drawing/2014/main" id="{29E91D04-EF92-459D-B720-23300793B545}"/>
               </a:ext>
             </a:extLst>
           </p:cNvPr>
@@ -9284,7 +9284,7 @@
           <p:cNvPr id="7" name="">
             <a:extLst xmlns:a="http://schemas.openxmlformats.org/drawingml/2006/main">
               <a:ext uri="{FF2B5EF4-FFF2-40B4-BE49-F238E27FC236}">
-                <a16:creationId xmlns:a16="http://schemas.microsoft.com/office/drawing/2014/main" id="{4A3EB94B-2770-4000-A64C-8A853531DB5B}"/>
+                <a16:creationId xmlns:a16="http://schemas.microsoft.com/office/drawing/2014/main" id="{D5FFCFBB-3BC2-4447-9D2C-498BDCFFFD0F}"/>
               </a:ext>
             </a:extLst>
           </p:cNvPr>
@@ -9334,7 +9334,7 @@
           <p:cNvPr id="8" name="">
             <a:extLst xmlns:a="http://schemas.openxmlformats.org/drawingml/2006/main">
               <a:ext uri="{FF2B5EF4-FFF2-40B4-BE49-F238E27FC236}">
-                <a16:creationId xmlns:a16="http://schemas.microsoft.com/office/drawing/2014/main" id="{B9AA2260-3E94-4717-8C6A-276D9B41BA23}"/>
+                <a16:creationId xmlns:a16="http://schemas.microsoft.com/office/drawing/2014/main" id="{43B1CD58-2A99-4147-909E-5EB04E30F7F4}"/>
               </a:ext>
             </a:extLst>
           </p:cNvPr>
@@ -9384,7 +9384,7 @@
           <p:cNvPr id="9" name="">
             <a:extLst xmlns:a="http://schemas.openxmlformats.org/drawingml/2006/main">
               <a:ext uri="{FF2B5EF4-FFF2-40B4-BE49-F238E27FC236}">
-                <a16:creationId xmlns:a16="http://schemas.microsoft.com/office/drawing/2014/main" id="{3D020375-51F3-436B-9859-777F07B3848B}"/>
+                <a16:creationId xmlns:a16="http://schemas.microsoft.com/office/drawing/2014/main" id="{7F3C1644-B48E-40F8-A7D3-81A32DD7939E}"/>
               </a:ext>
             </a:extLst>
           </p:cNvPr>
@@ -9415,7 +9415,7 @@
           <p:cNvPr id="10" name="">
             <a:extLst xmlns:a="http://schemas.openxmlformats.org/drawingml/2006/main">
               <a:ext uri="{FF2B5EF4-FFF2-40B4-BE49-F238E27FC236}">
-                <a16:creationId xmlns:a16="http://schemas.microsoft.com/office/drawing/2014/main" id="{5458C606-FE2B-4F4F-B8FD-61E63B9E03D5}"/>
+                <a16:creationId xmlns:a16="http://schemas.microsoft.com/office/drawing/2014/main" id="{6E9C600A-B913-4148-8583-073114B07C1F}"/>
               </a:ext>
             </a:extLst>
           </p:cNvPr>
@@ -9465,7 +9465,7 @@
           <p:cNvPr id="11" name="">
             <a:extLst xmlns:a="http://schemas.openxmlformats.org/drawingml/2006/main">
               <a:ext uri="{FF2B5EF4-FFF2-40B4-BE49-F238E27FC236}">
-                <a16:creationId xmlns:a16="http://schemas.microsoft.com/office/drawing/2014/main" id="{D5EBEDE5-7221-4292-A44E-B65189022389}"/>
+                <a16:creationId xmlns:a16="http://schemas.microsoft.com/office/drawing/2014/main" id="{10944D9D-39E5-42D4-AE5D-BAD7BCC097BE}"/>
               </a:ext>
             </a:extLst>
           </p:cNvPr>
@@ -9515,7 +9515,7 @@
           <p:cNvPr id="12" name="">
             <a:extLst xmlns:a="http://schemas.openxmlformats.org/drawingml/2006/main">
               <a:ext uri="{FF2B5EF4-FFF2-40B4-BE49-F238E27FC236}">
-                <a16:creationId xmlns:a16="http://schemas.microsoft.com/office/drawing/2014/main" id="{AC834804-3A77-4A17-8570-397B67711502}"/>
+                <a16:creationId xmlns:a16="http://schemas.microsoft.com/office/drawing/2014/main" id="{B21BF340-B028-400C-9283-A529139B6F0E}"/>
               </a:ext>
             </a:extLst>
           </p:cNvPr>
@@ -9546,7 +9546,7 @@
           <p:cNvPr id="13" name="">
             <a:extLst xmlns:a="http://schemas.openxmlformats.org/drawingml/2006/main">
               <a:ext uri="{FF2B5EF4-FFF2-40B4-BE49-F238E27FC236}">
-                <a16:creationId xmlns:a16="http://schemas.microsoft.com/office/drawing/2014/main" id="{B307FCB2-1C7F-460D-A269-B373658CBDCF}"/>
+                <a16:creationId xmlns:a16="http://schemas.microsoft.com/office/drawing/2014/main" id="{0A7B7C74-A42D-4137-BF62-482381E5F044}"/>
               </a:ext>
             </a:extLst>
           </p:cNvPr>
@@ -9596,7 +9596,7 @@
           <p:cNvPr id="14" name="">
             <a:extLst xmlns:a="http://schemas.openxmlformats.org/drawingml/2006/main">
               <a:ext uri="{FF2B5EF4-FFF2-40B4-BE49-F238E27FC236}">
-                <a16:creationId xmlns:a16="http://schemas.microsoft.com/office/drawing/2014/main" id="{48A08F29-E17F-4FCB-8A40-93CCCB10F046}"/>
+                <a16:creationId xmlns:a16="http://schemas.microsoft.com/office/drawing/2014/main" id="{A45D29FB-319B-449B-B022-2E67F23284A0}"/>
               </a:ext>
             </a:extLst>
           </p:cNvPr>
@@ -9646,7 +9646,7 @@
           <p:cNvPr id="15" name="">
             <a:extLst xmlns:a="http://schemas.openxmlformats.org/drawingml/2006/main">
               <a:ext uri="{FF2B5EF4-FFF2-40B4-BE49-F238E27FC236}">
-                <a16:creationId xmlns:a16="http://schemas.microsoft.com/office/drawing/2014/main" id="{64D6E541-BF08-4B4B-828E-597E6A8E7FFB}"/>
+                <a16:creationId xmlns:a16="http://schemas.microsoft.com/office/drawing/2014/main" id="{A58A4F90-20BD-4A5A-A79F-1854BA4F6F9D}"/>
               </a:ext>
             </a:extLst>
           </p:cNvPr>
@@ -9677,7 +9677,7 @@
           <p:cNvPr id="16" name="">
             <a:extLst xmlns:a="http://schemas.openxmlformats.org/drawingml/2006/main">
               <a:ext uri="{FF2B5EF4-FFF2-40B4-BE49-F238E27FC236}">
-                <a16:creationId xmlns:a16="http://schemas.microsoft.com/office/drawing/2014/main" id="{0590EE1C-C878-4A19-957F-2AC44E1EB9CA}"/>
+                <a16:creationId xmlns:a16="http://schemas.microsoft.com/office/drawing/2014/main" id="{C23B3EF2-EDCA-4806-97CA-54D924CF870C}"/>
               </a:ext>
             </a:extLst>
           </p:cNvPr>
@@ -9727,7 +9727,7 @@
           <p:cNvPr id="17" name="">
             <a:extLst xmlns:a="http://schemas.openxmlformats.org/drawingml/2006/main">
               <a:ext uri="{FF2B5EF4-FFF2-40B4-BE49-F238E27FC236}">
-                <a16:creationId xmlns:a16="http://schemas.microsoft.com/office/drawing/2014/main" id="{C92141B1-AD7B-4D0B-A911-3C058749CF52}"/>
+                <a16:creationId xmlns:a16="http://schemas.microsoft.com/office/drawing/2014/main" id="{789185D9-47BA-4674-B5F7-039086F87ACC}"/>
               </a:ext>
             </a:extLst>
           </p:cNvPr>
@@ -9777,7 +9777,7 @@
           <p:cNvPr id="18" name="">
             <a:extLst xmlns:a="http://schemas.openxmlformats.org/drawingml/2006/main">
               <a:ext uri="{FF2B5EF4-FFF2-40B4-BE49-F238E27FC236}">
-                <a16:creationId xmlns:a16="http://schemas.microsoft.com/office/drawing/2014/main" id="{BA423953-0D1E-40EB-BC7C-A012B66B08CA}"/>
+                <a16:creationId xmlns:a16="http://schemas.microsoft.com/office/drawing/2014/main" id="{C8A68904-B51F-4BC4-B905-6A9C65B1342A}"/>
               </a:ext>
             </a:extLst>
           </p:cNvPr>
@@ -9808,7 +9808,7 @@
           <p:cNvPr id="19" name="">
             <a:extLst xmlns:a="http://schemas.openxmlformats.org/drawingml/2006/main">
               <a:ext uri="{FF2B5EF4-FFF2-40B4-BE49-F238E27FC236}">
-                <a16:creationId xmlns:a16="http://schemas.microsoft.com/office/drawing/2014/main" id="{FA5E6163-D347-4580-99F9-F8E204B0864C}"/>
+                <a16:creationId xmlns:a16="http://schemas.microsoft.com/office/drawing/2014/main" id="{3353B409-A50E-472D-8BFA-866FA8FDCB5A}"/>
               </a:ext>
             </a:extLst>
           </p:cNvPr>
@@ -9858,7 +9858,7 @@
           <p:cNvPr id="20" name="">
             <a:extLst xmlns:a="http://schemas.openxmlformats.org/drawingml/2006/main">
               <a:ext uri="{FF2B5EF4-FFF2-40B4-BE49-F238E27FC236}">
-                <a16:creationId xmlns:a16="http://schemas.microsoft.com/office/drawing/2014/main" id="{A441A5E1-AB0A-4D1A-993F-87DAF4487FF2}"/>
+                <a16:creationId xmlns:a16="http://schemas.microsoft.com/office/drawing/2014/main" id="{4F1C0007-D5AC-4587-A892-F5466103276D}"/>
               </a:ext>
             </a:extLst>
           </p:cNvPr>
@@ -9908,7 +9908,7 @@
           <p:cNvPr id="21" name="">
             <a:extLst xmlns:a="http://schemas.openxmlformats.org/drawingml/2006/main">
               <a:ext uri="{FF2B5EF4-FFF2-40B4-BE49-F238E27FC236}">
-                <a16:creationId xmlns:a16="http://schemas.microsoft.com/office/drawing/2014/main" id="{D626D67F-C8F9-4C21-95DB-D62736CA066E}"/>
+                <a16:creationId xmlns:a16="http://schemas.microsoft.com/office/drawing/2014/main" id="{8E4C69EA-995B-4A3F-85F7-5F63C5780CCB}"/>
               </a:ext>
             </a:extLst>
           </p:cNvPr>
@@ -9939,7 +9939,7 @@
           <p:cNvPr id="22" name="">
             <a:extLst xmlns:a="http://schemas.openxmlformats.org/drawingml/2006/main">
               <a:ext uri="{FF2B5EF4-FFF2-40B4-BE49-F238E27FC236}">
-                <a16:creationId xmlns:a16="http://schemas.microsoft.com/office/drawing/2014/main" id="{B330A989-E4DF-4407-A011-D594029BBD55}"/>
+                <a16:creationId xmlns:a16="http://schemas.microsoft.com/office/drawing/2014/main" id="{AE13EE68-C3AE-4A0F-BD98-40B21F53C204}"/>
               </a:ext>
             </a:extLst>
           </p:cNvPr>
@@ -9989,7 +9989,7 @@
           <p:cNvPr id="23" name="">
             <a:extLst xmlns:a="http://schemas.openxmlformats.org/drawingml/2006/main">
               <a:ext uri="{FF2B5EF4-FFF2-40B4-BE49-F238E27FC236}">
-                <a16:creationId xmlns:a16="http://schemas.microsoft.com/office/drawing/2014/main" id="{3D2E2302-F6BA-432F-8339-277EE47F973A}"/>
+                <a16:creationId xmlns:a16="http://schemas.microsoft.com/office/drawing/2014/main" id="{CE79DC81-B6D9-4C8A-913F-4F5EE1DF3E6A}"/>
               </a:ext>
             </a:extLst>
           </p:cNvPr>
@@ -10039,7 +10039,7 @@
           <p:cNvPr id="24" name="">
             <a:extLst xmlns:a="http://schemas.openxmlformats.org/drawingml/2006/main">
               <a:ext uri="{FF2B5EF4-FFF2-40B4-BE49-F238E27FC236}">
-                <a16:creationId xmlns:a16="http://schemas.microsoft.com/office/drawing/2014/main" id="{E65D6593-CABD-4F82-B2A5-1B1F9FED3BAE}"/>
+                <a16:creationId xmlns:a16="http://schemas.microsoft.com/office/drawing/2014/main" id="{F80C8E3E-2275-444D-A2A7-8E567FE3E283}"/>
               </a:ext>
             </a:extLst>
           </p:cNvPr>
@@ -10068,7 +10068,7 @@
     </p:spTree>
     <p:extLst>
       <p:ext uri="{BB962C8B-B14F-4D97-AF65-F5344CB8AC3E}">
-        <p14:creationId xmlns:p14="http://schemas.microsoft.com/office/powerpoint/2010/main" val="614469403"/>
+        <p14:creationId xmlns:p14="http://schemas.microsoft.com/office/powerpoint/2010/main" val="494886340"/>
       </p:ext>
     </p:extLst>
   </p:cSld>
@@ -10099,7 +10099,7 @@
           <p:cNvPr id="1" name="">
             <a:extLst xmlns:a="http://schemas.openxmlformats.org/drawingml/2006/main">
               <a:ext uri="{FF2B5EF4-FFF2-40B4-BE49-F238E27FC236}">
-                <a16:creationId xmlns:a16="http://schemas.microsoft.com/office/drawing/2014/main" id="{A97CACAE-405D-4B42-A6FA-B5ACCB3202CA}"/>
+                <a16:creationId xmlns:a16="http://schemas.microsoft.com/office/drawing/2014/main" id="{9CED286B-8981-4AC8-BCE2-5A3D4949E454}"/>
               </a:ext>
             </a:extLst>
           </p:cNvPr>
@@ -10130,7 +10130,7 @@
           <p:cNvPr id="2" name="">
             <a:extLst xmlns:a="http://schemas.openxmlformats.org/drawingml/2006/main">
               <a:ext uri="{FF2B5EF4-FFF2-40B4-BE49-F238E27FC236}">
-                <a16:creationId xmlns:a16="http://schemas.microsoft.com/office/drawing/2014/main" id="{769A3F4A-1520-44D1-A302-71C51E4C13FE}"/>
+                <a16:creationId xmlns:a16="http://schemas.microsoft.com/office/drawing/2014/main" id="{A8136813-C348-4D09-A646-8043BCE2DF01}"/>
               </a:ext>
             </a:extLst>
           </p:cNvPr>
@@ -10180,7 +10180,7 @@
           <p:cNvPr id="3" name="">
             <a:extLst xmlns:a="http://schemas.openxmlformats.org/drawingml/2006/main">
               <a:ext uri="{FF2B5EF4-FFF2-40B4-BE49-F238E27FC236}">
-                <a16:creationId xmlns:a16="http://schemas.microsoft.com/office/drawing/2014/main" id="{4A9E8E5A-301F-4645-9C63-AAB8D1580DAA}"/>
+                <a16:creationId xmlns:a16="http://schemas.microsoft.com/office/drawing/2014/main" id="{2A1F32CF-C8F3-491A-8AD5-48D8D4E5B5F0}"/>
               </a:ext>
             </a:extLst>
           </p:cNvPr>
@@ -10230,7 +10230,7 @@
           <p:cNvPr id="4" name="">
             <a:extLst xmlns:a="http://schemas.openxmlformats.org/drawingml/2006/main">
               <a:ext uri="{FF2B5EF4-FFF2-40B4-BE49-F238E27FC236}">
-                <a16:creationId xmlns:a16="http://schemas.microsoft.com/office/drawing/2014/main" id="{23C2739C-2B8C-4E35-9BC0-E8ACA5A99094}"/>
+                <a16:creationId xmlns:a16="http://schemas.microsoft.com/office/drawing/2014/main" id="{5390D782-1650-42CC-ACEC-A61389E6268A}"/>
               </a:ext>
             </a:extLst>
           </p:cNvPr>
@@ -10261,7 +10261,7 @@
           <p:cNvPr id="5" name="">
             <a:extLst xmlns:a="http://schemas.openxmlformats.org/drawingml/2006/main">
               <a:ext uri="{FF2B5EF4-FFF2-40B4-BE49-F238E27FC236}">
-                <a16:creationId xmlns:a16="http://schemas.microsoft.com/office/drawing/2014/main" id="{F08BE4B5-027D-404C-97C5-34C7B41B9151}"/>
+                <a16:creationId xmlns:a16="http://schemas.microsoft.com/office/drawing/2014/main" id="{36A706DB-29AE-46D0-AEBD-81105F87BCD7}"/>
               </a:ext>
             </a:extLst>
           </p:cNvPr>
@@ -10311,7 +10311,7 @@
           <p:cNvPr id="6" name="">
             <a:extLst xmlns:a="http://schemas.openxmlformats.org/drawingml/2006/main">
               <a:ext uri="{FF2B5EF4-FFF2-40B4-BE49-F238E27FC236}">
-                <a16:creationId xmlns:a16="http://schemas.microsoft.com/office/drawing/2014/main" id="{EDD2D7D3-C4AC-4454-8B95-E3845BB7C3DF}"/>
+                <a16:creationId xmlns:a16="http://schemas.microsoft.com/office/drawing/2014/main" id="{9BE16415-4F43-431B-9A33-018D93FB660E}"/>
               </a:ext>
             </a:extLst>
           </p:cNvPr>
@@ -10361,7 +10361,7 @@
           <p:cNvPr id="7" name="">
             <a:extLst xmlns:a="http://schemas.openxmlformats.org/drawingml/2006/main">
               <a:ext uri="{FF2B5EF4-FFF2-40B4-BE49-F238E27FC236}">
-                <a16:creationId xmlns:a16="http://schemas.microsoft.com/office/drawing/2014/main" id="{E5DDA724-11F1-4CA9-831F-3BE2822A1508}"/>
+                <a16:creationId xmlns:a16="http://schemas.microsoft.com/office/drawing/2014/main" id="{42934F85-66B4-4DD9-8DCE-5DC36F70D8D4}"/>
               </a:ext>
             </a:extLst>
           </p:cNvPr>
@@ -10411,7 +10411,7 @@
           <p:cNvPr id="8" name="">
             <a:extLst xmlns:a="http://schemas.openxmlformats.org/drawingml/2006/main">
               <a:ext uri="{FF2B5EF4-FFF2-40B4-BE49-F238E27FC236}">
-                <a16:creationId xmlns:a16="http://schemas.microsoft.com/office/drawing/2014/main" id="{8E67850E-4A31-4A9F-86D4-DF3023426A37}"/>
+                <a16:creationId xmlns:a16="http://schemas.microsoft.com/office/drawing/2014/main" id="{40266D0E-3C9C-4389-9591-1FA79E84926D}"/>
               </a:ext>
             </a:extLst>
           </p:cNvPr>
@@ -10461,7 +10461,7 @@
           <p:cNvPr id="9" name="">
             <a:extLst xmlns:a="http://schemas.openxmlformats.org/drawingml/2006/main">
               <a:ext uri="{FF2B5EF4-FFF2-40B4-BE49-F238E27FC236}">
-                <a16:creationId xmlns:a16="http://schemas.microsoft.com/office/drawing/2014/main" id="{5B6194AB-C35E-4438-BCDE-F25610534B6A}"/>
+                <a16:creationId xmlns:a16="http://schemas.microsoft.com/office/drawing/2014/main" id="{91F9497A-ACE7-4B8A-B778-334AABAEE05A}"/>
               </a:ext>
             </a:extLst>
           </p:cNvPr>
@@ -10492,7 +10492,7 @@
           <p:cNvPr id="10" name="">
             <a:extLst xmlns:a="http://schemas.openxmlformats.org/drawingml/2006/main">
               <a:ext uri="{FF2B5EF4-FFF2-40B4-BE49-F238E27FC236}">
-                <a16:creationId xmlns:a16="http://schemas.microsoft.com/office/drawing/2014/main" id="{CE7ADAC7-5F80-4634-8A33-913BD8E0F4E8}"/>
+                <a16:creationId xmlns:a16="http://schemas.microsoft.com/office/drawing/2014/main" id="{2C4A1A2F-AA6F-4C85-B775-9BD268E11012}"/>
               </a:ext>
             </a:extLst>
           </p:cNvPr>
@@ -10525,7 +10525,7 @@
           <p:cNvPr id="11" name="">
             <a:extLst xmlns:a="http://schemas.openxmlformats.org/drawingml/2006/main">
               <a:ext uri="{FF2B5EF4-FFF2-40B4-BE49-F238E27FC236}">
-                <a16:creationId xmlns:a16="http://schemas.microsoft.com/office/drawing/2014/main" id="{BF8F0319-9568-4C56-B990-1980CF242D38}"/>
+                <a16:creationId xmlns:a16="http://schemas.microsoft.com/office/drawing/2014/main" id="{E5872D5C-332C-455F-84FE-C535D606619E}"/>
               </a:ext>
             </a:extLst>
           </p:cNvPr>
@@ -10575,7 +10575,7 @@
           <p:cNvPr id="12" name="">
             <a:extLst xmlns:a="http://schemas.openxmlformats.org/drawingml/2006/main">
               <a:ext uri="{FF2B5EF4-FFF2-40B4-BE49-F238E27FC236}">
-                <a16:creationId xmlns:a16="http://schemas.microsoft.com/office/drawing/2014/main" id="{A55BAE28-7811-4CC9-87B0-8C7CD467219C}"/>
+                <a16:creationId xmlns:a16="http://schemas.microsoft.com/office/drawing/2014/main" id="{3D2F0478-2668-4662-A619-371DAB1DF16B}"/>
               </a:ext>
             </a:extLst>
           </p:cNvPr>
@@ -10625,7 +10625,7 @@
           <p:cNvPr id="13" name="">
             <a:extLst xmlns:a="http://schemas.openxmlformats.org/drawingml/2006/main">
               <a:ext uri="{FF2B5EF4-FFF2-40B4-BE49-F238E27FC236}">
-                <a16:creationId xmlns:a16="http://schemas.microsoft.com/office/drawing/2014/main" id="{99219B6B-8D08-4E7B-A012-FD7FDB6A2529}"/>
+                <a16:creationId xmlns:a16="http://schemas.microsoft.com/office/drawing/2014/main" id="{D547EEE9-1B57-46EC-AD5F-9F78A4F0056C}"/>
               </a:ext>
             </a:extLst>
           </p:cNvPr>
@@ -10658,7 +10658,7 @@
           <p:cNvPr id="14" name="">
             <a:extLst xmlns:a="http://schemas.openxmlformats.org/drawingml/2006/main">
               <a:ext uri="{FF2B5EF4-FFF2-40B4-BE49-F238E27FC236}">
-                <a16:creationId xmlns:a16="http://schemas.microsoft.com/office/drawing/2014/main" id="{3A3FAF6A-5A52-4098-8E3E-80A54C68BDB7}"/>
+                <a16:creationId xmlns:a16="http://schemas.microsoft.com/office/drawing/2014/main" id="{AC28A92F-8F67-483A-8FC1-959663ECA363}"/>
               </a:ext>
             </a:extLst>
           </p:cNvPr>
@@ -10708,7 +10708,7 @@
           <p:cNvPr id="15" name="">
             <a:extLst xmlns:a="http://schemas.openxmlformats.org/drawingml/2006/main">
               <a:ext uri="{FF2B5EF4-FFF2-40B4-BE49-F238E27FC236}">
-                <a16:creationId xmlns:a16="http://schemas.microsoft.com/office/drawing/2014/main" id="{5D169482-3E82-4294-9780-7747FFBAB777}"/>
+                <a16:creationId xmlns:a16="http://schemas.microsoft.com/office/drawing/2014/main" id="{1F641F16-7A43-4C52-AC8D-A602F3871DE4}"/>
               </a:ext>
             </a:extLst>
           </p:cNvPr>
@@ -10758,7 +10758,7 @@
           <p:cNvPr id="16" name="">
             <a:extLst xmlns:a="http://schemas.openxmlformats.org/drawingml/2006/main">
               <a:ext uri="{FF2B5EF4-FFF2-40B4-BE49-F238E27FC236}">
-                <a16:creationId xmlns:a16="http://schemas.microsoft.com/office/drawing/2014/main" id="{30C694DC-E915-4A76-B835-9EEE3C0E169E}"/>
+                <a16:creationId xmlns:a16="http://schemas.microsoft.com/office/drawing/2014/main" id="{8734981B-98BF-4854-9850-180C49A91DD2}"/>
               </a:ext>
             </a:extLst>
           </p:cNvPr>
@@ -10808,7 +10808,7 @@
           <p:cNvPr id="17" name="">
             <a:extLst xmlns:a="http://schemas.openxmlformats.org/drawingml/2006/main">
               <a:ext uri="{FF2B5EF4-FFF2-40B4-BE49-F238E27FC236}">
-                <a16:creationId xmlns:a16="http://schemas.microsoft.com/office/drawing/2014/main" id="{CB816FF5-8016-4A55-B394-2FA587581D4D}"/>
+                <a16:creationId xmlns:a16="http://schemas.microsoft.com/office/drawing/2014/main" id="{CCBFEDA0-A07B-4D25-9DB8-175B4984E4E6}"/>
               </a:ext>
             </a:extLst>
           </p:cNvPr>
@@ -10856,7 +10856,7 @@
     </p:spTree>
     <p:extLst>
       <p:ext uri="{BB962C8B-B14F-4D97-AF65-F5344CB8AC3E}">
-        <p14:creationId xmlns:p14="http://schemas.microsoft.com/office/powerpoint/2010/main" val="215196880"/>
+        <p14:creationId xmlns:p14="http://schemas.microsoft.com/office/powerpoint/2010/main" val="715002186"/>
       </p:ext>
     </p:extLst>
   </p:cSld>
@@ -10887,7 +10887,7 @@
           <p:cNvPr id="1" name="">
             <a:extLst xmlns:a="http://schemas.openxmlformats.org/drawingml/2006/main">
               <a:ext uri="{FF2B5EF4-FFF2-40B4-BE49-F238E27FC236}">
-                <a16:creationId xmlns:a16="http://schemas.microsoft.com/office/drawing/2014/main" id="{214760A7-C7EC-4834-B8F3-3A71FC089E3E}"/>
+                <a16:creationId xmlns:a16="http://schemas.microsoft.com/office/drawing/2014/main" id="{D672FC63-8F5A-4736-B7FD-55A4563D8C7E}"/>
               </a:ext>
             </a:extLst>
           </p:cNvPr>
@@ -10918,7 +10918,7 @@
           <p:cNvPr id="2" name="">
             <a:extLst xmlns:a="http://schemas.openxmlformats.org/drawingml/2006/main">
               <a:ext uri="{FF2B5EF4-FFF2-40B4-BE49-F238E27FC236}">
-                <a16:creationId xmlns:a16="http://schemas.microsoft.com/office/drawing/2014/main" id="{C74727AE-EDCC-48A8-8F66-FCA90798D81C}"/>
+                <a16:creationId xmlns:a16="http://schemas.microsoft.com/office/drawing/2014/main" id="{80CE48D2-6B95-4E02-ACD9-5D07463444B6}"/>
               </a:ext>
             </a:extLst>
           </p:cNvPr>
@@ -10968,7 +10968,7 @@
           <p:cNvPr id="3" name="">
             <a:extLst xmlns:a="http://schemas.openxmlformats.org/drawingml/2006/main">
               <a:ext uri="{FF2B5EF4-FFF2-40B4-BE49-F238E27FC236}">
-                <a16:creationId xmlns:a16="http://schemas.microsoft.com/office/drawing/2014/main" id="{172CEC89-CD73-4A55-979B-CD401E1AE9EE}"/>
+                <a16:creationId xmlns:a16="http://schemas.microsoft.com/office/drawing/2014/main" id="{2DA45C77-F79D-4A1C-83DA-71B36DA14FF5}"/>
               </a:ext>
             </a:extLst>
           </p:cNvPr>
@@ -11018,7 +11018,7 @@
           <p:cNvPr id="4" name="">
             <a:extLst xmlns:a="http://schemas.openxmlformats.org/drawingml/2006/main">
               <a:ext uri="{FF2B5EF4-FFF2-40B4-BE49-F238E27FC236}">
-                <a16:creationId xmlns:a16="http://schemas.microsoft.com/office/drawing/2014/main" id="{A2B55337-0380-473C-99F7-1CD817EBBFEE}"/>
+                <a16:creationId xmlns:a16="http://schemas.microsoft.com/office/drawing/2014/main" id="{6201DA3B-BA33-4B30-954D-2BF1DAF69D63}"/>
               </a:ext>
             </a:extLst>
           </p:cNvPr>
@@ -11049,7 +11049,7 @@
           <p:cNvPr id="5" name="">
             <a:extLst xmlns:a="http://schemas.openxmlformats.org/drawingml/2006/main">
               <a:ext uri="{FF2B5EF4-FFF2-40B4-BE49-F238E27FC236}">
-                <a16:creationId xmlns:a16="http://schemas.microsoft.com/office/drawing/2014/main" id="{11F02ED3-330F-4A9D-B6C2-4DA0311B991A}"/>
+                <a16:creationId xmlns:a16="http://schemas.microsoft.com/office/drawing/2014/main" id="{176821D8-141E-4DA5-9E35-C749D08300CB}"/>
               </a:ext>
             </a:extLst>
           </p:cNvPr>
@@ -11099,7 +11099,7 @@
           <p:cNvPr id="6" name="">
             <a:extLst xmlns:a="http://schemas.openxmlformats.org/drawingml/2006/main">
               <a:ext uri="{FF2B5EF4-FFF2-40B4-BE49-F238E27FC236}">
-                <a16:creationId xmlns:a16="http://schemas.microsoft.com/office/drawing/2014/main" id="{D2CB9765-4746-4654-86DC-651248C91E17}"/>
+                <a16:creationId xmlns:a16="http://schemas.microsoft.com/office/drawing/2014/main" id="{E006FED8-34C8-4A0D-8B92-E2AD8896B9FC}"/>
               </a:ext>
             </a:extLst>
           </p:cNvPr>
@@ -11149,7 +11149,7 @@
           <p:cNvPr id="7" name="">
             <a:extLst xmlns:a="http://schemas.openxmlformats.org/drawingml/2006/main">
               <a:ext uri="{FF2B5EF4-FFF2-40B4-BE49-F238E27FC236}">
-                <a16:creationId xmlns:a16="http://schemas.microsoft.com/office/drawing/2014/main" id="{CA04DB39-861D-47B9-97BE-7EC1CC471232}"/>
+                <a16:creationId xmlns:a16="http://schemas.microsoft.com/office/drawing/2014/main" id="{C6809F7E-3E90-468D-A185-78990B9FF155}"/>
               </a:ext>
             </a:extLst>
           </p:cNvPr>
@@ -11199,7 +11199,7 @@
           <p:cNvPr id="8" name="">
             <a:extLst xmlns:a="http://schemas.openxmlformats.org/drawingml/2006/main">
               <a:ext uri="{FF2B5EF4-FFF2-40B4-BE49-F238E27FC236}">
-                <a16:creationId xmlns:a16="http://schemas.microsoft.com/office/drawing/2014/main" id="{2A85173C-A4AA-4721-9A0D-5924A2DA4989}"/>
+                <a16:creationId xmlns:a16="http://schemas.microsoft.com/office/drawing/2014/main" id="{94DD1C8A-689F-44B1-91FA-D7EB78FC67C5}"/>
               </a:ext>
             </a:extLst>
           </p:cNvPr>
@@ -11249,7 +11249,7 @@
           <p:cNvPr id="9" name="">
             <a:extLst xmlns:a="http://schemas.openxmlformats.org/drawingml/2006/main">
               <a:ext uri="{FF2B5EF4-FFF2-40B4-BE49-F238E27FC236}">
-                <a16:creationId xmlns:a16="http://schemas.microsoft.com/office/drawing/2014/main" id="{CABD8D43-B62E-4A12-A089-F9E597EF8842}"/>
+                <a16:creationId xmlns:a16="http://schemas.microsoft.com/office/drawing/2014/main" id="{E4A721B3-90AB-4108-B730-E57918A1B50C}"/>
               </a:ext>
             </a:extLst>
           </p:cNvPr>
@@ -11280,7 +11280,7 @@
           <p:cNvPr id="10" name="">
             <a:extLst xmlns:a="http://schemas.openxmlformats.org/drawingml/2006/main">
               <a:ext uri="{FF2B5EF4-FFF2-40B4-BE49-F238E27FC236}">
-                <a16:creationId xmlns:a16="http://schemas.microsoft.com/office/drawing/2014/main" id="{E8E60A20-4E1B-40B5-BE64-8BA0F6E06379}"/>
+                <a16:creationId xmlns:a16="http://schemas.microsoft.com/office/drawing/2014/main" id="{058E7A4D-BD88-4767-ABF0-18600EB221F8}"/>
               </a:ext>
             </a:extLst>
           </p:cNvPr>
@@ -11313,7 +11313,7 @@
           <p:cNvPr id="11" name="">
             <a:extLst xmlns:a="http://schemas.openxmlformats.org/drawingml/2006/main">
               <a:ext uri="{FF2B5EF4-FFF2-40B4-BE49-F238E27FC236}">
-                <a16:creationId xmlns:a16="http://schemas.microsoft.com/office/drawing/2014/main" id="{C52AAAEA-67AB-4BDA-A35D-677E1A830623}"/>
+                <a16:creationId xmlns:a16="http://schemas.microsoft.com/office/drawing/2014/main" id="{6B059022-FAA3-4130-B1C9-0E605C774561}"/>
               </a:ext>
             </a:extLst>
           </p:cNvPr>
@@ -11363,7 +11363,7 @@
           <p:cNvPr id="12" name="">
             <a:extLst xmlns:a="http://schemas.openxmlformats.org/drawingml/2006/main">
               <a:ext uri="{FF2B5EF4-FFF2-40B4-BE49-F238E27FC236}">
-                <a16:creationId xmlns:a16="http://schemas.microsoft.com/office/drawing/2014/main" id="{930D54EF-11AC-4A07-80BC-662C0D1D0CAF}"/>
+                <a16:creationId xmlns:a16="http://schemas.microsoft.com/office/drawing/2014/main" id="{AA0557B5-B342-4008-B111-CC96BD46E620}"/>
               </a:ext>
             </a:extLst>
           </p:cNvPr>
@@ -11413,7 +11413,7 @@
           <p:cNvPr id="13" name="">
             <a:extLst xmlns:a="http://schemas.openxmlformats.org/drawingml/2006/main">
               <a:ext uri="{FF2B5EF4-FFF2-40B4-BE49-F238E27FC236}">
-                <a16:creationId xmlns:a16="http://schemas.microsoft.com/office/drawing/2014/main" id="{F7175CC8-FFF5-47EC-BD5D-823D71A3D8DF}"/>
+                <a16:creationId xmlns:a16="http://schemas.microsoft.com/office/drawing/2014/main" id="{805A80AC-3C84-4F6F-A201-1D2D8A5DF40E}"/>
               </a:ext>
             </a:extLst>
           </p:cNvPr>
@@ -11463,7 +11463,7 @@
           <p:cNvPr id="14" name="">
             <a:extLst xmlns:a="http://schemas.openxmlformats.org/drawingml/2006/main">
               <a:ext uri="{FF2B5EF4-FFF2-40B4-BE49-F238E27FC236}">
-                <a16:creationId xmlns:a16="http://schemas.microsoft.com/office/drawing/2014/main" id="{EDC18ADB-1936-4213-AAAF-3266F2EC0057}"/>
+                <a16:creationId xmlns:a16="http://schemas.microsoft.com/office/drawing/2014/main" id="{7E8FA767-3D84-4634-A0FF-D6DEEAD416A0}"/>
               </a:ext>
             </a:extLst>
           </p:cNvPr>
@@ -11513,7 +11513,7 @@
           <p:cNvPr id="15" name="">
             <a:extLst xmlns:a="http://schemas.openxmlformats.org/drawingml/2006/main">
               <a:ext uri="{FF2B5EF4-FFF2-40B4-BE49-F238E27FC236}">
-                <a16:creationId xmlns:a16="http://schemas.microsoft.com/office/drawing/2014/main" id="{6FD4E390-5A4C-443A-BD18-C8B64FE9B6E2}"/>
+                <a16:creationId xmlns:a16="http://schemas.microsoft.com/office/drawing/2014/main" id="{A13E77D3-CF4B-412A-80B3-65F9ABD2CB11}"/>
               </a:ext>
             </a:extLst>
           </p:cNvPr>
@@ -11546,7 +11546,7 @@
           <p:cNvPr id="16" name="">
             <a:extLst xmlns:a="http://schemas.openxmlformats.org/drawingml/2006/main">
               <a:ext uri="{FF2B5EF4-FFF2-40B4-BE49-F238E27FC236}">
-                <a16:creationId xmlns:a16="http://schemas.microsoft.com/office/drawing/2014/main" id="{AF7D5F0F-A533-48F9-BBCE-4B80539324C2}"/>
+                <a16:creationId xmlns:a16="http://schemas.microsoft.com/office/drawing/2014/main" id="{B7F79DAC-2672-4F19-967B-D37AB57AC704}"/>
               </a:ext>
             </a:extLst>
           </p:cNvPr>
@@ -11596,7 +11596,7 @@
           <p:cNvPr id="17" name="">
             <a:extLst xmlns:a="http://schemas.openxmlformats.org/drawingml/2006/main">
               <a:ext uri="{FF2B5EF4-FFF2-40B4-BE49-F238E27FC236}">
-                <a16:creationId xmlns:a16="http://schemas.microsoft.com/office/drawing/2014/main" id="{8D222B9B-5F72-4BC1-9AEE-B0EC0E95431F}"/>
+                <a16:creationId xmlns:a16="http://schemas.microsoft.com/office/drawing/2014/main" id="{538A512D-C7F1-43F5-B3CD-04DC8A55E9D6}"/>
               </a:ext>
             </a:extLst>
           </p:cNvPr>
@@ -11646,7 +11646,7 @@
           <p:cNvPr id="18" name="">
             <a:extLst xmlns:a="http://schemas.openxmlformats.org/drawingml/2006/main">
               <a:ext uri="{FF2B5EF4-FFF2-40B4-BE49-F238E27FC236}">
-                <a16:creationId xmlns:a16="http://schemas.microsoft.com/office/drawing/2014/main" id="{B67707A7-0749-4643-99AE-99B584BBFCEC}"/>
+                <a16:creationId xmlns:a16="http://schemas.microsoft.com/office/drawing/2014/main" id="{EB11E734-178A-41DE-B3DF-960A3E70E3AE}"/>
               </a:ext>
             </a:extLst>
           </p:cNvPr>
@@ -11696,7 +11696,7 @@
           <p:cNvPr id="19" name="">
             <a:extLst xmlns:a="http://schemas.openxmlformats.org/drawingml/2006/main">
               <a:ext uri="{FF2B5EF4-FFF2-40B4-BE49-F238E27FC236}">
-                <a16:creationId xmlns:a16="http://schemas.microsoft.com/office/drawing/2014/main" id="{6B2C266F-E8B1-4F57-B8B7-6204B2C49102}"/>
+                <a16:creationId xmlns:a16="http://schemas.microsoft.com/office/drawing/2014/main" id="{72BE4C7A-C23C-41C4-BA35-CBECDDAE7354}"/>
               </a:ext>
             </a:extLst>
           </p:cNvPr>
@@ -11746,7 +11746,7 @@
           <p:cNvPr id="20" name="">
             <a:extLst xmlns:a="http://schemas.openxmlformats.org/drawingml/2006/main">
               <a:ext uri="{FF2B5EF4-FFF2-40B4-BE49-F238E27FC236}">
-                <a16:creationId xmlns:a16="http://schemas.microsoft.com/office/drawing/2014/main" id="{258DB589-334D-425D-BB4A-D4874D50DCBF}"/>
+                <a16:creationId xmlns:a16="http://schemas.microsoft.com/office/drawing/2014/main" id="{EF44FBBD-AD4E-4394-B229-B41B22E5BF5C}"/>
               </a:ext>
             </a:extLst>
           </p:cNvPr>
@@ -11779,7 +11779,7 @@
           <p:cNvPr id="21" name="">
             <a:extLst xmlns:a="http://schemas.openxmlformats.org/drawingml/2006/main">
               <a:ext uri="{FF2B5EF4-FFF2-40B4-BE49-F238E27FC236}">
-                <a16:creationId xmlns:a16="http://schemas.microsoft.com/office/drawing/2014/main" id="{5CC46E08-0C2F-47ED-BA88-A40164B43F23}"/>
+                <a16:creationId xmlns:a16="http://schemas.microsoft.com/office/drawing/2014/main" id="{1B932C7D-1F60-4D40-B177-9E05526462DB}"/>
               </a:ext>
             </a:extLst>
           </p:cNvPr>
@@ -11829,7 +11829,7 @@
           <p:cNvPr id="22" name="">
             <a:extLst xmlns:a="http://schemas.openxmlformats.org/drawingml/2006/main">
               <a:ext uri="{FF2B5EF4-FFF2-40B4-BE49-F238E27FC236}">
-                <a16:creationId xmlns:a16="http://schemas.microsoft.com/office/drawing/2014/main" id="{EBE910FE-5F82-49B2-A8B7-FFD31B697F26}"/>
+                <a16:creationId xmlns:a16="http://schemas.microsoft.com/office/drawing/2014/main" id="{58F6CEBA-73F4-4249-8A71-47566EF2AC35}"/>
               </a:ext>
             </a:extLst>
           </p:cNvPr>
@@ -11879,7 +11879,7 @@
           <p:cNvPr id="23" name="">
             <a:extLst xmlns:a="http://schemas.openxmlformats.org/drawingml/2006/main">
               <a:ext uri="{FF2B5EF4-FFF2-40B4-BE49-F238E27FC236}">
-                <a16:creationId xmlns:a16="http://schemas.microsoft.com/office/drawing/2014/main" id="{E18B6A63-485B-4244-B324-B198C9AC6076}"/>
+                <a16:creationId xmlns:a16="http://schemas.microsoft.com/office/drawing/2014/main" id="{7E784502-41E6-4D0B-ADD2-3AAFE27043BD}"/>
               </a:ext>
             </a:extLst>
           </p:cNvPr>
@@ -11929,7 +11929,7 @@
           <p:cNvPr id="24" name="">
             <a:extLst xmlns:a="http://schemas.openxmlformats.org/drawingml/2006/main">
               <a:ext uri="{FF2B5EF4-FFF2-40B4-BE49-F238E27FC236}">
-                <a16:creationId xmlns:a16="http://schemas.microsoft.com/office/drawing/2014/main" id="{F9090234-08DF-40A1-BB55-6D6027044DEC}"/>
+                <a16:creationId xmlns:a16="http://schemas.microsoft.com/office/drawing/2014/main" id="{BECF20CE-1FA4-4929-8D59-EADCB718446D}"/>
               </a:ext>
             </a:extLst>
           </p:cNvPr>
@@ -11979,7 +11979,7 @@
           <p:cNvPr id="25" name="">
             <a:extLst xmlns:a="http://schemas.openxmlformats.org/drawingml/2006/main">
               <a:ext uri="{FF2B5EF4-FFF2-40B4-BE49-F238E27FC236}">
-                <a16:creationId xmlns:a16="http://schemas.microsoft.com/office/drawing/2014/main" id="{09DF91BD-5AE2-4877-BA53-C653C7F830E3}"/>
+                <a16:creationId xmlns:a16="http://schemas.microsoft.com/office/drawing/2014/main" id="{035958B2-A79E-4B46-A1BC-D649BF38AC3A}"/>
               </a:ext>
             </a:extLst>
           </p:cNvPr>
@@ -12012,7 +12012,7 @@
           <p:cNvPr id="26" name="">
             <a:extLst xmlns:a="http://schemas.openxmlformats.org/drawingml/2006/main">
               <a:ext uri="{FF2B5EF4-FFF2-40B4-BE49-F238E27FC236}">
-                <a16:creationId xmlns:a16="http://schemas.microsoft.com/office/drawing/2014/main" id="{A9303428-B9D4-4F0F-AE90-D6BA2DFD888A}"/>
+                <a16:creationId xmlns:a16="http://schemas.microsoft.com/office/drawing/2014/main" id="{95035416-AED6-48B9-A88E-D04F2739DED2}"/>
               </a:ext>
             </a:extLst>
           </p:cNvPr>
@@ -12062,7 +12062,7 @@
           <p:cNvPr id="27" name="">
             <a:extLst xmlns:a="http://schemas.openxmlformats.org/drawingml/2006/main">
               <a:ext uri="{FF2B5EF4-FFF2-40B4-BE49-F238E27FC236}">
-                <a16:creationId xmlns:a16="http://schemas.microsoft.com/office/drawing/2014/main" id="{D3BB4E1F-843B-421E-B2D6-AC2ECE77F6C8}"/>
+                <a16:creationId xmlns:a16="http://schemas.microsoft.com/office/drawing/2014/main" id="{12A429DE-B995-439B-9D33-CE0E386060FA}"/>
               </a:ext>
             </a:extLst>
           </p:cNvPr>
@@ -12112,7 +12112,7 @@
           <p:cNvPr id="28" name="">
             <a:extLst xmlns:a="http://schemas.openxmlformats.org/drawingml/2006/main">
               <a:ext uri="{FF2B5EF4-FFF2-40B4-BE49-F238E27FC236}">
-                <a16:creationId xmlns:a16="http://schemas.microsoft.com/office/drawing/2014/main" id="{0FF086C4-7B34-440A-AA42-43642F696973}"/>
+                <a16:creationId xmlns:a16="http://schemas.microsoft.com/office/drawing/2014/main" id="{A5B792A3-A863-41FA-BE13-639BB833551C}"/>
               </a:ext>
             </a:extLst>
           </p:cNvPr>
@@ -12162,7 +12162,7 @@
           <p:cNvPr id="29" name="">
             <a:extLst xmlns:a="http://schemas.openxmlformats.org/drawingml/2006/main">
               <a:ext uri="{FF2B5EF4-FFF2-40B4-BE49-F238E27FC236}">
-                <a16:creationId xmlns:a16="http://schemas.microsoft.com/office/drawing/2014/main" id="{1FAD8B59-74E7-4521-AF51-275B55C6B528}"/>
+                <a16:creationId xmlns:a16="http://schemas.microsoft.com/office/drawing/2014/main" id="{1B53500D-9DC1-4006-AF5B-9B6C5E8912C2}"/>
               </a:ext>
             </a:extLst>
           </p:cNvPr>
@@ -12212,7 +12212,7 @@
           <p:cNvPr id="30" name="">
             <a:extLst xmlns:a="http://schemas.openxmlformats.org/drawingml/2006/main">
               <a:ext uri="{FF2B5EF4-FFF2-40B4-BE49-F238E27FC236}">
-                <a16:creationId xmlns:a16="http://schemas.microsoft.com/office/drawing/2014/main" id="{BEDEF059-FA9D-4EC3-B728-52F66A938928}"/>
+                <a16:creationId xmlns:a16="http://schemas.microsoft.com/office/drawing/2014/main" id="{16991D22-BB87-4D2F-A005-C7307BD1F5A6}"/>
               </a:ext>
             </a:extLst>
           </p:cNvPr>
@@ -12245,7 +12245,7 @@
           <p:cNvPr id="31" name="">
             <a:extLst xmlns:a="http://schemas.openxmlformats.org/drawingml/2006/main">
               <a:ext uri="{FF2B5EF4-FFF2-40B4-BE49-F238E27FC236}">
-                <a16:creationId xmlns:a16="http://schemas.microsoft.com/office/drawing/2014/main" id="{F9834C41-AF09-42BF-B3A4-300CAFE07C8E}"/>
+                <a16:creationId xmlns:a16="http://schemas.microsoft.com/office/drawing/2014/main" id="{5FF73487-DE27-42F2-A3AE-2BC05B027FD1}"/>
               </a:ext>
             </a:extLst>
           </p:cNvPr>
@@ -12295,7 +12295,7 @@
           <p:cNvPr id="32" name="">
             <a:extLst xmlns:a="http://schemas.openxmlformats.org/drawingml/2006/main">
               <a:ext uri="{FF2B5EF4-FFF2-40B4-BE49-F238E27FC236}">
-                <a16:creationId xmlns:a16="http://schemas.microsoft.com/office/drawing/2014/main" id="{DDA92A70-B126-4FAC-88C6-79E7DA585D82}"/>
+                <a16:creationId xmlns:a16="http://schemas.microsoft.com/office/drawing/2014/main" id="{237F656F-D5E6-486F-A322-9A7C7C233B58}"/>
               </a:ext>
             </a:extLst>
           </p:cNvPr>
@@ -12345,7 +12345,7 @@
           <p:cNvPr id="33" name="">
             <a:extLst xmlns:a="http://schemas.openxmlformats.org/drawingml/2006/main">
               <a:ext uri="{FF2B5EF4-FFF2-40B4-BE49-F238E27FC236}">
-                <a16:creationId xmlns:a16="http://schemas.microsoft.com/office/drawing/2014/main" id="{3D89A52F-97D9-46C0-B834-BDC8460F31B7}"/>
+                <a16:creationId xmlns:a16="http://schemas.microsoft.com/office/drawing/2014/main" id="{D1AAB1DF-A24F-428B-B660-5839EDF17F68}"/>
               </a:ext>
             </a:extLst>
           </p:cNvPr>
@@ -12395,7 +12395,7 @@
           <p:cNvPr id="34" name="">
             <a:extLst xmlns:a="http://schemas.openxmlformats.org/drawingml/2006/main">
               <a:ext uri="{FF2B5EF4-FFF2-40B4-BE49-F238E27FC236}">
-                <a16:creationId xmlns:a16="http://schemas.microsoft.com/office/drawing/2014/main" id="{13BAC5EE-1B13-41F6-B873-A32FBC273839}"/>
+                <a16:creationId xmlns:a16="http://schemas.microsoft.com/office/drawing/2014/main" id="{66237210-94B1-481D-A172-35D8F51DFDBE}"/>
               </a:ext>
             </a:extLst>
           </p:cNvPr>
@@ -12443,7 +12443,7 @@
     </p:spTree>
     <p:extLst>
       <p:ext uri="{BB962C8B-B14F-4D97-AF65-F5344CB8AC3E}">
-        <p14:creationId xmlns:p14="http://schemas.microsoft.com/office/powerpoint/2010/main" val="318913398"/>
+        <p14:creationId xmlns:p14="http://schemas.microsoft.com/office/powerpoint/2010/main" val="1394102473"/>
       </p:ext>
     </p:extLst>
   </p:cSld>
@@ -12474,7 +12474,7 @@
           <p:cNvPr id="1" name="">
             <a:extLst xmlns:a="http://schemas.openxmlformats.org/drawingml/2006/main">
               <a:ext uri="{FF2B5EF4-FFF2-40B4-BE49-F238E27FC236}">
-                <a16:creationId xmlns:a16="http://schemas.microsoft.com/office/drawing/2014/main" id="{7D398202-0C29-4E55-8653-95EE68D2A751}"/>
+                <a16:creationId xmlns:a16="http://schemas.microsoft.com/office/drawing/2014/main" id="{CF2E2AA5-588F-47A5-A92E-F6332BF90EC0}"/>
               </a:ext>
             </a:extLst>
           </p:cNvPr>
@@ -12505,7 +12505,7 @@
           <p:cNvPr id="2" name="">
             <a:extLst xmlns:a="http://schemas.openxmlformats.org/drawingml/2006/main">
               <a:ext uri="{FF2B5EF4-FFF2-40B4-BE49-F238E27FC236}">
-                <a16:creationId xmlns:a16="http://schemas.microsoft.com/office/drawing/2014/main" id="{567B39FA-F443-4C6E-B679-9ECAFF56641F}"/>
+                <a16:creationId xmlns:a16="http://schemas.microsoft.com/office/drawing/2014/main" id="{851A83E1-C3FC-4418-83E6-F1C7599C92B1}"/>
               </a:ext>
             </a:extLst>
           </p:cNvPr>
@@ -12555,7 +12555,7 @@
           <p:cNvPr id="3" name="">
             <a:extLst xmlns:a="http://schemas.openxmlformats.org/drawingml/2006/main">
               <a:ext uri="{FF2B5EF4-FFF2-40B4-BE49-F238E27FC236}">
-                <a16:creationId xmlns:a16="http://schemas.microsoft.com/office/drawing/2014/main" id="{0B6F9AAC-3676-46BF-966E-1F82FABF7D00}"/>
+                <a16:creationId xmlns:a16="http://schemas.microsoft.com/office/drawing/2014/main" id="{A13994BD-2CC7-4C5A-9424-C681C41B270A}"/>
               </a:ext>
             </a:extLst>
           </p:cNvPr>
@@ -12605,7 +12605,7 @@
           <p:cNvPr id="4" name="">
             <a:extLst xmlns:a="http://schemas.openxmlformats.org/drawingml/2006/main">
               <a:ext uri="{FF2B5EF4-FFF2-40B4-BE49-F238E27FC236}">
-                <a16:creationId xmlns:a16="http://schemas.microsoft.com/office/drawing/2014/main" id="{B0A08BAB-9D68-4DE1-A3C3-92AA3F043F0A}"/>
+                <a16:creationId xmlns:a16="http://schemas.microsoft.com/office/drawing/2014/main" id="{04B640FC-B4AD-4B57-93D0-0B7532B604D5}"/>
               </a:ext>
             </a:extLst>
           </p:cNvPr>
@@ -12636,7 +12636,7 @@
           <p:cNvPr id="5" name="">
             <a:extLst xmlns:a="http://schemas.openxmlformats.org/drawingml/2006/main">
               <a:ext uri="{FF2B5EF4-FFF2-40B4-BE49-F238E27FC236}">
-                <a16:creationId xmlns:a16="http://schemas.microsoft.com/office/drawing/2014/main" id="{B7F5470E-FB51-4A52-A795-30D0E63F8FEB}"/>
+                <a16:creationId xmlns:a16="http://schemas.microsoft.com/office/drawing/2014/main" id="{504CA47C-2B77-4CD0-BB48-E1401A703091}"/>
               </a:ext>
             </a:extLst>
           </p:cNvPr>
@@ -12686,7 +12686,7 @@
           <p:cNvPr id="6" name="">
             <a:extLst xmlns:a="http://schemas.openxmlformats.org/drawingml/2006/main">
               <a:ext uri="{FF2B5EF4-FFF2-40B4-BE49-F238E27FC236}">
-                <a16:creationId xmlns:a16="http://schemas.microsoft.com/office/drawing/2014/main" id="{DD0F07AF-675A-476C-BEF5-3609C7D8226A}"/>
+                <a16:creationId xmlns:a16="http://schemas.microsoft.com/office/drawing/2014/main" id="{B308BB09-3323-4289-A28B-0A627986835A}"/>
               </a:ext>
             </a:extLst>
           </p:cNvPr>
@@ -12736,7 +12736,7 @@
           <p:cNvPr id="7" name="">
             <a:extLst xmlns:a="http://schemas.openxmlformats.org/drawingml/2006/main">
               <a:ext uri="{FF2B5EF4-FFF2-40B4-BE49-F238E27FC236}">
-                <a16:creationId xmlns:a16="http://schemas.microsoft.com/office/drawing/2014/main" id="{353B922F-12EF-4111-9D49-FEC87577BC23}"/>
+                <a16:creationId xmlns:a16="http://schemas.microsoft.com/office/drawing/2014/main" id="{2F203B99-24B4-4B52-8540-435BFAE2A3ED}"/>
               </a:ext>
             </a:extLst>
           </p:cNvPr>
@@ -12786,7 +12786,7 @@
           <p:cNvPr id="8" name="">
             <a:extLst xmlns:a="http://schemas.openxmlformats.org/drawingml/2006/main">
               <a:ext uri="{FF2B5EF4-FFF2-40B4-BE49-F238E27FC236}">
-                <a16:creationId xmlns:a16="http://schemas.microsoft.com/office/drawing/2014/main" id="{42168915-9AAF-4B6D-A359-74B71B8D983D}"/>
+                <a16:creationId xmlns:a16="http://schemas.microsoft.com/office/drawing/2014/main" id="{50467DCE-5A8D-465B-B7AA-D02C1A62E98B}"/>
               </a:ext>
             </a:extLst>
           </p:cNvPr>
@@ -12836,7 +12836,7 @@
           <p:cNvPr id="9" name="">
             <a:extLst xmlns:a="http://schemas.openxmlformats.org/drawingml/2006/main">
               <a:ext uri="{FF2B5EF4-FFF2-40B4-BE49-F238E27FC236}">
-                <a16:creationId xmlns:a16="http://schemas.microsoft.com/office/drawing/2014/main" id="{A3BA1E35-5FDB-4DD2-9F68-E3935D4EEFA4}"/>
+                <a16:creationId xmlns:a16="http://schemas.microsoft.com/office/drawing/2014/main" id="{0E051245-87FE-44A6-A84D-A29A518FADC0}"/>
               </a:ext>
             </a:extLst>
           </p:cNvPr>
@@ -12867,7 +12867,7 @@
           <p:cNvPr id="10" name="">
             <a:extLst xmlns:a="http://schemas.openxmlformats.org/drawingml/2006/main">
               <a:ext uri="{FF2B5EF4-FFF2-40B4-BE49-F238E27FC236}">
-                <a16:creationId xmlns:a16="http://schemas.microsoft.com/office/drawing/2014/main" id="{53BB6400-99DE-42EE-BE27-BE02BF2CF57C}"/>
+                <a16:creationId xmlns:a16="http://schemas.microsoft.com/office/drawing/2014/main" id="{2DC523EA-2BF7-45D7-9C59-38178A9EA770}"/>
               </a:ext>
             </a:extLst>
           </p:cNvPr>
@@ -12900,7 +12900,7 @@
           <p:cNvPr id="11" name="">
             <a:extLst xmlns:a="http://schemas.openxmlformats.org/drawingml/2006/main">
               <a:ext uri="{FF2B5EF4-FFF2-40B4-BE49-F238E27FC236}">
-                <a16:creationId xmlns:a16="http://schemas.microsoft.com/office/drawing/2014/main" id="{4027B527-A964-4A70-A65F-DD544B7865CD}"/>
+                <a16:creationId xmlns:a16="http://schemas.microsoft.com/office/drawing/2014/main" id="{B480B7EB-1F46-442F-8799-5FA28461DE64}"/>
               </a:ext>
             </a:extLst>
           </p:cNvPr>
@@ -12950,7 +12950,7 @@
           <p:cNvPr id="12" name="">
             <a:extLst xmlns:a="http://schemas.openxmlformats.org/drawingml/2006/main">
               <a:ext uri="{FF2B5EF4-FFF2-40B4-BE49-F238E27FC236}">
-                <a16:creationId xmlns:a16="http://schemas.microsoft.com/office/drawing/2014/main" id="{C05D16F0-546D-48D9-9D55-21D1CC1E7A61}"/>
+                <a16:creationId xmlns:a16="http://schemas.microsoft.com/office/drawing/2014/main" id="{34F79235-6A1D-43BD-867E-F2EE2886917C}"/>
               </a:ext>
             </a:extLst>
           </p:cNvPr>
@@ -13085,7 +13085,7 @@
           <p:cNvPr id="13" name="">
             <a:extLst xmlns:a="http://schemas.openxmlformats.org/drawingml/2006/main">
               <a:ext uri="{FF2B5EF4-FFF2-40B4-BE49-F238E27FC236}">
-                <a16:creationId xmlns:a16="http://schemas.microsoft.com/office/drawing/2014/main" id="{F9388099-693D-4E3B-9483-B911CE4611F8}"/>
+                <a16:creationId xmlns:a16="http://schemas.microsoft.com/office/drawing/2014/main" id="{BBA7DB0F-3410-4AD3-A45A-A67CF95E2682}"/>
               </a:ext>
             </a:extLst>
           </p:cNvPr>
@@ -13118,7 +13118,7 @@
           <p:cNvPr id="14" name="">
             <a:extLst xmlns:a="http://schemas.openxmlformats.org/drawingml/2006/main">
               <a:ext uri="{FF2B5EF4-FFF2-40B4-BE49-F238E27FC236}">
-                <a16:creationId xmlns:a16="http://schemas.microsoft.com/office/drawing/2014/main" id="{F3CF817B-36FD-4C73-BB37-F6B032A70B58}"/>
+                <a16:creationId xmlns:a16="http://schemas.microsoft.com/office/drawing/2014/main" id="{4576B44F-AC54-4E35-84CD-612B15B14B7D}"/>
               </a:ext>
             </a:extLst>
           </p:cNvPr>
@@ -13168,7 +13168,7 @@
           <p:cNvPr id="15" name="">
             <a:extLst xmlns:a="http://schemas.openxmlformats.org/drawingml/2006/main">
               <a:ext uri="{FF2B5EF4-FFF2-40B4-BE49-F238E27FC236}">
-                <a16:creationId xmlns:a16="http://schemas.microsoft.com/office/drawing/2014/main" id="{05B613FC-4001-4F84-9282-F4396502F7BA}"/>
+                <a16:creationId xmlns:a16="http://schemas.microsoft.com/office/drawing/2014/main" id="{3A3ED74C-BEA4-422F-BBF6-A247E7261EEE}"/>
               </a:ext>
             </a:extLst>
           </p:cNvPr>
@@ -13303,7 +13303,7 @@
           <p:cNvPr id="16" name="">
             <a:extLst xmlns:a="http://schemas.openxmlformats.org/drawingml/2006/main">
               <a:ext uri="{FF2B5EF4-FFF2-40B4-BE49-F238E27FC236}">
-                <a16:creationId xmlns:a16="http://schemas.microsoft.com/office/drawing/2014/main" id="{ECDD6AFF-070F-4971-98FB-1B694AF32C51}"/>
+                <a16:creationId xmlns:a16="http://schemas.microsoft.com/office/drawing/2014/main" id="{9B41C053-3124-495C-8695-E972FF5DB255}"/>
               </a:ext>
             </a:extLst>
           </p:cNvPr>
@@ -13336,7 +13336,7 @@
           <p:cNvPr id="17" name="">
             <a:extLst xmlns:a="http://schemas.openxmlformats.org/drawingml/2006/main">
               <a:ext uri="{FF2B5EF4-FFF2-40B4-BE49-F238E27FC236}">
-                <a16:creationId xmlns:a16="http://schemas.microsoft.com/office/drawing/2014/main" id="{33C28C6E-2DC4-4F4D-AEE6-07112FBB9E5D}"/>
+                <a16:creationId xmlns:a16="http://schemas.microsoft.com/office/drawing/2014/main" id="{2452E403-CA7E-4352-9E21-2570722D4524}"/>
               </a:ext>
             </a:extLst>
           </p:cNvPr>
@@ -13386,7 +13386,7 @@
           <p:cNvPr id="18" name="">
             <a:extLst xmlns:a="http://schemas.openxmlformats.org/drawingml/2006/main">
               <a:ext uri="{FF2B5EF4-FFF2-40B4-BE49-F238E27FC236}">
-                <a16:creationId xmlns:a16="http://schemas.microsoft.com/office/drawing/2014/main" id="{4004CE49-0AF5-4A12-8D58-27B1B1031C7E}"/>
+                <a16:creationId xmlns:a16="http://schemas.microsoft.com/office/drawing/2014/main" id="{10814CD2-2B4D-4C37-B3FF-3647B3B13A7A}"/>
               </a:ext>
             </a:extLst>
           </p:cNvPr>
@@ -13519,7 +13519,7 @@
     </p:spTree>
     <p:extLst>
       <p:ext uri="{BB962C8B-B14F-4D97-AF65-F5344CB8AC3E}">
-        <p14:creationId xmlns:p14="http://schemas.microsoft.com/office/powerpoint/2010/main" val="17062461"/>
+        <p14:creationId xmlns:p14="http://schemas.microsoft.com/office/powerpoint/2010/main" val="747724713"/>
       </p:ext>
     </p:extLst>
   </p:cSld>
@@ -13550,7 +13550,7 @@
           <p:cNvPr id="1" name="">
             <a:extLst xmlns:a="http://schemas.openxmlformats.org/drawingml/2006/main">
               <a:ext uri="{FF2B5EF4-FFF2-40B4-BE49-F238E27FC236}">
-                <a16:creationId xmlns:a16="http://schemas.microsoft.com/office/drawing/2014/main" id="{81230EC0-CA23-4648-A473-86167BA30774}"/>
+                <a16:creationId xmlns:a16="http://schemas.microsoft.com/office/drawing/2014/main" id="{2A25A988-F6C2-46E4-B399-5E6667EA787C}"/>
               </a:ext>
             </a:extLst>
           </p:cNvPr>
@@ -13581,7 +13581,7 @@
           <p:cNvPr id="2" name="">
             <a:extLst xmlns:a="http://schemas.openxmlformats.org/drawingml/2006/main">
               <a:ext uri="{FF2B5EF4-FFF2-40B4-BE49-F238E27FC236}">
-                <a16:creationId xmlns:a16="http://schemas.microsoft.com/office/drawing/2014/main" id="{76347BE3-B2D0-472C-94D0-D890ABDFE70F}"/>
+                <a16:creationId xmlns:a16="http://schemas.microsoft.com/office/drawing/2014/main" id="{56A00066-F9F2-4686-B8C1-C812ECC87589}"/>
               </a:ext>
             </a:extLst>
           </p:cNvPr>
@@ -13631,7 +13631,7 @@
           <p:cNvPr id="3" name="">
             <a:extLst xmlns:a="http://schemas.openxmlformats.org/drawingml/2006/main">
               <a:ext uri="{FF2B5EF4-FFF2-40B4-BE49-F238E27FC236}">
-                <a16:creationId xmlns:a16="http://schemas.microsoft.com/office/drawing/2014/main" id="{98119284-96B6-409C-B41B-30F7F6277319}"/>
+                <a16:creationId xmlns:a16="http://schemas.microsoft.com/office/drawing/2014/main" id="{7A2EEBB1-1FF9-45F6-AA8E-3F0BED49E3A4}"/>
               </a:ext>
             </a:extLst>
           </p:cNvPr>
@@ -13681,7 +13681,7 @@
           <p:cNvPr id="4" name="">
             <a:extLst xmlns:a="http://schemas.openxmlformats.org/drawingml/2006/main">
               <a:ext uri="{FF2B5EF4-FFF2-40B4-BE49-F238E27FC236}">
-                <a16:creationId xmlns:a16="http://schemas.microsoft.com/office/drawing/2014/main" id="{64966AF3-8328-4E10-A18B-F23D23FDBFE4}"/>
+                <a16:creationId xmlns:a16="http://schemas.microsoft.com/office/drawing/2014/main" id="{BE5A5A1D-8C32-4199-BEB9-B10A7B7EC581}"/>
               </a:ext>
             </a:extLst>
           </p:cNvPr>
@@ -13712,7 +13712,7 @@
           <p:cNvPr id="5" name="">
             <a:extLst xmlns:a="http://schemas.openxmlformats.org/drawingml/2006/main">
               <a:ext uri="{FF2B5EF4-FFF2-40B4-BE49-F238E27FC236}">
-                <a16:creationId xmlns:a16="http://schemas.microsoft.com/office/drawing/2014/main" id="{0F9913BB-0650-43A7-8C2D-ACDE7AF3F72A}"/>
+                <a16:creationId xmlns:a16="http://schemas.microsoft.com/office/drawing/2014/main" id="{86B8725E-F2AC-46B3-8259-B4B4075318C1}"/>
               </a:ext>
             </a:extLst>
           </p:cNvPr>
@@ -13762,7 +13762,7 @@
           <p:cNvPr id="6" name="">
             <a:extLst xmlns:a="http://schemas.openxmlformats.org/drawingml/2006/main">
               <a:ext uri="{FF2B5EF4-FFF2-40B4-BE49-F238E27FC236}">
-                <a16:creationId xmlns:a16="http://schemas.microsoft.com/office/drawing/2014/main" id="{4A279E72-AFB8-4073-9388-994BA69095AB}"/>
+                <a16:creationId xmlns:a16="http://schemas.microsoft.com/office/drawing/2014/main" id="{63047CE7-A0A9-42C5-992A-B42AFA37E738}"/>
               </a:ext>
             </a:extLst>
           </p:cNvPr>
@@ -13812,7 +13812,7 @@
           <p:cNvPr id="7" name="">
             <a:extLst xmlns:a="http://schemas.openxmlformats.org/drawingml/2006/main">
               <a:ext uri="{FF2B5EF4-FFF2-40B4-BE49-F238E27FC236}">
-                <a16:creationId xmlns:a16="http://schemas.microsoft.com/office/drawing/2014/main" id="{FCAAC2D6-71D8-4C6B-8579-02FDA9E5AC22}"/>
+                <a16:creationId xmlns:a16="http://schemas.microsoft.com/office/drawing/2014/main" id="{0054EEB6-D581-4E1E-8D1C-995823C6D2A2}"/>
               </a:ext>
             </a:extLst>
           </p:cNvPr>
@@ -13862,7 +13862,7 @@
           <p:cNvPr id="8" name="">
             <a:extLst xmlns:a="http://schemas.openxmlformats.org/drawingml/2006/main">
               <a:ext uri="{FF2B5EF4-FFF2-40B4-BE49-F238E27FC236}">
-                <a16:creationId xmlns:a16="http://schemas.microsoft.com/office/drawing/2014/main" id="{E7F4AE9E-7E0F-481F-901B-2FE8493992CB}"/>
+                <a16:creationId xmlns:a16="http://schemas.microsoft.com/office/drawing/2014/main" id="{6A06EE6A-3DA7-4733-95D0-4558D7458DD4}"/>
               </a:ext>
             </a:extLst>
           </p:cNvPr>
@@ -13912,7 +13912,7 @@
           <p:cNvPr id="9" name="">
             <a:extLst xmlns:a="http://schemas.openxmlformats.org/drawingml/2006/main">
               <a:ext uri="{FF2B5EF4-FFF2-40B4-BE49-F238E27FC236}">
-                <a16:creationId xmlns:a16="http://schemas.microsoft.com/office/drawing/2014/main" id="{2D273B4C-8E30-499D-ABF1-5EF9AF03A52F}"/>
+                <a16:creationId xmlns:a16="http://schemas.microsoft.com/office/drawing/2014/main" id="{212B6E6A-0D4F-4306-B706-C84AB99929E4}"/>
               </a:ext>
             </a:extLst>
           </p:cNvPr>
@@ -13943,7 +13943,7 @@
           <p:cNvPr id="10" name="">
             <a:extLst xmlns:a="http://schemas.openxmlformats.org/drawingml/2006/main">
               <a:ext uri="{FF2B5EF4-FFF2-40B4-BE49-F238E27FC236}">
-                <a16:creationId xmlns:a16="http://schemas.microsoft.com/office/drawing/2014/main" id="{C32DADE5-EE9A-4A7A-ABD3-71ACD97ED994}"/>
+                <a16:creationId xmlns:a16="http://schemas.microsoft.com/office/drawing/2014/main" id="{9CCB334A-0D2A-4F53-B686-C028892DCF3C}"/>
               </a:ext>
             </a:extLst>
           </p:cNvPr>
@@ -13976,7 +13976,7 @@
           <p:cNvPr id="11" name="">
             <a:extLst xmlns:a="http://schemas.openxmlformats.org/drawingml/2006/main">
               <a:ext uri="{FF2B5EF4-FFF2-40B4-BE49-F238E27FC236}">
-                <a16:creationId xmlns:a16="http://schemas.microsoft.com/office/drawing/2014/main" id="{95F25EF4-15F9-4250-8A5D-E80135F9BF27}"/>
+                <a16:creationId xmlns:a16="http://schemas.microsoft.com/office/drawing/2014/main" id="{9CC9A2D9-7191-4647-A3F6-CFB04F16BEEC}"/>
               </a:ext>
             </a:extLst>
           </p:cNvPr>
@@ -14026,7 +14026,7 @@
           <p:cNvPr id="12" name="">
             <a:extLst xmlns:a="http://schemas.openxmlformats.org/drawingml/2006/main">
               <a:ext uri="{FF2B5EF4-FFF2-40B4-BE49-F238E27FC236}">
-                <a16:creationId xmlns:a16="http://schemas.microsoft.com/office/drawing/2014/main" id="{E41A5999-FC12-4715-AFE2-775A4FF7D14A}"/>
+                <a16:creationId xmlns:a16="http://schemas.microsoft.com/office/drawing/2014/main" id="{8646DC34-9DAA-4FD7-8C44-91A17E90BBA5}"/>
               </a:ext>
             </a:extLst>
           </p:cNvPr>
@@ -14076,7 +14076,7 @@
           <p:cNvPr id="13" name="">
             <a:extLst xmlns:a="http://schemas.openxmlformats.org/drawingml/2006/main">
               <a:ext uri="{FF2B5EF4-FFF2-40B4-BE49-F238E27FC236}">
-                <a16:creationId xmlns:a16="http://schemas.microsoft.com/office/drawing/2014/main" id="{65175BED-4FD1-4BF6-AB4A-81A94A7CD6DC}"/>
+                <a16:creationId xmlns:a16="http://schemas.microsoft.com/office/drawing/2014/main" id="{9BAB12D2-7B61-4DBB-82F9-B15E1D43BE68}"/>
               </a:ext>
             </a:extLst>
           </p:cNvPr>
@@ -14109,7 +14109,7 @@
           <p:cNvPr id="14" name="">
             <a:extLst xmlns:a="http://schemas.openxmlformats.org/drawingml/2006/main">
               <a:ext uri="{FF2B5EF4-FFF2-40B4-BE49-F238E27FC236}">
-                <a16:creationId xmlns:a16="http://schemas.microsoft.com/office/drawing/2014/main" id="{62BFE6C0-F35C-4847-87E2-A510EB1F880C}"/>
+                <a16:creationId xmlns:a16="http://schemas.microsoft.com/office/drawing/2014/main" id="{549898D4-F9CF-4745-88C3-04A248B88487}"/>
               </a:ext>
             </a:extLst>
           </p:cNvPr>
@@ -14159,7 +14159,7 @@
           <p:cNvPr id="15" name="">
             <a:extLst xmlns:a="http://schemas.openxmlformats.org/drawingml/2006/main">
               <a:ext uri="{FF2B5EF4-FFF2-40B4-BE49-F238E27FC236}">
-                <a16:creationId xmlns:a16="http://schemas.microsoft.com/office/drawing/2014/main" id="{AD2B4ABD-6AE5-4414-83BD-966B935D27FB}"/>
+                <a16:creationId xmlns:a16="http://schemas.microsoft.com/office/drawing/2014/main" id="{7E81CFC6-4CD5-445F-AD76-0FFAD5AAC7BF}"/>
               </a:ext>
             </a:extLst>
           </p:cNvPr>
@@ -14209,7 +14209,7 @@
           <p:cNvPr id="16" name="">
             <a:extLst xmlns:a="http://schemas.openxmlformats.org/drawingml/2006/main">
               <a:ext uri="{FF2B5EF4-FFF2-40B4-BE49-F238E27FC236}">
-                <a16:creationId xmlns:a16="http://schemas.microsoft.com/office/drawing/2014/main" id="{378CFF44-1DF1-432D-9E09-59AF10613354}"/>
+                <a16:creationId xmlns:a16="http://schemas.microsoft.com/office/drawing/2014/main" id="{ACA20D42-2CD4-4630-A486-9F255853F054}"/>
               </a:ext>
             </a:extLst>
           </p:cNvPr>
@@ -14242,7 +14242,7 @@
           <p:cNvPr id="17" name="">
             <a:extLst xmlns:a="http://schemas.openxmlformats.org/drawingml/2006/main">
               <a:ext uri="{FF2B5EF4-FFF2-40B4-BE49-F238E27FC236}">
-                <a16:creationId xmlns:a16="http://schemas.microsoft.com/office/drawing/2014/main" id="{90A337A1-ECBC-4710-9EE8-7AB51E845062}"/>
+                <a16:creationId xmlns:a16="http://schemas.microsoft.com/office/drawing/2014/main" id="{406DD51C-55E7-499D-9390-D8B98421542E}"/>
               </a:ext>
             </a:extLst>
           </p:cNvPr>
@@ -14292,7 +14292,7 @@
           <p:cNvPr id="18" name="">
             <a:extLst xmlns:a="http://schemas.openxmlformats.org/drawingml/2006/main">
               <a:ext uri="{FF2B5EF4-FFF2-40B4-BE49-F238E27FC236}">
-                <a16:creationId xmlns:a16="http://schemas.microsoft.com/office/drawing/2014/main" id="{63713D90-4FCE-4B66-9830-51FF47C8AF09}"/>
+                <a16:creationId xmlns:a16="http://schemas.microsoft.com/office/drawing/2014/main" id="{40777B66-8246-4EF2-816A-51B07F13C413}"/>
               </a:ext>
             </a:extLst>
           </p:cNvPr>
@@ -14342,7 +14342,7 @@
           <p:cNvPr id="19" name="">
             <a:extLst xmlns:a="http://schemas.openxmlformats.org/drawingml/2006/main">
               <a:ext uri="{FF2B5EF4-FFF2-40B4-BE49-F238E27FC236}">
-                <a16:creationId xmlns:a16="http://schemas.microsoft.com/office/drawing/2014/main" id="{F8A07574-C23B-4D1E-84C2-0E183A6950C3}"/>
+                <a16:creationId xmlns:a16="http://schemas.microsoft.com/office/drawing/2014/main" id="{B7E28867-4920-4E37-89E8-FE45FA8F05E1}"/>
               </a:ext>
             </a:extLst>
           </p:cNvPr>
@@ -14375,7 +14375,7 @@
           <p:cNvPr id="20" name="">
             <a:extLst xmlns:a="http://schemas.openxmlformats.org/drawingml/2006/main">
               <a:ext uri="{FF2B5EF4-FFF2-40B4-BE49-F238E27FC236}">
-                <a16:creationId xmlns:a16="http://schemas.microsoft.com/office/drawing/2014/main" id="{5947A81C-C7ED-471D-82B6-18BFC6766994}"/>
+                <a16:creationId xmlns:a16="http://schemas.microsoft.com/office/drawing/2014/main" id="{7D04D1E3-5352-4F41-9CF9-76F8F4B4B52F}"/>
               </a:ext>
             </a:extLst>
           </p:cNvPr>
@@ -14425,7 +14425,7 @@
           <p:cNvPr id="21" name="">
             <a:extLst xmlns:a="http://schemas.openxmlformats.org/drawingml/2006/main">
               <a:ext uri="{FF2B5EF4-FFF2-40B4-BE49-F238E27FC236}">
-                <a16:creationId xmlns:a16="http://schemas.microsoft.com/office/drawing/2014/main" id="{BC756F26-AD45-4089-AF3F-ADEDA6932F49}"/>
+                <a16:creationId xmlns:a16="http://schemas.microsoft.com/office/drawing/2014/main" id="{B40319B0-A6E2-47E5-8A0F-28DE4BEB55C3}"/>
               </a:ext>
             </a:extLst>
           </p:cNvPr>
@@ -14475,7 +14475,7 @@
           <p:cNvPr id="22" name="">
             <a:extLst xmlns:a="http://schemas.openxmlformats.org/drawingml/2006/main">
               <a:ext uri="{FF2B5EF4-FFF2-40B4-BE49-F238E27FC236}">
-                <a16:creationId xmlns:a16="http://schemas.microsoft.com/office/drawing/2014/main" id="{85B7A137-30A1-4162-9321-F62B0F9D8798}"/>
+                <a16:creationId xmlns:a16="http://schemas.microsoft.com/office/drawing/2014/main" id="{6465F848-49B2-40FB-BC40-4D6774B6160E}"/>
               </a:ext>
             </a:extLst>
           </p:cNvPr>
@@ -14508,7 +14508,7 @@
           <p:cNvPr id="23" name="">
             <a:extLst xmlns:a="http://schemas.openxmlformats.org/drawingml/2006/main">
               <a:ext uri="{FF2B5EF4-FFF2-40B4-BE49-F238E27FC236}">
-                <a16:creationId xmlns:a16="http://schemas.microsoft.com/office/drawing/2014/main" id="{28A37793-3098-4250-A2EF-0FB9194652E9}"/>
+                <a16:creationId xmlns:a16="http://schemas.microsoft.com/office/drawing/2014/main" id="{CD7B43EF-F9F5-476E-95C2-2CEF588FEED5}"/>
               </a:ext>
             </a:extLst>
           </p:cNvPr>
@@ -14558,7 +14558,7 @@
           <p:cNvPr id="24" name="">
             <a:extLst xmlns:a="http://schemas.openxmlformats.org/drawingml/2006/main">
               <a:ext uri="{FF2B5EF4-FFF2-40B4-BE49-F238E27FC236}">
-                <a16:creationId xmlns:a16="http://schemas.microsoft.com/office/drawing/2014/main" id="{8FAE50F8-8AA8-429C-B102-D9ECFBC1D1C7}"/>
+                <a16:creationId xmlns:a16="http://schemas.microsoft.com/office/drawing/2014/main" id="{5766D61C-343C-4DD1-B1DA-2A443E63B609}"/>
               </a:ext>
             </a:extLst>
           </p:cNvPr>
@@ -14608,7 +14608,7 @@
           <p:cNvPr id="25" name="">
             <a:extLst xmlns:a="http://schemas.openxmlformats.org/drawingml/2006/main">
               <a:ext uri="{FF2B5EF4-FFF2-40B4-BE49-F238E27FC236}">
-                <a16:creationId xmlns:a16="http://schemas.microsoft.com/office/drawing/2014/main" id="{C30310DE-D369-4BB2-9333-D5D6A0AFD30F}"/>
+                <a16:creationId xmlns:a16="http://schemas.microsoft.com/office/drawing/2014/main" id="{F44F4DF7-08EB-4C95-A3A0-B5365F481C76}"/>
               </a:ext>
             </a:extLst>
           </p:cNvPr>
@@ -14641,7 +14641,7 @@
           <p:cNvPr id="26" name="">
             <a:extLst xmlns:a="http://schemas.openxmlformats.org/drawingml/2006/main">
               <a:ext uri="{FF2B5EF4-FFF2-40B4-BE49-F238E27FC236}">
-                <a16:creationId xmlns:a16="http://schemas.microsoft.com/office/drawing/2014/main" id="{0A871580-FC22-4875-A635-3EAA490496E1}"/>
+                <a16:creationId xmlns:a16="http://schemas.microsoft.com/office/drawing/2014/main" id="{95638B6D-8289-481F-A613-FCC28E6E9823}"/>
               </a:ext>
             </a:extLst>
           </p:cNvPr>
@@ -14691,7 +14691,7 @@
           <p:cNvPr id="27" name="">
             <a:extLst xmlns:a="http://schemas.openxmlformats.org/drawingml/2006/main">
               <a:ext uri="{FF2B5EF4-FFF2-40B4-BE49-F238E27FC236}">
-                <a16:creationId xmlns:a16="http://schemas.microsoft.com/office/drawing/2014/main" id="{D1A0866D-46B0-45E5-8832-780EBE2E17F2}"/>
+                <a16:creationId xmlns:a16="http://schemas.microsoft.com/office/drawing/2014/main" id="{C2ABD5D6-4208-4AD4-BD70-720AFCFD4B03}"/>
               </a:ext>
             </a:extLst>
           </p:cNvPr>
@@ -14741,7 +14741,7 @@
           <p:cNvPr id="28" name="">
             <a:extLst xmlns:a="http://schemas.openxmlformats.org/drawingml/2006/main">
               <a:ext uri="{FF2B5EF4-FFF2-40B4-BE49-F238E27FC236}">
-                <a16:creationId xmlns:a16="http://schemas.microsoft.com/office/drawing/2014/main" id="{F56E7C0D-A3C1-494C-AA31-97AF3A96441D}"/>
+                <a16:creationId xmlns:a16="http://schemas.microsoft.com/office/drawing/2014/main" id="{022F6BF8-9086-4893-BF67-AB210B477AA2}"/>
               </a:ext>
             </a:extLst>
           </p:cNvPr>
@@ -14774,7 +14774,7 @@
           <p:cNvPr id="29" name="">
             <a:extLst xmlns:a="http://schemas.openxmlformats.org/drawingml/2006/main">
               <a:ext uri="{FF2B5EF4-FFF2-40B4-BE49-F238E27FC236}">
-                <a16:creationId xmlns:a16="http://schemas.microsoft.com/office/drawing/2014/main" id="{DC4A0DDA-FDD9-4C22-9689-1320605B46BC}"/>
+                <a16:creationId xmlns:a16="http://schemas.microsoft.com/office/drawing/2014/main" id="{1429CE44-834E-4597-8372-6AA54D12BB79}"/>
               </a:ext>
             </a:extLst>
           </p:cNvPr>
@@ -14824,7 +14824,7 @@
           <p:cNvPr id="30" name="">
             <a:extLst xmlns:a="http://schemas.openxmlformats.org/drawingml/2006/main">
               <a:ext uri="{FF2B5EF4-FFF2-40B4-BE49-F238E27FC236}">
-                <a16:creationId xmlns:a16="http://schemas.microsoft.com/office/drawing/2014/main" id="{87EE9390-B494-450F-B11B-4E64F990E523}"/>
+                <a16:creationId xmlns:a16="http://schemas.microsoft.com/office/drawing/2014/main" id="{1A22B14E-1962-42CE-9DAD-0E1A258CC9CF}"/>
               </a:ext>
             </a:extLst>
           </p:cNvPr>
@@ -14857,7 +14857,7 @@
           <p:cNvPr id="31" name="">
             <a:extLst xmlns:a="http://schemas.openxmlformats.org/drawingml/2006/main">
               <a:ext uri="{FF2B5EF4-FFF2-40B4-BE49-F238E27FC236}">
-                <a16:creationId xmlns:a16="http://schemas.microsoft.com/office/drawing/2014/main" id="{196E3A53-40E1-4C9E-AB8B-28B33B9FF9A0}"/>
+                <a16:creationId xmlns:a16="http://schemas.microsoft.com/office/drawing/2014/main" id="{5624D08A-4D59-4AE3-A299-95BA80AABF7B}"/>
               </a:ext>
             </a:extLst>
           </p:cNvPr>
@@ -14907,7 +14907,7 @@
           <p:cNvPr id="32" name="">
             <a:extLst xmlns:a="http://schemas.openxmlformats.org/drawingml/2006/main">
               <a:ext uri="{FF2B5EF4-FFF2-40B4-BE49-F238E27FC236}">
-                <a16:creationId xmlns:a16="http://schemas.microsoft.com/office/drawing/2014/main" id="{12ADAEB2-0621-4CB8-A6DB-F3F8823CB4E2}"/>
+                <a16:creationId xmlns:a16="http://schemas.microsoft.com/office/drawing/2014/main" id="{FEB7AA8C-DE71-4A81-BF97-CCB54FF55C22}"/>
               </a:ext>
             </a:extLst>
           </p:cNvPr>
@@ -14955,7 +14955,7 @@
     </p:spTree>
     <p:extLst>
       <p:ext uri="{BB962C8B-B14F-4D97-AF65-F5344CB8AC3E}">
-        <p14:creationId xmlns:p14="http://schemas.microsoft.com/office/powerpoint/2010/main" val="1779834863"/>
+        <p14:creationId xmlns:p14="http://schemas.microsoft.com/office/powerpoint/2010/main" val="2125305089"/>
       </p:ext>
     </p:extLst>
   </p:cSld>
@@ -14986,7 +14986,7 @@
           <p:cNvPr id="1" name="">
             <a:extLst xmlns:a="http://schemas.openxmlformats.org/drawingml/2006/main">
               <a:ext uri="{FF2B5EF4-FFF2-40B4-BE49-F238E27FC236}">
-                <a16:creationId xmlns:a16="http://schemas.microsoft.com/office/drawing/2014/main" id="{BA39D9BA-88D6-4BA9-A4A6-C6C00CAD3994}"/>
+                <a16:creationId xmlns:a16="http://schemas.microsoft.com/office/drawing/2014/main" id="{FE751B6A-8D6B-4B49-A2B2-20CB681D6A2E}"/>
               </a:ext>
             </a:extLst>
           </p:cNvPr>
@@ -15017,7 +15017,7 @@
           <p:cNvPr id="2" name="">
             <a:extLst xmlns:a="http://schemas.openxmlformats.org/drawingml/2006/main">
               <a:ext uri="{FF2B5EF4-FFF2-40B4-BE49-F238E27FC236}">
-                <a16:creationId xmlns:a16="http://schemas.microsoft.com/office/drawing/2014/main" id="{BE29705A-29C6-40C4-9514-8749D1CA68C5}"/>
+                <a16:creationId xmlns:a16="http://schemas.microsoft.com/office/drawing/2014/main" id="{627C32FC-443B-4B1D-97F2-8F82E3FC8E9B}"/>
               </a:ext>
             </a:extLst>
           </p:cNvPr>
@@ -15067,7 +15067,7 @@
           <p:cNvPr id="3" name="">
             <a:extLst xmlns:a="http://schemas.openxmlformats.org/drawingml/2006/main">
               <a:ext uri="{FF2B5EF4-FFF2-40B4-BE49-F238E27FC236}">
-                <a16:creationId xmlns:a16="http://schemas.microsoft.com/office/drawing/2014/main" id="{626A99FC-44F1-427C-8053-C763A7348A13}"/>
+                <a16:creationId xmlns:a16="http://schemas.microsoft.com/office/drawing/2014/main" id="{8AADEF2D-BCDB-48A8-9441-12FBA79A4371}"/>
               </a:ext>
             </a:extLst>
           </p:cNvPr>
@@ -15117,7 +15117,7 @@
           <p:cNvPr id="4" name="">
             <a:extLst xmlns:a="http://schemas.openxmlformats.org/drawingml/2006/main">
               <a:ext uri="{FF2B5EF4-FFF2-40B4-BE49-F238E27FC236}">
-                <a16:creationId xmlns:a16="http://schemas.microsoft.com/office/drawing/2014/main" id="{76EE399D-F38E-4106-B6CB-27D9CFD00B74}"/>
+                <a16:creationId xmlns:a16="http://schemas.microsoft.com/office/drawing/2014/main" id="{FDB7FC73-C3FE-4CD1-B0A7-136A1963ADB3}"/>
               </a:ext>
             </a:extLst>
           </p:cNvPr>
@@ -15148,7 +15148,7 @@
           <p:cNvPr id="5" name="">
             <a:extLst xmlns:a="http://schemas.openxmlformats.org/drawingml/2006/main">
               <a:ext uri="{FF2B5EF4-FFF2-40B4-BE49-F238E27FC236}">
-                <a16:creationId xmlns:a16="http://schemas.microsoft.com/office/drawing/2014/main" id="{E59D83CA-1982-412D-9A8A-E82AA5F5BB4D}"/>
+                <a16:creationId xmlns:a16="http://schemas.microsoft.com/office/drawing/2014/main" id="{DE40E4FD-3DE8-4454-B7E8-EA3A46819A9A}"/>
               </a:ext>
             </a:extLst>
           </p:cNvPr>
@@ -15198,7 +15198,7 @@
           <p:cNvPr id="6" name="">
             <a:extLst xmlns:a="http://schemas.openxmlformats.org/drawingml/2006/main">
               <a:ext uri="{FF2B5EF4-FFF2-40B4-BE49-F238E27FC236}">
-                <a16:creationId xmlns:a16="http://schemas.microsoft.com/office/drawing/2014/main" id="{FEF6708C-FBEF-4F7F-A411-810D7B61FE46}"/>
+                <a16:creationId xmlns:a16="http://schemas.microsoft.com/office/drawing/2014/main" id="{0482EBA2-E0CE-4742-9BEF-F7A61CF4EAAE}"/>
               </a:ext>
             </a:extLst>
           </p:cNvPr>
@@ -15248,7 +15248,7 @@
           <p:cNvPr id="7" name="">
             <a:extLst xmlns:a="http://schemas.openxmlformats.org/drawingml/2006/main">
               <a:ext uri="{FF2B5EF4-FFF2-40B4-BE49-F238E27FC236}">
-                <a16:creationId xmlns:a16="http://schemas.microsoft.com/office/drawing/2014/main" id="{DBA6BE5A-6B52-4522-AFAC-04798593F2E9}"/>
+                <a16:creationId xmlns:a16="http://schemas.microsoft.com/office/drawing/2014/main" id="{3A441741-AD36-4496-94C4-3DE14B190387}"/>
               </a:ext>
             </a:extLst>
           </p:cNvPr>
@@ -15298,7 +15298,7 @@
           <p:cNvPr id="8" name="">
             <a:extLst xmlns:a="http://schemas.openxmlformats.org/drawingml/2006/main">
               <a:ext uri="{FF2B5EF4-FFF2-40B4-BE49-F238E27FC236}">
-                <a16:creationId xmlns:a16="http://schemas.microsoft.com/office/drawing/2014/main" id="{7DFF9A49-0C41-499C-9837-A84468E1EC58}"/>
+                <a16:creationId xmlns:a16="http://schemas.microsoft.com/office/drawing/2014/main" id="{DEEEF404-4A2B-43A1-A8F9-CCC1CD7ED135}"/>
               </a:ext>
             </a:extLst>
           </p:cNvPr>
@@ -15348,7 +15348,7 @@
           <p:cNvPr id="9" name="">
             <a:extLst xmlns:a="http://schemas.openxmlformats.org/drawingml/2006/main">
               <a:ext uri="{FF2B5EF4-FFF2-40B4-BE49-F238E27FC236}">
-                <a16:creationId xmlns:a16="http://schemas.microsoft.com/office/drawing/2014/main" id="{E1B9EF52-AE09-4E87-A496-1AE5C1FD3260}"/>
+                <a16:creationId xmlns:a16="http://schemas.microsoft.com/office/drawing/2014/main" id="{796C4209-8C11-47D2-A48C-57C9CD48D340}"/>
               </a:ext>
             </a:extLst>
           </p:cNvPr>
@@ -15379,7 +15379,7 @@
           <p:cNvPr id="10" name="">
             <a:extLst xmlns:a="http://schemas.openxmlformats.org/drawingml/2006/main">
               <a:ext uri="{FF2B5EF4-FFF2-40B4-BE49-F238E27FC236}">
-                <a16:creationId xmlns:a16="http://schemas.microsoft.com/office/drawing/2014/main" id="{FE7031C0-3DD0-412A-8AB3-329C9F384080}"/>
+                <a16:creationId xmlns:a16="http://schemas.microsoft.com/office/drawing/2014/main" id="{9A9AA0BD-CFF9-4DAD-B21B-0B57343DE161}"/>
               </a:ext>
             </a:extLst>
           </p:cNvPr>
@@ -15412,7 +15412,7 @@
           <p:cNvPr id="11" name="">
             <a:extLst xmlns:a="http://schemas.openxmlformats.org/drawingml/2006/main">
               <a:ext uri="{FF2B5EF4-FFF2-40B4-BE49-F238E27FC236}">
-                <a16:creationId xmlns:a16="http://schemas.microsoft.com/office/drawing/2014/main" id="{2AB95449-2AAE-4804-96DA-2C1BE55F4020}"/>
+                <a16:creationId xmlns:a16="http://schemas.microsoft.com/office/drawing/2014/main" id="{34F2A3D3-AF42-4C24-AE60-FFCEBC95ED46}"/>
               </a:ext>
             </a:extLst>
           </p:cNvPr>
@@ -15462,7 +15462,7 @@
           <p:cNvPr id="12" name="">
             <a:extLst xmlns:a="http://schemas.openxmlformats.org/drawingml/2006/main">
               <a:ext uri="{FF2B5EF4-FFF2-40B4-BE49-F238E27FC236}">
-                <a16:creationId xmlns:a16="http://schemas.microsoft.com/office/drawing/2014/main" id="{82C6D43E-FD13-44C0-8F34-ED1CCB3420B5}"/>
+                <a16:creationId xmlns:a16="http://schemas.microsoft.com/office/drawing/2014/main" id="{CF00416C-4E05-4160-8E9D-F9AFA2C85B04}"/>
               </a:ext>
             </a:extLst>
           </p:cNvPr>
@@ -15597,7 +15597,7 @@
           <p:cNvPr id="13" name="">
             <a:extLst xmlns:a="http://schemas.openxmlformats.org/drawingml/2006/main">
               <a:ext uri="{FF2B5EF4-FFF2-40B4-BE49-F238E27FC236}">
-                <a16:creationId xmlns:a16="http://schemas.microsoft.com/office/drawing/2014/main" id="{214F5E0D-2C82-4E43-98A6-5A4EB26CB04C}"/>
+                <a16:creationId xmlns:a16="http://schemas.microsoft.com/office/drawing/2014/main" id="{FA70C2E9-EA6D-4F79-9B12-72620AAAB718}"/>
               </a:ext>
             </a:extLst>
           </p:cNvPr>
@@ -15630,7 +15630,7 @@
           <p:cNvPr id="14" name="">
             <a:extLst xmlns:a="http://schemas.openxmlformats.org/drawingml/2006/main">
               <a:ext uri="{FF2B5EF4-FFF2-40B4-BE49-F238E27FC236}">
-                <a16:creationId xmlns:a16="http://schemas.microsoft.com/office/drawing/2014/main" id="{6F937842-AE75-4CCE-BAC2-CA9F66E9D7E0}"/>
+                <a16:creationId xmlns:a16="http://schemas.microsoft.com/office/drawing/2014/main" id="{5447BE16-93E1-44DE-B825-B11937F7E77E}"/>
               </a:ext>
             </a:extLst>
           </p:cNvPr>
@@ -15680,7 +15680,7 @@
           <p:cNvPr id="15" name="">
             <a:extLst xmlns:a="http://schemas.openxmlformats.org/drawingml/2006/main">
               <a:ext uri="{FF2B5EF4-FFF2-40B4-BE49-F238E27FC236}">
-                <a16:creationId xmlns:a16="http://schemas.microsoft.com/office/drawing/2014/main" id="{40D89F1A-E96B-450A-94BB-6E66D96AB162}"/>
+                <a16:creationId xmlns:a16="http://schemas.microsoft.com/office/drawing/2014/main" id="{69E18796-F3CD-498A-AD58-108DD3202C06}"/>
               </a:ext>
             </a:extLst>
           </p:cNvPr>
@@ -15798,7 +15798,7 @@
           <p:cNvPr id="16" name="">
             <a:extLst xmlns:a="http://schemas.openxmlformats.org/drawingml/2006/main">
               <a:ext uri="{FF2B5EF4-FFF2-40B4-BE49-F238E27FC236}">
-                <a16:creationId xmlns:a16="http://schemas.microsoft.com/office/drawing/2014/main" id="{F7D0CDB9-A9E9-49C0-BCD8-6432F0B2C43A}"/>
+                <a16:creationId xmlns:a16="http://schemas.microsoft.com/office/drawing/2014/main" id="{24EAEE79-B949-404E-958F-CDA49C23017B}"/>
               </a:ext>
             </a:extLst>
           </p:cNvPr>
@@ -15831,7 +15831,7 @@
           <p:cNvPr id="17" name="">
             <a:extLst xmlns:a="http://schemas.openxmlformats.org/drawingml/2006/main">
               <a:ext uri="{FF2B5EF4-FFF2-40B4-BE49-F238E27FC236}">
-                <a16:creationId xmlns:a16="http://schemas.microsoft.com/office/drawing/2014/main" id="{48435D0A-DBE7-4E49-A708-013C727232BE}"/>
+                <a16:creationId xmlns:a16="http://schemas.microsoft.com/office/drawing/2014/main" id="{8DD10362-B47D-4881-9FC6-1607FD25AE37}"/>
               </a:ext>
             </a:extLst>
           </p:cNvPr>
@@ -15881,7 +15881,7 @@
           <p:cNvPr id="18" name="">
             <a:extLst xmlns:a="http://schemas.openxmlformats.org/drawingml/2006/main">
               <a:ext uri="{FF2B5EF4-FFF2-40B4-BE49-F238E27FC236}">
-                <a16:creationId xmlns:a16="http://schemas.microsoft.com/office/drawing/2014/main" id="{24F40CB4-C6E5-4756-A9FC-5DDA5D98B5DC}"/>
+                <a16:creationId xmlns:a16="http://schemas.microsoft.com/office/drawing/2014/main" id="{CB892BDC-CA6D-4836-91D5-92573F33EC57}"/>
               </a:ext>
             </a:extLst>
           </p:cNvPr>
@@ -15951,7 +15951,7 @@
     </p:spTree>
     <p:extLst>
       <p:ext uri="{BB962C8B-B14F-4D97-AF65-F5344CB8AC3E}">
-        <p14:creationId xmlns:p14="http://schemas.microsoft.com/office/powerpoint/2010/main" val="443234786"/>
+        <p14:creationId xmlns:p14="http://schemas.microsoft.com/office/powerpoint/2010/main" val="1240693815"/>
       </p:ext>
     </p:extLst>
   </p:cSld>
@@ -15982,7 +15982,7 @@
           <p:cNvPr id="1" name="">
             <a:extLst xmlns:a="http://schemas.openxmlformats.org/drawingml/2006/main">
               <a:ext uri="{FF2B5EF4-FFF2-40B4-BE49-F238E27FC236}">
-                <a16:creationId xmlns:a16="http://schemas.microsoft.com/office/drawing/2014/main" id="{D2D95776-F9D9-4F88-B8A9-6BD5B048A940}"/>
+                <a16:creationId xmlns:a16="http://schemas.microsoft.com/office/drawing/2014/main" id="{E972D559-FBC4-40D1-811D-9066C7553DA7}"/>
               </a:ext>
             </a:extLst>
           </p:cNvPr>
@@ -16013,7 +16013,7 @@
           <p:cNvPr id="2" name="">
             <a:extLst xmlns:a="http://schemas.openxmlformats.org/drawingml/2006/main">
               <a:ext uri="{FF2B5EF4-FFF2-40B4-BE49-F238E27FC236}">
-                <a16:creationId xmlns:a16="http://schemas.microsoft.com/office/drawing/2014/main" id="{6B29BE5D-ADBE-482E-B621-F9689B4497C6}"/>
+                <a16:creationId xmlns:a16="http://schemas.microsoft.com/office/drawing/2014/main" id="{1F877F73-3D43-4685-ABAD-44E735F4658A}"/>
               </a:ext>
             </a:extLst>
           </p:cNvPr>
@@ -16063,7 +16063,7 @@
           <p:cNvPr id="3" name="">
             <a:extLst xmlns:a="http://schemas.openxmlformats.org/drawingml/2006/main">
               <a:ext uri="{FF2B5EF4-FFF2-40B4-BE49-F238E27FC236}">
-                <a16:creationId xmlns:a16="http://schemas.microsoft.com/office/drawing/2014/main" id="{07E2D229-FD06-4A66-90BF-6BB067DD318D}"/>
+                <a16:creationId xmlns:a16="http://schemas.microsoft.com/office/drawing/2014/main" id="{63D8EB26-053A-4633-9B7C-651012060BA5}"/>
               </a:ext>
             </a:extLst>
           </p:cNvPr>
@@ -16113,7 +16113,7 @@
           <p:cNvPr id="4" name="">
             <a:extLst xmlns:a="http://schemas.openxmlformats.org/drawingml/2006/main">
               <a:ext uri="{FF2B5EF4-FFF2-40B4-BE49-F238E27FC236}">
-                <a16:creationId xmlns:a16="http://schemas.microsoft.com/office/drawing/2014/main" id="{89087606-1D95-49C3-A106-FC1835F434D9}"/>
+                <a16:creationId xmlns:a16="http://schemas.microsoft.com/office/drawing/2014/main" id="{82721049-8CFC-4DB2-8644-6C1D94F54ED7}"/>
               </a:ext>
             </a:extLst>
           </p:cNvPr>
@@ -16144,7 +16144,7 @@
           <p:cNvPr id="5" name="">
             <a:extLst xmlns:a="http://schemas.openxmlformats.org/drawingml/2006/main">
               <a:ext uri="{FF2B5EF4-FFF2-40B4-BE49-F238E27FC236}">
-                <a16:creationId xmlns:a16="http://schemas.microsoft.com/office/drawing/2014/main" id="{34BF0AF5-7DD2-4839-B8EF-679AFB1C2609}"/>
+                <a16:creationId xmlns:a16="http://schemas.microsoft.com/office/drawing/2014/main" id="{3EF8B096-40DC-44CF-92D8-9B6FC499B7D7}"/>
               </a:ext>
             </a:extLst>
           </p:cNvPr>
@@ -16194,7 +16194,7 @@
           <p:cNvPr id="6" name="">
             <a:extLst xmlns:a="http://schemas.openxmlformats.org/drawingml/2006/main">
               <a:ext uri="{FF2B5EF4-FFF2-40B4-BE49-F238E27FC236}">
-                <a16:creationId xmlns:a16="http://schemas.microsoft.com/office/drawing/2014/main" id="{7ED46940-7CAB-47A1-8656-62276D7BAF39}"/>
+                <a16:creationId xmlns:a16="http://schemas.microsoft.com/office/drawing/2014/main" id="{9DB4C4CA-CFB6-48F9-8557-441D316743BF}"/>
               </a:ext>
             </a:extLst>
           </p:cNvPr>
@@ -16244,7 +16244,7 @@
           <p:cNvPr id="7" name="">
             <a:extLst xmlns:a="http://schemas.openxmlformats.org/drawingml/2006/main">
               <a:ext uri="{FF2B5EF4-FFF2-40B4-BE49-F238E27FC236}">
-                <a16:creationId xmlns:a16="http://schemas.microsoft.com/office/drawing/2014/main" id="{A9C8B45B-9202-4F36-8ED8-B1C5F748A49D}"/>
+                <a16:creationId xmlns:a16="http://schemas.microsoft.com/office/drawing/2014/main" id="{0E752C53-55AB-4E1E-B859-6E746E30E20B}"/>
               </a:ext>
             </a:extLst>
           </p:cNvPr>
@@ -16294,7 +16294,7 @@
           <p:cNvPr id="8" name="">
             <a:extLst xmlns:a="http://schemas.openxmlformats.org/drawingml/2006/main">
               <a:ext uri="{FF2B5EF4-FFF2-40B4-BE49-F238E27FC236}">
-                <a16:creationId xmlns:a16="http://schemas.microsoft.com/office/drawing/2014/main" id="{4AFE86AB-6A37-484A-90B3-34CA3AFB02DE}"/>
+                <a16:creationId xmlns:a16="http://schemas.microsoft.com/office/drawing/2014/main" id="{491D8AF3-2ED3-4762-8800-8CA41FD19468}"/>
               </a:ext>
             </a:extLst>
           </p:cNvPr>
@@ -16344,7 +16344,7 @@
           <p:cNvPr id="9" name="">
             <a:extLst xmlns:a="http://schemas.openxmlformats.org/drawingml/2006/main">
               <a:ext uri="{FF2B5EF4-FFF2-40B4-BE49-F238E27FC236}">
-                <a16:creationId xmlns:a16="http://schemas.microsoft.com/office/drawing/2014/main" id="{9BB4CA32-7929-47EF-9F13-AC77FE96BF73}"/>
+                <a16:creationId xmlns:a16="http://schemas.microsoft.com/office/drawing/2014/main" id="{D2DCE5E7-06CC-449C-896C-411EAC8661B0}"/>
               </a:ext>
             </a:extLst>
           </p:cNvPr>
@@ -16375,7 +16375,7 @@
           <p:cNvPr id="10" name="">
             <a:extLst xmlns:a="http://schemas.openxmlformats.org/drawingml/2006/main">
               <a:ext uri="{FF2B5EF4-FFF2-40B4-BE49-F238E27FC236}">
-                <a16:creationId xmlns:a16="http://schemas.microsoft.com/office/drawing/2014/main" id="{ED9BB479-2CF5-465F-B9AF-1DDD9605F64E}"/>
+                <a16:creationId xmlns:a16="http://schemas.microsoft.com/office/drawing/2014/main" id="{F6F39F4D-4BC6-434E-B16D-3304B8CC462E}"/>
               </a:ext>
             </a:extLst>
           </p:cNvPr>
@@ -16408,7 +16408,7 @@
           <p:cNvPr id="11" name="">
             <a:extLst xmlns:a="http://schemas.openxmlformats.org/drawingml/2006/main">
               <a:ext uri="{FF2B5EF4-FFF2-40B4-BE49-F238E27FC236}">
-                <a16:creationId xmlns:a16="http://schemas.microsoft.com/office/drawing/2014/main" id="{18E9D646-22D1-42FC-BB03-E85B0947FA3A}"/>
+                <a16:creationId xmlns:a16="http://schemas.microsoft.com/office/drawing/2014/main" id="{1B5B2FFC-473C-47E0-A165-5031B12BE82D}"/>
               </a:ext>
             </a:extLst>
           </p:cNvPr>
@@ -16439,7 +16439,7 @@
           <p:cNvPr id="12" name="">
             <a:extLst xmlns:a="http://schemas.openxmlformats.org/drawingml/2006/main">
               <a:ext uri="{FF2B5EF4-FFF2-40B4-BE49-F238E27FC236}">
-                <a16:creationId xmlns:a16="http://schemas.microsoft.com/office/drawing/2014/main" id="{265060D3-6914-4132-BA66-FF9DA0B7339F}"/>
+                <a16:creationId xmlns:a16="http://schemas.microsoft.com/office/drawing/2014/main" id="{B5F697A3-DDFA-4830-9E60-0BD652D0883A}"/>
               </a:ext>
             </a:extLst>
           </p:cNvPr>
@@ -16489,7 +16489,7 @@
           <p:cNvPr id="13" name="">
             <a:extLst xmlns:a="http://schemas.openxmlformats.org/drawingml/2006/main">
               <a:ext uri="{FF2B5EF4-FFF2-40B4-BE49-F238E27FC236}">
-                <a16:creationId xmlns:a16="http://schemas.microsoft.com/office/drawing/2014/main" id="{6231C809-0D46-46F2-BAD7-65547CF733B2}"/>
+                <a16:creationId xmlns:a16="http://schemas.microsoft.com/office/drawing/2014/main" id="{DEB56AD4-E587-440E-99A3-1A7DBA3EF0DF}"/>
               </a:ext>
             </a:extLst>
           </p:cNvPr>
@@ -16539,7 +16539,7 @@
           <p:cNvPr id="14" name="">
             <a:extLst xmlns:a="http://schemas.openxmlformats.org/drawingml/2006/main">
               <a:ext uri="{FF2B5EF4-FFF2-40B4-BE49-F238E27FC236}">
-                <a16:creationId xmlns:a16="http://schemas.microsoft.com/office/drawing/2014/main" id="{508D199E-B874-4503-A40E-3611D7739B09}"/>
+                <a16:creationId xmlns:a16="http://schemas.microsoft.com/office/drawing/2014/main" id="{52D46EBA-1ED4-4295-8D06-E1B08F866BC5}"/>
               </a:ext>
             </a:extLst>
           </p:cNvPr>
@@ -16623,7 +16623,7 @@
           <p:cNvPr id="15" name="">
             <a:extLst xmlns:a="http://schemas.openxmlformats.org/drawingml/2006/main">
               <a:ext uri="{FF2B5EF4-FFF2-40B4-BE49-F238E27FC236}">
-                <a16:creationId xmlns:a16="http://schemas.microsoft.com/office/drawing/2014/main" id="{803EC5E9-4BDE-4993-8D0B-534C70A1B253}"/>
+                <a16:creationId xmlns:a16="http://schemas.microsoft.com/office/drawing/2014/main" id="{10275E75-99A4-4EA7-815B-FC96F2A97E32}"/>
               </a:ext>
             </a:extLst>
           </p:cNvPr>
@@ -16673,7 +16673,7 @@
           <p:cNvPr id="16" name="">
             <a:extLst xmlns:a="http://schemas.openxmlformats.org/drawingml/2006/main">
               <a:ext uri="{FF2B5EF4-FFF2-40B4-BE49-F238E27FC236}">
-                <a16:creationId xmlns:a16="http://schemas.microsoft.com/office/drawing/2014/main" id="{4F47BDCA-E5CC-4AC4-BADD-C583A8EB0380}"/>
+                <a16:creationId xmlns:a16="http://schemas.microsoft.com/office/drawing/2014/main" id="{8245F06E-59E2-417E-ACCD-555067B12E61}"/>
               </a:ext>
             </a:extLst>
           </p:cNvPr>
@@ -16706,7 +16706,7 @@
           <p:cNvPr id="17" name="">
             <a:extLst xmlns:a="http://schemas.openxmlformats.org/drawingml/2006/main">
               <a:ext uri="{FF2B5EF4-FFF2-40B4-BE49-F238E27FC236}">
-                <a16:creationId xmlns:a16="http://schemas.microsoft.com/office/drawing/2014/main" id="{9AAF9AEF-2BF1-4D0C-82C1-23D8E6BE46B5}"/>
+                <a16:creationId xmlns:a16="http://schemas.microsoft.com/office/drawing/2014/main" id="{B69BF201-EA7B-46DA-9328-8B7A7C9B5156}"/>
               </a:ext>
             </a:extLst>
           </p:cNvPr>
@@ -16737,7 +16737,7 @@
           <p:cNvPr id="18" name="">
             <a:extLst xmlns:a="http://schemas.openxmlformats.org/drawingml/2006/main">
               <a:ext uri="{FF2B5EF4-FFF2-40B4-BE49-F238E27FC236}">
-                <a16:creationId xmlns:a16="http://schemas.microsoft.com/office/drawing/2014/main" id="{043BB454-17EE-4029-A17F-5045D29B928D}"/>
+                <a16:creationId xmlns:a16="http://schemas.microsoft.com/office/drawing/2014/main" id="{24FAF14B-E1DB-4D51-8507-C11401154591}"/>
               </a:ext>
             </a:extLst>
           </p:cNvPr>
@@ -16787,7 +16787,7 @@
           <p:cNvPr id="19" name="">
             <a:extLst xmlns:a="http://schemas.openxmlformats.org/drawingml/2006/main">
               <a:ext uri="{FF2B5EF4-FFF2-40B4-BE49-F238E27FC236}">
-                <a16:creationId xmlns:a16="http://schemas.microsoft.com/office/drawing/2014/main" id="{2B305C52-6895-4A45-85E8-49D18EF41B1A}"/>
+                <a16:creationId xmlns:a16="http://schemas.microsoft.com/office/drawing/2014/main" id="{A5B25F38-B6A8-4EA4-B423-9668C49CA3BB}"/>
               </a:ext>
             </a:extLst>
           </p:cNvPr>
@@ -16837,7 +16837,7 @@
           <p:cNvPr id="20" name="">
             <a:extLst xmlns:a="http://schemas.openxmlformats.org/drawingml/2006/main">
               <a:ext uri="{FF2B5EF4-FFF2-40B4-BE49-F238E27FC236}">
-                <a16:creationId xmlns:a16="http://schemas.microsoft.com/office/drawing/2014/main" id="{EFE68B25-1A22-4BE9-B68C-94BE299879DA}"/>
+                <a16:creationId xmlns:a16="http://schemas.microsoft.com/office/drawing/2014/main" id="{A5AFA17E-DF06-4758-AE0B-53352FD7A06A}"/>
               </a:ext>
             </a:extLst>
           </p:cNvPr>
@@ -16921,7 +16921,7 @@
           <p:cNvPr id="21" name="">
             <a:extLst xmlns:a="http://schemas.openxmlformats.org/drawingml/2006/main">
               <a:ext uri="{FF2B5EF4-FFF2-40B4-BE49-F238E27FC236}">
-                <a16:creationId xmlns:a16="http://schemas.microsoft.com/office/drawing/2014/main" id="{87F3D441-F87B-4207-934E-EDFB2DF88F69}"/>
+                <a16:creationId xmlns:a16="http://schemas.microsoft.com/office/drawing/2014/main" id="{0CF46327-B091-47C5-B65F-E78C8296D116}"/>
               </a:ext>
             </a:extLst>
           </p:cNvPr>
@@ -16971,7 +16971,7 @@
           <p:cNvPr id="22" name="">
             <a:extLst xmlns:a="http://schemas.openxmlformats.org/drawingml/2006/main">
               <a:ext uri="{FF2B5EF4-FFF2-40B4-BE49-F238E27FC236}">
-                <a16:creationId xmlns:a16="http://schemas.microsoft.com/office/drawing/2014/main" id="{E09B245C-2FF3-4B54-BA0E-B08B63F1C62B}"/>
+                <a16:creationId xmlns:a16="http://schemas.microsoft.com/office/drawing/2014/main" id="{020025F1-95F4-4D27-B220-422DCC977EBC}"/>
               </a:ext>
             </a:extLst>
           </p:cNvPr>
@@ -17004,7 +17004,7 @@
           <p:cNvPr id="23" name="">
             <a:extLst xmlns:a="http://schemas.openxmlformats.org/drawingml/2006/main">
               <a:ext uri="{FF2B5EF4-FFF2-40B4-BE49-F238E27FC236}">
-                <a16:creationId xmlns:a16="http://schemas.microsoft.com/office/drawing/2014/main" id="{50C6C56F-DC54-4871-B1B8-3F8F6EC43A51}"/>
+                <a16:creationId xmlns:a16="http://schemas.microsoft.com/office/drawing/2014/main" id="{940A744D-0540-45AE-A429-3A90B26581CA}"/>
               </a:ext>
             </a:extLst>
           </p:cNvPr>
@@ -17035,7 +17035,7 @@
           <p:cNvPr id="24" name="">
             <a:extLst xmlns:a="http://schemas.openxmlformats.org/drawingml/2006/main">
               <a:ext uri="{FF2B5EF4-FFF2-40B4-BE49-F238E27FC236}">
-                <a16:creationId xmlns:a16="http://schemas.microsoft.com/office/drawing/2014/main" id="{B263D47E-F6C5-439E-8732-806A75B34605}"/>
+                <a16:creationId xmlns:a16="http://schemas.microsoft.com/office/drawing/2014/main" id="{5FEA6AAA-F650-4363-BBD6-E468F7DD39C0}"/>
               </a:ext>
             </a:extLst>
           </p:cNvPr>
@@ -17085,7 +17085,7 @@
           <p:cNvPr id="25" name="">
             <a:extLst xmlns:a="http://schemas.openxmlformats.org/drawingml/2006/main">
               <a:ext uri="{FF2B5EF4-FFF2-40B4-BE49-F238E27FC236}">
-                <a16:creationId xmlns:a16="http://schemas.microsoft.com/office/drawing/2014/main" id="{2B04BD81-9426-499E-BD1D-91E2A5222EC9}"/>
+                <a16:creationId xmlns:a16="http://schemas.microsoft.com/office/drawing/2014/main" id="{F2A54FD0-1E1B-46B8-8716-99AC26C769E9}"/>
               </a:ext>
             </a:extLst>
           </p:cNvPr>
@@ -17135,7 +17135,7 @@
           <p:cNvPr id="26" name="">
             <a:extLst xmlns:a="http://schemas.openxmlformats.org/drawingml/2006/main">
               <a:ext uri="{FF2B5EF4-FFF2-40B4-BE49-F238E27FC236}">
-                <a16:creationId xmlns:a16="http://schemas.microsoft.com/office/drawing/2014/main" id="{2396C626-AC5A-49E2-829B-B107B6E57B0C}"/>
+                <a16:creationId xmlns:a16="http://schemas.microsoft.com/office/drawing/2014/main" id="{FCC3C738-3CE2-4078-8D97-3655C43F9B83}"/>
               </a:ext>
             </a:extLst>
           </p:cNvPr>
@@ -17219,7 +17219,7 @@
           <p:cNvPr id="27" name="">
             <a:extLst xmlns:a="http://schemas.openxmlformats.org/drawingml/2006/main">
               <a:ext uri="{FF2B5EF4-FFF2-40B4-BE49-F238E27FC236}">
-                <a16:creationId xmlns:a16="http://schemas.microsoft.com/office/drawing/2014/main" id="{019BCF8C-F858-43D0-9B5E-FDD9A985E4E3}"/>
+                <a16:creationId xmlns:a16="http://schemas.microsoft.com/office/drawing/2014/main" id="{B2D037F3-CBF0-4204-AB81-C4E2BBB69969}"/>
               </a:ext>
             </a:extLst>
           </p:cNvPr>
@@ -17267,7 +17267,7 @@
     </p:spTree>
     <p:extLst>
       <p:ext uri="{BB962C8B-B14F-4D97-AF65-F5344CB8AC3E}">
-        <p14:creationId xmlns:p14="http://schemas.microsoft.com/office/powerpoint/2010/main" val="564759971"/>
+        <p14:creationId xmlns:p14="http://schemas.microsoft.com/office/powerpoint/2010/main" val="842450186"/>
       </p:ext>
     </p:extLst>
   </p:cSld>

</xml_diff>